<commit_message>
docs: YC pitch narrative, deck, deploy; drop external reference mentions
Reframe Friday around AI code velocity vs human review and security asymmetry.
Update README, hackathon submission, PITCH, architecture; rebuild pptx; Cloud Run deploy assets.

Co-authored-by: Cursor <cursoragent@cursor.com>
</commit_message>
<xml_diff>
--- a/docs/presentation/Friday-Voice-Agent.pptx
+++ b/docs/presentation/Friday-Voice-Agent.pptx
@@ -3093,6 +3093,14 @@
 <file path=ppt/slides/slide1.xml><?xml version="1.0" encoding="utf-8"?>
 <p:sld xmlns:a="http://schemas.openxmlformats.org/drawingml/2006/main" xmlns:p="http://schemas.openxmlformats.org/presentationml/2006/main" xmlns:r="http://schemas.openxmlformats.org/officeDocument/2006/relationships">
   <p:cSld>
+    <p:bg>
+      <p:bgPr>
+        <a:solidFill>
+          <a:srgbClr val="0A0A0A"/>
+        </a:solidFill>
+        <a:effectLst/>
+      </p:bgPr>
+    </p:bg>
     <p:spTree>
       <p:nvGrpSpPr>
         <p:cNvPr id="1" name=""/>
@@ -3108,8 +3116,8 @@
         </p:nvSpPr>
         <p:spPr>
           <a:xfrm>
-            <a:off x="548640" y="1828800"/>
-            <a:ext cx="10972800" cy="1371600"/>
+            <a:off x="685800" y="2103120"/>
+            <a:ext cx="10515600" cy="1280160"/>
           </a:xfrm>
           <a:prstGeom prst="rect">
             <a:avLst/>
@@ -3117,15 +3125,15 @@
           <a:noFill/>
         </p:spPr>
         <p:txBody>
-          <a:bodyPr wrap="none">
+          <a:bodyPr wrap="square">
             <a:spAutoFit/>
           </a:bodyPr>
           <a:lstStyle/>
           <a:p>
-            <a:pPr>
-              <a:defRPr sz="4000" b="1">
-                <a:solidFill>
-                  <a:srgbClr val="0F172A"/>
+            <a:pPr algn="l">
+              <a:defRPr sz="5200" b="1">
+                <a:solidFill>
+                  <a:srgbClr val="FAFAFA"/>
                 </a:solidFill>
               </a:defRPr>
             </a:pPr>
@@ -3143,8 +3151,8 @@
         </p:nvSpPr>
         <p:spPr>
           <a:xfrm>
-            <a:off x="548640" y="2926080"/>
-            <a:ext cx="10972800" cy="914400"/>
+            <a:off x="685800" y="3063240"/>
+            <a:ext cx="10515600" cy="1097280"/>
           </a:xfrm>
           <a:prstGeom prst="rect">
             <a:avLst/>
@@ -3158,14 +3166,14 @@
           <a:lstStyle/>
           <a:p>
             <a:pPr>
-              <a:defRPr sz="2200">
-                <a:solidFill>
-                  <a:srgbClr val="64748B"/>
+              <a:defRPr sz="2400">
+                <a:solidFill>
+                  <a:srgbClr val="A1A1AA"/>
                 </a:solidFill>
               </a:defRPr>
             </a:pPr>
             <a:r>
-              <a:t>Voice-first control for GitHub repositories</a:t>
+              <a:t>Stay in control when code—and threats—move faster than review.</a:t>
             </a:r>
           </a:p>
         </p:txBody>
@@ -3181,6 +3189,14 @@
 <file path=ppt/slides/slide10.xml><?xml version="1.0" encoding="utf-8"?>
 <p:sld xmlns:a="http://schemas.openxmlformats.org/drawingml/2006/main" xmlns:p="http://schemas.openxmlformats.org/presentationml/2006/main" xmlns:r="http://schemas.openxmlformats.org/officeDocument/2006/relationships">
   <p:cSld>
+    <p:bg>
+      <p:bgPr>
+        <a:solidFill>
+          <a:srgbClr val="0A0A0A"/>
+        </a:solidFill>
+        <a:effectLst/>
+      </p:bgPr>
+    </p:bg>
     <p:spTree>
       <p:nvGrpSpPr>
         <p:cNvPr id="1" name=""/>
@@ -3196,8 +3212,8 @@
         </p:nvSpPr>
         <p:spPr>
           <a:xfrm>
-            <a:off x="548640" y="365760"/>
-            <a:ext cx="10972800" cy="731520"/>
+            <a:off x="685800" y="502920"/>
+            <a:ext cx="10515600" cy="1280160"/>
           </a:xfrm>
           <a:prstGeom prst="rect">
             <a:avLst/>
@@ -3205,20 +3221,20 @@
           <a:noFill/>
         </p:spPr>
         <p:txBody>
-          <a:bodyPr wrap="none">
+          <a:bodyPr wrap="square">
             <a:spAutoFit/>
           </a:bodyPr>
           <a:lstStyle/>
           <a:p>
-            <a:pPr>
-              <a:defRPr sz="2800" b="1">
-                <a:solidFill>
-                  <a:srgbClr val="38BDF8"/>
+            <a:pPr algn="l">
+              <a:defRPr sz="3200" b="1">
+                <a:solidFill>
+                  <a:srgbClr val="F97316"/>
                 </a:solidFill>
               </a:defRPr>
             </a:pPr>
             <a:r>
-              <a:t>Testing</a:t>
+              <a:t>Stack</a:t>
             </a:r>
           </a:p>
         </p:txBody>
@@ -3231,8 +3247,8 @@
         </p:nvSpPr>
         <p:spPr>
           <a:xfrm>
-            <a:off x="731520" y="1188720"/>
-            <a:ext cx="10515600" cy="5029200"/>
+            <a:off x="777240" y="1325880"/>
+            <a:ext cx="10241280" cy="4754880"/>
           </a:xfrm>
           <a:prstGeom prst="rect">
             <a:avLst/>
@@ -3240,32 +3256,53 @@
           <a:noFill/>
         </p:spPr>
         <p:txBody>
-          <a:bodyPr wrap="none">
+          <a:bodyPr wrap="square">
             <a:spAutoFit/>
           </a:bodyPr>
           <a:lstStyle/>
           <a:p>
             <a:pPr>
-              <a:defRPr sz="1800"/>
+              <a:spcAft>
+                <a:spcPts val="1400"/>
+              </a:spcAft>
+              <a:defRPr sz="2000">
+                <a:solidFill>
+                  <a:srgbClr val="FAFAFA"/>
+                </a:solidFill>
+              </a:defRPr>
             </a:pPr>
             <a:r>
-              <a:t>python test_friday.py</a:t>
+              <a:t>FastAPI · AssemblyAI Voice + STT + LLM Gateway</a:t>
             </a:r>
           </a:p>
           <a:p>
             <a:pPr>
-              <a:defRPr sz="1800"/>
+              <a:spcAft>
+                <a:spcPts val="1400"/>
+              </a:spcAft>
+              <a:defRPr sz="2000">
+                <a:solidFill>
+                  <a:srgbClr val="FAFAFA"/>
+                </a:solidFill>
+              </a:defRPr>
             </a:pPr>
             <a:r>
-              <a:t>docs/TEST_QUESTIONS.md — 37 scenarios</a:t>
+              <a:t>GitHub REST / OAuth · D3 map ingest</a:t>
             </a:r>
           </a:p>
           <a:p>
             <a:pPr>
-              <a:defRPr sz="1800"/>
+              <a:spcAft>
+                <a:spcPts val="1400"/>
+              </a:spcAft>
+              <a:defRPr sz="2000">
+                <a:solidFill>
+                  <a:srgbClr val="FAFAFA"/>
+                </a:solidFill>
+              </a:defRPr>
             </a:pPr>
             <a:r>
-              <a:t>Voice and Ask parity tests</a:t>
+              <a:t>Deployed on Google Cloud Run</a:t>
             </a:r>
           </a:p>
         </p:txBody>
@@ -3281,6 +3318,14 @@
 <file path=ppt/slides/slide11.xml><?xml version="1.0" encoding="utf-8"?>
 <p:sld xmlns:a="http://schemas.openxmlformats.org/drawingml/2006/main" xmlns:p="http://schemas.openxmlformats.org/presentationml/2006/main" xmlns:r="http://schemas.openxmlformats.org/officeDocument/2006/relationships">
   <p:cSld>
+    <p:bg>
+      <p:bgPr>
+        <a:solidFill>
+          <a:srgbClr val="0A0A0A"/>
+        </a:solidFill>
+        <a:effectLst/>
+      </p:bgPr>
+    </p:bg>
     <p:spTree>
       <p:nvGrpSpPr>
         <p:cNvPr id="1" name=""/>
@@ -3296,8 +3341,8 @@
         </p:nvSpPr>
         <p:spPr>
           <a:xfrm>
-            <a:off x="548640" y="365760"/>
-            <a:ext cx="10972800" cy="731520"/>
+            <a:off x="685800" y="1828800"/>
+            <a:ext cx="10515600" cy="1280160"/>
           </a:xfrm>
           <a:prstGeom prst="rect">
             <a:avLst/>
@@ -3305,20 +3350,20 @@
           <a:noFill/>
         </p:spPr>
         <p:txBody>
-          <a:bodyPr wrap="none">
+          <a:bodyPr wrap="square">
             <a:spAutoFit/>
           </a:bodyPr>
           <a:lstStyle/>
           <a:p>
-            <a:pPr>
-              <a:defRPr sz="2800" b="1">
-                <a:solidFill>
-                  <a:srgbClr val="38BDF8"/>
+            <a:pPr algn="l">
+              <a:defRPr sz="4000" b="1">
+                <a:solidFill>
+                  <a:srgbClr val="F97316"/>
                 </a:solidFill>
               </a:defRPr>
             </a:pPr>
             <a:r>
-              <a:t>Config</a:t>
+              <a:t>Try it</a:t>
             </a:r>
           </a:p>
         </p:txBody>
@@ -3331,8 +3376,8 @@
         </p:nvSpPr>
         <p:spPr>
           <a:xfrm>
-            <a:off x="731520" y="1188720"/>
-            <a:ext cx="10515600" cy="5029200"/>
+            <a:off x="685800" y="2743200"/>
+            <a:ext cx="10515600" cy="1097280"/>
           </a:xfrm>
           <a:prstGeom prst="rect">
             <a:avLst/>
@@ -3346,26 +3391,23 @@
           <a:lstStyle/>
           <a:p>
             <a:pPr>
-              <a:defRPr sz="1800"/>
+              <a:defRPr sz="2000">
+                <a:solidFill>
+                  <a:srgbClr val="A1A1AA"/>
+                </a:solidFill>
+              </a:defRPr>
             </a:pPr>
             <a:r>
-              <a:t>ASSEMBLYAI_API_KEY, GitHub token/OAuth</a:t>
-            </a:r>
-          </a:p>
-          <a:p>
-            <a:pPr>
-              <a:defRPr sz="1800"/>
-            </a:pPr>
-            <a:r>
-              <a:t>FRIDAY_GITHUB_GATEWAY=multi|all|off</a:t>
-            </a:r>
-          </a:p>
-          <a:p>
-            <a:pPr>
-              <a:defRPr sz="1800"/>
-            </a:pPr>
-            <a:r>
-              <a:t>AGENT_LLM_PROVIDER=assemblyai|ifm</a:t>
+              <a:t>https://friday-voice-agent-147606977567.us-central1.run.app</a:t>
+            </a:r>
+            <a:br/>
+            <a:r>
+              <a:t>?repo=owner/name</a:t>
+            </a:r>
+            <a:br/>
+            <a:br/>
+            <a:r>
+              <a:t>Hold the mic · Explain the map · Check the latest commit</a:t>
             </a:r>
           </a:p>
         </p:txBody>
@@ -3381,6 +3423,14 @@
 <file path=ppt/slides/slide12.xml><?xml version="1.0" encoding="utf-8"?>
 <p:sld xmlns:a="http://schemas.openxmlformats.org/drawingml/2006/main" xmlns:p="http://schemas.openxmlformats.org/presentationml/2006/main" xmlns:r="http://schemas.openxmlformats.org/officeDocument/2006/relationships">
   <p:cSld>
+    <p:bg>
+      <p:bgPr>
+        <a:solidFill>
+          <a:srgbClr val="0A0A0A"/>
+        </a:solidFill>
+        <a:effectLst/>
+      </p:bgPr>
+    </p:bg>
     <p:spTree>
       <p:nvGrpSpPr>
         <p:cNvPr id="1" name=""/>
@@ -3396,8 +3446,8 @@
         </p:nvSpPr>
         <p:spPr>
           <a:xfrm>
-            <a:off x="548640" y="365760"/>
-            <a:ext cx="10972800" cy="731520"/>
+            <a:off x="685800" y="1737360"/>
+            <a:ext cx="10515600" cy="1280160"/>
           </a:xfrm>
           <a:prstGeom prst="rect">
             <a:avLst/>
@@ -3405,20 +3455,20 @@
           <a:noFill/>
         </p:spPr>
         <p:txBody>
-          <a:bodyPr wrap="none">
+          <a:bodyPr wrap="square">
             <a:spAutoFit/>
           </a:bodyPr>
           <a:lstStyle/>
           <a:p>
-            <a:pPr>
-              <a:defRPr sz="2800" b="1">
-                <a:solidFill>
-                  <a:srgbClr val="38BDF8"/>
+            <a:pPr algn="l">
+              <a:defRPr sz="3600" b="1">
+                <a:solidFill>
+                  <a:srgbClr val="FAFAFA"/>
                 </a:solidFill>
               </a:defRPr>
             </a:pPr>
             <a:r>
-              <a:t>Reliability tradeoffs</a:t>
+              <a:t>Why now</a:t>
             </a:r>
           </a:p>
         </p:txBody>
@@ -3431,8 +3481,8 @@
         </p:nvSpPr>
         <p:spPr>
           <a:xfrm>
-            <a:off x="731520" y="1188720"/>
-            <a:ext cx="10515600" cy="5029200"/>
+            <a:off x="685800" y="2743200"/>
+            <a:ext cx="10515600" cy="1097280"/>
           </a:xfrm>
           <a:prstGeom prst="rect">
             <a:avLst/>
@@ -3446,34 +3496,18 @@
           <a:lstStyle/>
           <a:p>
             <a:pPr>
-              <a:defRPr sz="1800"/>
+              <a:defRPr sz="2200">
+                <a:solidFill>
+                  <a:srgbClr val="A1A1AA"/>
+                </a:solidFill>
+              </a:defRPr>
             </a:pPr>
             <a:r>
-              <a:t>Hybrid recommended: Jev for map, Gateway for GitHub</a:t>
-            </a:r>
-          </a:p>
-          <a:p>
-            <a:pPr>
-              <a:defRPr sz="1800"/>
-            </a:pPr>
-            <a:r>
-              <a:t>FRIDAY_GITHUB_GATEWAY=all for tutorial-like behavior</a:t>
-            </a:r>
-          </a:p>
-          <a:p>
-            <a:pPr>
-              <a:defRPr sz="1800"/>
-            </a:pPr>
-            <a:r>
-              <a:t>Dropping Jev needs full agent loop for map tools</a:t>
-            </a:r>
-          </a:p>
-          <a:p>
-            <a:pPr>
-              <a:defRPr sz="1800"/>
-            </a:pPr>
-            <a:r>
-              <a:t>Reference: Hands-On-AI-Engineering voice-github-agent</a:t>
+              <a:t>The window where humans still approve what ships is narrowing.</a:t>
+            </a:r>
+            <a:br/>
+            <a:r>
+              <a:t>Friday is how you keep orientation and consent in that window.</a:t>
             </a:r>
           </a:p>
         </p:txBody>
@@ -3489,6 +3523,14 @@
 <file path=ppt/slides/slide13.xml><?xml version="1.0" encoding="utf-8"?>
 <p:sld xmlns:a="http://schemas.openxmlformats.org/drawingml/2006/main" xmlns:p="http://schemas.openxmlformats.org/presentationml/2006/main" xmlns:r="http://schemas.openxmlformats.org/officeDocument/2006/relationships">
   <p:cSld>
+    <p:bg>
+      <p:bgPr>
+        <a:solidFill>
+          <a:srgbClr val="0A0A0A"/>
+        </a:solidFill>
+        <a:effectLst/>
+      </p:bgPr>
+    </p:bg>
     <p:spTree>
       <p:nvGrpSpPr>
         <p:cNvPr id="1" name=""/>
@@ -3504,8 +3546,8 @@
         </p:nvSpPr>
         <p:spPr>
           <a:xfrm>
-            <a:off x="548640" y="1828800"/>
-            <a:ext cx="10972800" cy="1371600"/>
+            <a:off x="685800" y="2286000"/>
+            <a:ext cx="10515600" cy="1280160"/>
           </a:xfrm>
           <a:prstGeom prst="rect">
             <a:avLst/>
@@ -3513,20 +3555,20 @@
           <a:noFill/>
         </p:spPr>
         <p:txBody>
-          <a:bodyPr wrap="none">
+          <a:bodyPr wrap="square">
             <a:spAutoFit/>
           </a:bodyPr>
           <a:lstStyle/>
           <a:p>
-            <a:pPr>
-              <a:defRPr sz="4000" b="1">
-                <a:solidFill>
-                  <a:srgbClr val="0F172A"/>
+            <a:pPr algn="l">
+              <a:defRPr sz="4800" b="1">
+                <a:solidFill>
+                  <a:srgbClr val="FAFAFA"/>
                 </a:solidFill>
               </a:defRPr>
             </a:pPr>
             <a:r>
-              <a:t>Thank you</a:t>
+              <a:t>Friday</a:t>
             </a:r>
           </a:p>
         </p:txBody>
@@ -3539,8 +3581,8 @@
         </p:nvSpPr>
         <p:spPr>
           <a:xfrm>
-            <a:off x="548640" y="2926080"/>
-            <a:ext cx="10972800" cy="914400"/>
+            <a:off x="685800" y="3108960"/>
+            <a:ext cx="10515600" cy="1097280"/>
           </a:xfrm>
           <a:prstGeom prst="rect">
             <a:avLst/>
@@ -3556,7 +3598,7 @@
             <a:pPr>
               <a:defRPr sz="2200">
                 <a:solidFill>
-                  <a:srgbClr val="64748B"/>
+                  <a:srgbClr val="A1A1AA"/>
                 </a:solidFill>
               </a:defRPr>
             </a:pPr>
@@ -3577,6 +3619,14 @@
 <file path=ppt/slides/slide2.xml><?xml version="1.0" encoding="utf-8"?>
 <p:sld xmlns:a="http://schemas.openxmlformats.org/drawingml/2006/main" xmlns:p="http://schemas.openxmlformats.org/presentationml/2006/main" xmlns:r="http://schemas.openxmlformats.org/officeDocument/2006/relationships">
   <p:cSld>
+    <p:bg>
+      <p:bgPr>
+        <a:solidFill>
+          <a:srgbClr val="0A0A0A"/>
+        </a:solidFill>
+        <a:effectLst/>
+      </p:bgPr>
+    </p:bg>
     <p:spTree>
       <p:nvGrpSpPr>
         <p:cNvPr id="1" name=""/>
@@ -3592,8 +3642,8 @@
         </p:nvSpPr>
         <p:spPr>
           <a:xfrm>
-            <a:off x="548640" y="1828800"/>
-            <a:ext cx="10972800" cy="1371600"/>
+            <a:off x="685800" y="1828800"/>
+            <a:ext cx="10515600" cy="1280160"/>
           </a:xfrm>
           <a:prstGeom prst="rect">
             <a:avLst/>
@@ -3601,20 +3651,20 @@
           <a:noFill/>
         </p:spPr>
         <p:txBody>
-          <a:bodyPr wrap="none">
+          <a:bodyPr wrap="square">
             <a:spAutoFit/>
           </a:bodyPr>
           <a:lstStyle/>
           <a:p>
-            <a:pPr>
-              <a:defRPr sz="4000" b="1">
-                <a:solidFill>
-                  <a:srgbClr val="0F172A"/>
+            <a:pPr algn="l">
+              <a:defRPr sz="3800" b="1">
+                <a:solidFill>
+                  <a:srgbClr val="FAFAFA"/>
                 </a:solidFill>
               </a:defRPr>
             </a:pPr>
             <a:r>
-              <a:t>The problem</a:t>
+              <a:t>We are in an existential squeeze.</a:t>
             </a:r>
           </a:p>
         </p:txBody>
@@ -3627,8 +3677,8 @@
         </p:nvSpPr>
         <p:spPr>
           <a:xfrm>
-            <a:off x="548640" y="2926080"/>
-            <a:ext cx="10972800" cy="914400"/>
+            <a:off x="685800" y="2926080"/>
+            <a:ext cx="10515600" cy="1097280"/>
           </a:xfrm>
           <a:prstGeom prst="rect">
             <a:avLst/>
@@ -3644,12 +3694,20 @@
             <a:pPr>
               <a:defRPr sz="2200">
                 <a:solidFill>
-                  <a:srgbClr val="64748B"/>
+                  <a:srgbClr val="A1A1AA"/>
                 </a:solidFill>
               </a:defRPr>
             </a:pPr>
             <a:r>
-              <a:t>Repos are large; keyboards and tabs slow triage</a:t>
+              <a:t>AI generates code at machine speed.</a:t>
+            </a:r>
+            <a:br/>
+            <a:r>
+              <a:t>Humans are still asked to review all of it.</a:t>
+            </a:r>
+            <a:br/>
+            <a:r>
+              <a:t>That math does not work.</a:t>
             </a:r>
           </a:p>
         </p:txBody>
@@ -3665,6 +3723,14 @@
 <file path=ppt/slides/slide3.xml><?xml version="1.0" encoding="utf-8"?>
 <p:sld xmlns:a="http://schemas.openxmlformats.org/drawingml/2006/main" xmlns:p="http://schemas.openxmlformats.org/presentationml/2006/main" xmlns:r="http://schemas.openxmlformats.org/officeDocument/2006/relationships">
   <p:cSld>
+    <p:bg>
+      <p:bgPr>
+        <a:solidFill>
+          <a:srgbClr val="0A0A0A"/>
+        </a:solidFill>
+        <a:effectLst/>
+      </p:bgPr>
+    </p:bg>
     <p:spTree>
       <p:nvGrpSpPr>
         <p:cNvPr id="1" name=""/>
@@ -3680,8 +3746,8 @@
         </p:nvSpPr>
         <p:spPr>
           <a:xfrm>
-            <a:off x="548640" y="365760"/>
-            <a:ext cx="10972800" cy="731520"/>
+            <a:off x="685800" y="502920"/>
+            <a:ext cx="10515600" cy="1280160"/>
           </a:xfrm>
           <a:prstGeom prst="rect">
             <a:avLst/>
@@ -3689,20 +3755,20 @@
           <a:noFill/>
         </p:spPr>
         <p:txBody>
-          <a:bodyPr wrap="none">
+          <a:bodyPr wrap="square">
             <a:spAutoFit/>
           </a:bodyPr>
           <a:lstStyle/>
           <a:p>
-            <a:pPr>
-              <a:defRPr sz="2800" b="1">
-                <a:solidFill>
-                  <a:srgbClr val="38BDF8"/>
+            <a:pPr algn="l">
+              <a:defRPr sz="3200" b="1">
+                <a:solidFill>
+                  <a:srgbClr val="F97316"/>
                 </a:solidFill>
               </a:defRPr>
             </a:pPr>
             <a:r>
-              <a:t>Solution</a:t>
+              <a:t>The review bottleneck</a:t>
             </a:r>
           </a:p>
         </p:txBody>
@@ -3715,8 +3781,8 @@
         </p:nvSpPr>
         <p:spPr>
           <a:xfrm>
-            <a:off x="731520" y="1188720"/>
-            <a:ext cx="10515600" cy="5029200"/>
+            <a:off x="777240" y="1325880"/>
+            <a:ext cx="10241280" cy="4754880"/>
           </a:xfrm>
           <a:prstGeom prst="rect">
             <a:avLst/>
@@ -3724,40 +3790,53 @@
           <a:noFill/>
         </p:spPr>
         <p:txBody>
-          <a:bodyPr wrap="none">
+          <a:bodyPr wrap="square">
             <a:spAutoFit/>
           </a:bodyPr>
           <a:lstStyle/>
           <a:p>
             <a:pPr>
-              <a:defRPr sz="1800"/>
+              <a:spcAft>
+                <a:spcPts val="1400"/>
+              </a:spcAft>
+              <a:defRPr sz="2000">
+                <a:solidFill>
+                  <a:srgbClr val="FAFAFA"/>
+                </a:solidFill>
+              </a:defRPr>
             </a:pPr>
             <a:r>
-              <a:t>Speak or type natural questions about an open repo</a:t>
+              <a:t>PR queues and diff mountains grow with every agent-assisted sprint</a:t>
             </a:r>
           </a:p>
           <a:p>
             <a:pPr>
-              <a:defRPr sz="1800"/>
+              <a:spcAft>
+                <a:spcPts val="1400"/>
+              </a:spcAft>
+              <a:defRPr sz="2000">
+                <a:solidFill>
+                  <a:srgbClr val="FAFAFA"/>
+                </a:solidFill>
+              </a:defRPr>
             </a:pPr>
             <a:r>
-              <a:t>Circle-pack map: entry points, core, hotspots</a:t>
+              <a:t>LGTM becomes survival, not assurance</a:t>
             </a:r>
           </a:p>
           <a:p>
             <a:pPr>
-              <a:defRPr sz="1800"/>
+              <a:spcAft>
+                <a:spcPts val="1400"/>
+              </a:spcAft>
+              <a:defRPr sz="2000">
+                <a:solidFill>
+                  <a:srgbClr val="FAFAFA"/>
+                </a:solidFill>
+              </a:defRPr>
             </a:pPr>
             <a:r>
-              <a:t>Read commits, issues, PRs; stage writes with confirmation</a:t>
-            </a:r>
-          </a:p>
-          <a:p>
-            <a:pPr>
-              <a:defRPr sz="1800"/>
-            </a:pPr>
-            <a:r>
-              <a:t>AssemblyAI Voice Agent for live conversation</a:t>
+              <a:t>Nobody holds architecture + history + issues in one head</a:t>
             </a:r>
           </a:p>
         </p:txBody>
@@ -3773,6 +3852,14 @@
 <file path=ppt/slides/slide4.xml><?xml version="1.0" encoding="utf-8"?>
 <p:sld xmlns:a="http://schemas.openxmlformats.org/drawingml/2006/main" xmlns:p="http://schemas.openxmlformats.org/presentationml/2006/main" xmlns:r="http://schemas.openxmlformats.org/officeDocument/2006/relationships">
   <p:cSld>
+    <p:bg>
+      <p:bgPr>
+        <a:solidFill>
+          <a:srgbClr val="0A0A0A"/>
+        </a:solidFill>
+        <a:effectLst/>
+      </p:bgPr>
+    </p:bg>
     <p:spTree>
       <p:nvGrpSpPr>
         <p:cNvPr id="1" name=""/>
@@ -3788,8 +3875,8 @@
         </p:nvSpPr>
         <p:spPr>
           <a:xfrm>
-            <a:off x="548640" y="365760"/>
-            <a:ext cx="10972800" cy="731520"/>
+            <a:off x="685800" y="502920"/>
+            <a:ext cx="10515600" cy="1280160"/>
           </a:xfrm>
           <a:prstGeom prst="rect">
             <a:avLst/>
@@ -3797,20 +3884,20 @@
           <a:noFill/>
         </p:spPr>
         <p:txBody>
-          <a:bodyPr wrap="none">
+          <a:bodyPr wrap="square">
             <a:spAutoFit/>
           </a:bodyPr>
           <a:lstStyle/>
           <a:p>
-            <a:pPr>
-              <a:defRPr sz="2800" b="1">
-                <a:solidFill>
-                  <a:srgbClr val="38BDF8"/>
+            <a:pPr algn="l">
+              <a:defRPr sz="3200" b="1">
+                <a:solidFill>
+                  <a:srgbClr val="F97316"/>
                 </a:solidFill>
               </a:defRPr>
             </a:pPr>
             <a:r>
-              <a:t>User experience</a:t>
+              <a:t>The security asymmetry</a:t>
             </a:r>
           </a:p>
         </p:txBody>
@@ -3823,8 +3910,8 @@
         </p:nvSpPr>
         <p:spPr>
           <a:xfrm>
-            <a:off x="731520" y="1188720"/>
-            <a:ext cx="10515600" cy="5029200"/>
+            <a:off x="777240" y="1325880"/>
+            <a:ext cx="10241280" cy="4754880"/>
           </a:xfrm>
           <a:prstGeom prst="rect">
             <a:avLst/>
@@ -3832,40 +3919,53 @@
           <a:noFill/>
         </p:spPr>
         <p:txBody>
-          <a:bodyPr wrap="none">
+          <a:bodyPr wrap="square">
             <a:spAutoFit/>
           </a:bodyPr>
           <a:lstStyle/>
           <a:p>
             <a:pPr>
-              <a:defRPr sz="1800"/>
+              <a:spcAft>
+                <a:spcPts val="1400"/>
+              </a:spcAft>
+              <a:defRPr sz="2000">
+                <a:solidFill>
+                  <a:srgbClr val="FAFAFA"/>
+                </a:solidFill>
+              </a:defRPr>
             </a:pPr>
             <a:r>
-              <a:t>Open localhost:5000/?repo=owner/name</a:t>
+              <a:t>AI finds vulnerabilities and unsafe patterns quickly</a:t>
             </a:r>
           </a:p>
           <a:p>
             <a:pPr>
-              <a:defRPr sz="1800"/>
+              <a:spcAft>
+                <a:spcPts val="1400"/>
+              </a:spcAft>
+              <a:defRPr sz="2000">
+                <a:solidFill>
+                  <a:srgbClr val="FAFAFA"/>
+                </a:solidFill>
+              </a:defRPr>
             </a:pPr>
             <a:r>
-              <a:t>Explore map; hold mic or Ctrl</a:t>
+              <a:t>Exploitation automates; understanding does not</a:t>
             </a:r>
           </a:p>
           <a:p>
             <a:pPr>
-              <a:defRPr sz="1800"/>
+              <a:spcAft>
+                <a:spcPts val="1400"/>
+              </a:spcAft>
+              <a:defRPr sz="2000">
+                <a:solidFill>
+                  <a:srgbClr val="FAFAFA"/>
+                </a:solidFill>
+              </a:defRPr>
             </a:pPr>
             <a:r>
-              <a:t>Ask landmarks, diffs, issues</a:t>
-            </a:r>
-          </a:p>
-          <a:p>
-            <a:pPr>
-              <a:defRPr sz="1800"/>
-            </a:pPr>
-            <a:r>
-              <a:t>Draft issue/comment then yes on a new turn</a:t>
+              <a:t>Ship fast without orientation → lose grip on what actually runs</a:t>
             </a:r>
           </a:p>
         </p:txBody>
@@ -3881,6 +3981,14 @@
 <file path=ppt/slides/slide5.xml><?xml version="1.0" encoding="utf-8"?>
 <p:sld xmlns:a="http://schemas.openxmlformats.org/drawingml/2006/main" xmlns:p="http://schemas.openxmlformats.org/presentationml/2006/main" xmlns:r="http://schemas.openxmlformats.org/officeDocument/2006/relationships">
   <p:cSld>
+    <p:bg>
+      <p:bgPr>
+        <a:solidFill>
+          <a:srgbClr val="0A0A0A"/>
+        </a:solidFill>
+        <a:effectLst/>
+      </p:bgPr>
+    </p:bg>
     <p:spTree>
       <p:nvGrpSpPr>
         <p:cNvPr id="1" name=""/>
@@ -3896,8 +4004,8 @@
         </p:nvSpPr>
         <p:spPr>
           <a:xfrm>
-            <a:off x="548640" y="365760"/>
-            <a:ext cx="10972800" cy="731520"/>
+            <a:off x="685800" y="1645920"/>
+            <a:ext cx="10515600" cy="1280160"/>
           </a:xfrm>
           <a:prstGeom prst="rect">
             <a:avLst/>
@@ -3905,20 +4013,20 @@
           <a:noFill/>
         </p:spPr>
         <p:txBody>
-          <a:bodyPr wrap="none">
+          <a:bodyPr wrap="square">
             <a:spAutoFit/>
           </a:bodyPr>
           <a:lstStyle/>
           <a:p>
-            <a:pPr>
-              <a:defRPr sz="2800" b="1">
-                <a:solidFill>
-                  <a:srgbClr val="38BDF8"/>
+            <a:pPr algn="l">
+              <a:defRPr sz="4400" b="1">
+                <a:solidFill>
+                  <a:srgbClr val="F97316"/>
                 </a:solidFill>
               </a:defRPr>
             </a:pPr>
             <a:r>
-              <a:t>Client architecture</a:t>
+              <a:t>Friday</a:t>
             </a:r>
           </a:p>
         </p:txBody>
@@ -3931,8 +4039,8 @@
         </p:nvSpPr>
         <p:spPr>
           <a:xfrm>
-            <a:off x="731520" y="1188720"/>
-            <a:ext cx="10515600" cy="5029200"/>
+            <a:off x="685800" y="2651760"/>
+            <a:ext cx="10515600" cy="1097280"/>
           </a:xfrm>
           <a:prstGeom prst="rect">
             <a:avLst/>
@@ -3946,34 +4054,18 @@
           <a:lstStyle/>
           <a:p>
             <a:pPr>
-              <a:defRPr sz="1800"/>
+              <a:defRPr sz="2200">
+                <a:solidFill>
+                  <a:srgbClr val="A1A1AA"/>
+                </a:solidFill>
+              </a:defRPr>
             </a:pPr>
             <a:r>
-              <a:t>D3 circle pack + file sidebar</a:t>
-            </a:r>
-          </a:p>
-          <a:p>
-            <a:pPr>
-              <a:defRPr sz="1800"/>
-            </a:pPr>
-            <a:r>
-              <a:t>Voice WebSocket to AssemblyAI</a:t>
-            </a:r>
-          </a:p>
-          <a:p>
-            <a:pPr>
-              <a:defRPr sz="1800"/>
-            </a:pPr>
-            <a:r>
-              <a:t>friday_turn to chat.turn on server</a:t>
-            </a:r>
-          </a:p>
-          <a:p>
-            <a:pPr>
-              <a:defRPr sz="1800"/>
-            </a:pPr>
-            <a:r>
-              <a:t>Ask + activity trace</a:t>
+              <a:t>A voice-first control surface for the repo you have open.</a:t>
+            </a:r>
+            <a:br/>
+            <a:r>
+              <a:t>See the shape. Ask out loud. Stage GitHub actions. Confirm before you post.</a:t>
             </a:r>
           </a:p>
         </p:txBody>
@@ -3989,6 +4081,14 @@
 <file path=ppt/slides/slide6.xml><?xml version="1.0" encoding="utf-8"?>
 <p:sld xmlns:a="http://schemas.openxmlformats.org/drawingml/2006/main" xmlns:p="http://schemas.openxmlformats.org/presentationml/2006/main" xmlns:r="http://schemas.openxmlformats.org/officeDocument/2006/relationships">
   <p:cSld>
+    <p:bg>
+      <p:bgPr>
+        <a:solidFill>
+          <a:srgbClr val="0A0A0A"/>
+        </a:solidFill>
+        <a:effectLst/>
+      </p:bgPr>
+    </p:bg>
     <p:spTree>
       <p:nvGrpSpPr>
         <p:cNvPr id="1" name=""/>
@@ -4004,8 +4104,8 @@
         </p:nvSpPr>
         <p:spPr>
           <a:xfrm>
-            <a:off x="548640" y="365760"/>
-            <a:ext cx="10972800" cy="731520"/>
+            <a:off x="685800" y="502920"/>
+            <a:ext cx="10515600" cy="1280160"/>
           </a:xfrm>
           <a:prstGeom prst="rect">
             <a:avLst/>
@@ -4013,20 +4113,20 @@
           <a:noFill/>
         </p:spPr>
         <p:txBody>
-          <a:bodyPr wrap="none">
+          <a:bodyPr wrap="square">
             <a:spAutoFit/>
           </a:bodyPr>
           <a:lstStyle/>
           <a:p>
-            <a:pPr>
-              <a:defRPr sz="2800" b="1">
-                <a:solidFill>
-                  <a:srgbClr val="38BDF8"/>
+            <a:pPr algn="l">
+              <a:defRPr sz="3200" b="1">
+                <a:solidFill>
+                  <a:srgbClr val="F97316"/>
                 </a:solidFill>
               </a:defRPr>
             </a:pPr>
             <a:r>
-              <a:t>Server architecture</a:t>
+              <a:t>Product</a:t>
             </a:r>
           </a:p>
         </p:txBody>
@@ -4039,8 +4139,8 @@
         </p:nvSpPr>
         <p:spPr>
           <a:xfrm>
-            <a:off x="731520" y="1188720"/>
-            <a:ext cx="10515600" cy="5029200"/>
+            <a:off x="777240" y="1325880"/>
+            <a:ext cx="10241280" cy="4754880"/>
           </a:xfrm>
           <a:prstGeom prst="rect">
             <a:avLst/>
@@ -4048,40 +4148,68 @@
           <a:noFill/>
         </p:spPr>
         <p:txBody>
-          <a:bodyPr wrap="none">
+          <a:bodyPr wrap="square">
             <a:spAutoFit/>
           </a:bodyPr>
           <a:lstStyle/>
           <a:p>
             <a:pPr>
-              <a:defRPr sz="1800"/>
+              <a:spcAft>
+                <a:spcPts val="1400"/>
+              </a:spcAft>
+              <a:defRPr sz="2000">
+                <a:solidFill>
+                  <a:srgbClr val="FAFAFA"/>
+                </a:solidFill>
+              </a:defRPr>
             </a:pPr>
             <a:r>
-              <a:t>map_pipeline ingest and landmarks</a:t>
+              <a:t>Circle-pack map — entry points, core, hotspots</a:t>
             </a:r>
           </a:p>
           <a:p>
             <a:pPr>
-              <a:defRPr sz="1800"/>
+              <a:spcAft>
+                <a:spcPts val="1400"/>
+              </a:spcAft>
+              <a:defRPr sz="2000">
+                <a:solidFill>
+                  <a:srgbClr val="FAFAFA"/>
+                </a:solidFill>
+              </a:defRPr>
             </a:pPr>
             <a:r>
-              <a:t>chat.turn: direct, gateway, Jev, orchestrator</a:t>
+              <a:t>Landmarks + layers — heat, imports, focus</a:t>
             </a:r>
           </a:p>
           <a:p>
             <a:pPr>
-              <a:defRPr sz="1800"/>
+              <a:spcAft>
+                <a:spcPts val="1400"/>
+              </a:spcAft>
+              <a:defRPr sz="2000">
+                <a:solidFill>
+                  <a:srgbClr val="FAFAFA"/>
+                </a:solidFill>
+              </a:defRPr>
             </a:pPr>
             <a:r>
-              <a:t>agent.run_agent: 8-turn Gateway loop</a:t>
+              <a:t>Voice (AssemblyAI) + typed Ask — same brain</a:t>
             </a:r>
           </a:p>
           <a:p>
             <a:pPr>
-              <a:defRPr sz="1800"/>
+              <a:spcAft>
+                <a:spcPts val="1400"/>
+              </a:spcAft>
+              <a:defRPr sz="2000">
+                <a:solidFill>
+                  <a:srgbClr val="FAFAFA"/>
+                </a:solidFill>
+              </a:defRPr>
             </a:pPr>
             <a:r>
-              <a:t>github_tools REST + confirm_write</a:t>
+              <a:t>Commits, issues, PRs, security scan, merge review</a:t>
             </a:r>
           </a:p>
         </p:txBody>
@@ -4097,6 +4225,14 @@
 <file path=ppt/slides/slide7.xml><?xml version="1.0" encoding="utf-8"?>
 <p:sld xmlns:a="http://schemas.openxmlformats.org/drawingml/2006/main" xmlns:p="http://schemas.openxmlformats.org/presentationml/2006/main" xmlns:r="http://schemas.openxmlformats.org/officeDocument/2006/relationships">
   <p:cSld>
+    <p:bg>
+      <p:bgPr>
+        <a:solidFill>
+          <a:srgbClr val="0A0A0A"/>
+        </a:solidFill>
+        <a:effectLst/>
+      </p:bgPr>
+    </p:bg>
     <p:spTree>
       <p:nvGrpSpPr>
         <p:cNvPr id="1" name=""/>
@@ -4112,8 +4248,8 @@
         </p:nvSpPr>
         <p:spPr>
           <a:xfrm>
-            <a:off x="548640" y="365760"/>
-            <a:ext cx="10972800" cy="731520"/>
+            <a:off x="685800" y="411480"/>
+            <a:ext cx="10515600" cy="1280160"/>
           </a:xfrm>
           <a:prstGeom prst="rect">
             <a:avLst/>
@@ -4121,34 +4257,427 @@
           <a:noFill/>
         </p:spPr>
         <p:txBody>
-          <a:bodyPr wrap="none">
+          <a:bodyPr wrap="square">
             <a:spAutoFit/>
           </a:bodyPr>
           <a:lstStyle/>
           <a:p>
+            <a:pPr algn="l">
+              <a:defRPr sz="3000" b="1">
+                <a:solidFill>
+                  <a:srgbClr val="F97316"/>
+                </a:solidFill>
+              </a:defRPr>
+            </a:pPr>
+            <a:r>
+              <a:t>How Friday works</a:t>
+            </a:r>
+          </a:p>
+        </p:txBody>
+      </p:sp>
+      <p:sp>
+        <p:nvSpPr>
+          <p:cNvPr id="3" name="Rounded Rectangle 2"/>
+          <p:cNvSpPr/>
+          <p:nvPr/>
+        </p:nvSpPr>
+        <p:spPr>
+          <a:xfrm>
+            <a:off x="548640" y="2148840"/>
+            <a:ext cx="2377440" cy="1234440"/>
+          </a:xfrm>
+          <a:prstGeom prst="roundRect">
+            <a:avLst/>
+          </a:prstGeom>
+          <a:solidFill>
+            <a:srgbClr val="1C1C1E"/>
+          </a:solidFill>
+          <a:ln>
+            <a:solidFill>
+              <a:srgbClr val="F97316"/>
+            </a:solidFill>
+          </a:ln>
+        </p:spPr>
+        <p:style>
+          <a:lnRef idx="1">
+            <a:schemeClr val="accent1"/>
+          </a:lnRef>
+          <a:fillRef idx="3">
+            <a:schemeClr val="accent1"/>
+          </a:fillRef>
+          <a:effectRef idx="2">
+            <a:schemeClr val="accent1"/>
+          </a:effectRef>
+          <a:fontRef idx="minor">
+            <a:schemeClr val="lt1"/>
+          </a:fontRef>
+        </p:style>
+        <p:txBody>
+          <a:bodyPr rtlCol="0" anchor="ctr"/>
+          <a:lstStyle/>
+          <a:p>
+            <a:pPr algn="ctr">
+              <a:defRPr sz="1800" b="1">
+                <a:solidFill>
+                  <a:srgbClr val="FAFAFA"/>
+                </a:solidFill>
+              </a:defRPr>
+            </a:pPr>
+            <a:r>
+              <a:t>You</a:t>
+            </a:r>
+          </a:p>
+          <a:p>
             <a:pPr>
-              <a:defRPr sz="2800" b="1">
-                <a:solidFill>
-                  <a:srgbClr val="38BDF8"/>
+              <a:defRPr sz="1300">
+                <a:solidFill>
+                  <a:srgbClr val="A1A1AA"/>
                 </a:solidFill>
               </a:defRPr>
             </a:pPr>
             <a:r>
-              <a:t>Routing for reliability</a:t>
-            </a:r>
-          </a:p>
-        </p:txBody>
-      </p:sp>
-      <p:sp>
-        <p:nvSpPr>
-          <p:cNvPr id="3" name="TextBox 2"/>
+              <a:t>Voice or text</a:t>
+            </a:r>
+          </a:p>
+        </p:txBody>
+      </p:sp>
+      <p:sp>
+        <p:nvSpPr>
+          <p:cNvPr id="4" name="Right Arrow 3"/>
+          <p:cNvSpPr/>
+          <p:nvPr/>
+        </p:nvSpPr>
+        <p:spPr>
+          <a:xfrm>
+            <a:off x="2971800" y="2560320"/>
+            <a:ext cx="228599" cy="320040"/>
+          </a:xfrm>
+          <a:prstGeom prst="rightArrow">
+            <a:avLst/>
+          </a:prstGeom>
+          <a:solidFill>
+            <a:srgbClr val="A1A1AA"/>
+          </a:solidFill>
+          <a:ln>
+            <a:noFill/>
+          </a:ln>
+        </p:spPr>
+        <p:style>
+          <a:lnRef idx="1">
+            <a:schemeClr val="accent1"/>
+          </a:lnRef>
+          <a:fillRef idx="3">
+            <a:schemeClr val="accent1"/>
+          </a:fillRef>
+          <a:effectRef idx="2">
+            <a:schemeClr val="accent1"/>
+          </a:effectRef>
+          <a:fontRef idx="minor">
+            <a:schemeClr val="lt1"/>
+          </a:fontRef>
+        </p:style>
+        <p:txBody>
+          <a:bodyPr rtlCol="0" anchor="ctr"/>
+          <a:lstStyle/>
+          <a:p>
+            <a:pPr algn="ctr"/>
+          </a:p>
+        </p:txBody>
+      </p:sp>
+      <p:sp>
+        <p:nvSpPr>
+          <p:cNvPr id="5" name="Rounded Rectangle 4"/>
+          <p:cNvSpPr/>
+          <p:nvPr/>
+        </p:nvSpPr>
+        <p:spPr>
+          <a:xfrm>
+            <a:off x="3246120" y="2148840"/>
+            <a:ext cx="2377440" cy="1234440"/>
+          </a:xfrm>
+          <a:prstGeom prst="roundRect">
+            <a:avLst/>
+          </a:prstGeom>
+          <a:solidFill>
+            <a:srgbClr val="1C1C1E"/>
+          </a:solidFill>
+          <a:ln>
+            <a:solidFill>
+              <a:srgbClr val="F97316"/>
+            </a:solidFill>
+          </a:ln>
+        </p:spPr>
+        <p:style>
+          <a:lnRef idx="1">
+            <a:schemeClr val="accent1"/>
+          </a:lnRef>
+          <a:fillRef idx="3">
+            <a:schemeClr val="accent1"/>
+          </a:fillRef>
+          <a:effectRef idx="2">
+            <a:schemeClr val="accent1"/>
+          </a:effectRef>
+          <a:fontRef idx="minor">
+            <a:schemeClr val="lt1"/>
+          </a:fontRef>
+        </p:style>
+        <p:txBody>
+          <a:bodyPr rtlCol="0" anchor="ctr"/>
+          <a:lstStyle/>
+          <a:p>
+            <a:pPr algn="ctr">
+              <a:defRPr sz="1800" b="1">
+                <a:solidFill>
+                  <a:srgbClr val="FAFAFA"/>
+                </a:solidFill>
+              </a:defRPr>
+            </a:pPr>
+            <a:r>
+              <a:t>Friday</a:t>
+            </a:r>
+          </a:p>
+          <a:p>
+            <a:pPr>
+              <a:defRPr sz="1300">
+                <a:solidFill>
+                  <a:srgbClr val="A1A1AA"/>
+                </a:solidFill>
+              </a:defRPr>
+            </a:pPr>
+            <a:r>
+              <a:t>Route + tools</a:t>
+            </a:r>
+          </a:p>
+        </p:txBody>
+      </p:sp>
+      <p:sp>
+        <p:nvSpPr>
+          <p:cNvPr id="6" name="Right Arrow 5"/>
+          <p:cNvSpPr/>
+          <p:nvPr/>
+        </p:nvSpPr>
+        <p:spPr>
+          <a:xfrm>
+            <a:off x="5669280" y="2560320"/>
+            <a:ext cx="228599" cy="320040"/>
+          </a:xfrm>
+          <a:prstGeom prst="rightArrow">
+            <a:avLst/>
+          </a:prstGeom>
+          <a:solidFill>
+            <a:srgbClr val="A1A1AA"/>
+          </a:solidFill>
+          <a:ln>
+            <a:noFill/>
+          </a:ln>
+        </p:spPr>
+        <p:style>
+          <a:lnRef idx="1">
+            <a:schemeClr val="accent1"/>
+          </a:lnRef>
+          <a:fillRef idx="3">
+            <a:schemeClr val="accent1"/>
+          </a:fillRef>
+          <a:effectRef idx="2">
+            <a:schemeClr val="accent1"/>
+          </a:effectRef>
+          <a:fontRef idx="minor">
+            <a:schemeClr val="lt1"/>
+          </a:fontRef>
+        </p:style>
+        <p:txBody>
+          <a:bodyPr rtlCol="0" anchor="ctr"/>
+          <a:lstStyle/>
+          <a:p>
+            <a:pPr algn="ctr"/>
+          </a:p>
+        </p:txBody>
+      </p:sp>
+      <p:sp>
+        <p:nvSpPr>
+          <p:cNvPr id="7" name="Rounded Rectangle 6"/>
+          <p:cNvSpPr/>
+          <p:nvPr/>
+        </p:nvSpPr>
+        <p:spPr>
+          <a:xfrm>
+            <a:off x="5943600" y="2148840"/>
+            <a:ext cx="2377440" cy="1234440"/>
+          </a:xfrm>
+          <a:prstGeom prst="roundRect">
+            <a:avLst/>
+          </a:prstGeom>
+          <a:solidFill>
+            <a:srgbClr val="1C1C1E"/>
+          </a:solidFill>
+          <a:ln>
+            <a:solidFill>
+              <a:srgbClr val="F97316"/>
+            </a:solidFill>
+          </a:ln>
+        </p:spPr>
+        <p:style>
+          <a:lnRef idx="1">
+            <a:schemeClr val="accent1"/>
+          </a:lnRef>
+          <a:fillRef idx="3">
+            <a:schemeClr val="accent1"/>
+          </a:fillRef>
+          <a:effectRef idx="2">
+            <a:schemeClr val="accent1"/>
+          </a:effectRef>
+          <a:fontRef idx="minor">
+            <a:schemeClr val="lt1"/>
+          </a:fontRef>
+        </p:style>
+        <p:txBody>
+          <a:bodyPr rtlCol="0" anchor="ctr"/>
+          <a:lstStyle/>
+          <a:p>
+            <a:pPr algn="ctr">
+              <a:defRPr sz="1800" b="1">
+                <a:solidFill>
+                  <a:srgbClr val="FAFAFA"/>
+                </a:solidFill>
+              </a:defRPr>
+            </a:pPr>
+            <a:r>
+              <a:t>Map + GitHub</a:t>
+            </a:r>
+          </a:p>
+          <a:p>
+            <a:pPr>
+              <a:defRPr sz="1300">
+                <a:solidFill>
+                  <a:srgbClr val="A1A1AA"/>
+                </a:solidFill>
+              </a:defRPr>
+            </a:pPr>
+            <a:r>
+              <a:t>Ground truth</a:t>
+            </a:r>
+          </a:p>
+        </p:txBody>
+      </p:sp>
+      <p:sp>
+        <p:nvSpPr>
+          <p:cNvPr id="8" name="Right Arrow 7"/>
+          <p:cNvSpPr/>
+          <p:nvPr/>
+        </p:nvSpPr>
+        <p:spPr>
+          <a:xfrm>
+            <a:off x="8366760" y="2560320"/>
+            <a:ext cx="228599" cy="320040"/>
+          </a:xfrm>
+          <a:prstGeom prst="rightArrow">
+            <a:avLst/>
+          </a:prstGeom>
+          <a:solidFill>
+            <a:srgbClr val="A1A1AA"/>
+          </a:solidFill>
+          <a:ln>
+            <a:noFill/>
+          </a:ln>
+        </p:spPr>
+        <p:style>
+          <a:lnRef idx="1">
+            <a:schemeClr val="accent1"/>
+          </a:lnRef>
+          <a:fillRef idx="3">
+            <a:schemeClr val="accent1"/>
+          </a:fillRef>
+          <a:effectRef idx="2">
+            <a:schemeClr val="accent1"/>
+          </a:effectRef>
+          <a:fontRef idx="minor">
+            <a:schemeClr val="lt1"/>
+          </a:fontRef>
+        </p:style>
+        <p:txBody>
+          <a:bodyPr rtlCol="0" anchor="ctr"/>
+          <a:lstStyle/>
+          <a:p>
+            <a:pPr algn="ctr"/>
+          </a:p>
+        </p:txBody>
+      </p:sp>
+      <p:sp>
+        <p:nvSpPr>
+          <p:cNvPr id="9" name="Rounded Rectangle 8"/>
+          <p:cNvSpPr/>
+          <p:nvPr/>
+        </p:nvSpPr>
+        <p:spPr>
+          <a:xfrm>
+            <a:off x="8641080" y="2148840"/>
+            <a:ext cx="2377440" cy="1234440"/>
+          </a:xfrm>
+          <a:prstGeom prst="roundRect">
+            <a:avLst/>
+          </a:prstGeom>
+          <a:solidFill>
+            <a:srgbClr val="1C1C1E"/>
+          </a:solidFill>
+          <a:ln>
+            <a:solidFill>
+              <a:srgbClr val="F97316"/>
+            </a:solidFill>
+          </a:ln>
+        </p:spPr>
+        <p:style>
+          <a:lnRef idx="1">
+            <a:schemeClr val="accent1"/>
+          </a:lnRef>
+          <a:fillRef idx="3">
+            <a:schemeClr val="accent1"/>
+          </a:fillRef>
+          <a:effectRef idx="2">
+            <a:schemeClr val="accent1"/>
+          </a:effectRef>
+          <a:fontRef idx="minor">
+            <a:schemeClr val="lt1"/>
+          </a:fontRef>
+        </p:style>
+        <p:txBody>
+          <a:bodyPr rtlCol="0" anchor="ctr"/>
+          <a:lstStyle/>
+          <a:p>
+            <a:pPr algn="ctr">
+              <a:defRPr sz="1800" b="1">
+                <a:solidFill>
+                  <a:srgbClr val="FAFAFA"/>
+                </a:solidFill>
+              </a:defRPr>
+            </a:pPr>
+            <a:r>
+              <a:t>You</a:t>
+            </a:r>
+          </a:p>
+          <a:p>
+            <a:pPr>
+              <a:defRPr sz="1300">
+                <a:solidFill>
+                  <a:srgbClr val="A1A1AA"/>
+                </a:solidFill>
+              </a:defRPr>
+            </a:pPr>
+            <a:r>
+              <a:t>Yes to post</a:t>
+            </a:r>
+          </a:p>
+        </p:txBody>
+      </p:sp>
+      <p:sp>
+        <p:nvSpPr>
+          <p:cNvPr id="10" name="TextBox 9"/>
           <p:cNvSpPr txBox="1"/>
           <p:nvPr/>
         </p:nvSpPr>
         <p:spPr>
           <a:xfrm>
-            <a:off x="731520" y="1188720"/>
-            <a:ext cx="10515600" cy="5029200"/>
+            <a:off x="685800" y="3794760"/>
+            <a:ext cx="10515600" cy="1097280"/>
           </a:xfrm>
           <a:prstGeom prst="rect">
             <a:avLst/>
@@ -4162,34 +4691,14 @@
           <a:lstStyle/>
           <a:p>
             <a:pPr>
-              <a:defRPr sz="1800"/>
+              <a:defRPr sz="1600">
+                <a:solidFill>
+                  <a:srgbClr val="A1A1AA"/>
+                </a:solidFill>
+              </a:defRPr>
             </a:pPr>
             <a:r>
-              <a:t>command: parsers and map shortcuts</a:t>
-            </a:r>
-          </a:p>
-          <a:p>
-            <a:pPr>
-              <a:defRPr sz="1800"/>
-            </a:pPr>
-            <a:r>
-              <a:t>gateway: multi-step GitHub triage</a:t>
-            </a:r>
-          </a:p>
-          <a:p>
-            <a:pPr>
-              <a:defRPr sz="1800"/>
-            </a:pPr>
-            <a:r>
-              <a:t>jev: single confident map tool</a:t>
-            </a:r>
-          </a:p>
-          <a:p>
-            <a:pPr>
-              <a:defRPr sz="1800"/>
-            </a:pPr>
-            <a:r>
-              <a:t>K2 when Jev confidence is low</a:t>
+              <a:t>Jev picks map tools · Gateway loop for multi-step GitHub · Writes never auto-post</a:t>
             </a:r>
           </a:p>
         </p:txBody>
@@ -4205,6 +4714,14 @@
 <file path=ppt/slides/slide8.xml><?xml version="1.0" encoding="utf-8"?>
 <p:sld xmlns:a="http://schemas.openxmlformats.org/drawingml/2006/main" xmlns:p="http://schemas.openxmlformats.org/presentationml/2006/main" xmlns:r="http://schemas.openxmlformats.org/officeDocument/2006/relationships">
   <p:cSld>
+    <p:bg>
+      <p:bgPr>
+        <a:solidFill>
+          <a:srgbClr val="0A0A0A"/>
+        </a:solidFill>
+        <a:effectLst/>
+      </p:bgPr>
+    </p:bg>
     <p:spTree>
       <p:nvGrpSpPr>
         <p:cNvPr id="1" name=""/>
@@ -4220,8 +4737,8 @@
         </p:nvSpPr>
         <p:spPr>
           <a:xfrm>
-            <a:off x="548640" y="365760"/>
-            <a:ext cx="10972800" cy="731520"/>
+            <a:off x="685800" y="502920"/>
+            <a:ext cx="10515600" cy="1280160"/>
           </a:xfrm>
           <a:prstGeom prst="rect">
             <a:avLst/>
@@ -4229,20 +4746,20 @@
           <a:noFill/>
         </p:spPr>
         <p:txBody>
-          <a:bodyPr wrap="none">
+          <a:bodyPr wrap="square">
             <a:spAutoFit/>
           </a:bodyPr>
           <a:lstStyle/>
           <a:p>
-            <a:pPr>
-              <a:defRPr sz="2800" b="1">
-                <a:solidFill>
-                  <a:srgbClr val="38BDF8"/>
+            <a:pPr algn="l">
+              <a:defRPr sz="3200" b="1">
+                <a:solidFill>
+                  <a:srgbClr val="F97316"/>
                 </a:solidFill>
               </a:defRPr>
             </a:pPr>
             <a:r>
-              <a:t>AssemblyAI</a:t>
+              <a:t>Human in the loop</a:t>
             </a:r>
           </a:p>
         </p:txBody>
@@ -4255,8 +4772,8 @@
         </p:nvSpPr>
         <p:spPr>
           <a:xfrm>
-            <a:off x="731520" y="1188720"/>
-            <a:ext cx="10515600" cy="5029200"/>
+            <a:off x="777240" y="1325880"/>
+            <a:ext cx="10241280" cy="4754880"/>
           </a:xfrm>
           <a:prstGeom prst="rect">
             <a:avLst/>
@@ -4264,40 +4781,68 @@
           <a:noFill/>
         </p:spPr>
         <p:txBody>
-          <a:bodyPr wrap="none">
+          <a:bodyPr wrap="square">
             <a:spAutoFit/>
           </a:bodyPr>
           <a:lstStyle/>
           <a:p>
             <a:pPr>
-              <a:defRPr sz="1800"/>
+              <a:spcAft>
+                <a:spcPts val="1400"/>
+              </a:spcAft>
+              <a:defRPr sz="2000">
+                <a:solidFill>
+                  <a:srgbClr val="FAFAFA"/>
+                </a:solidFill>
+              </a:defRPr>
             </a:pPr>
             <a:r>
-              <a:t>Voice Agent live STT and TTS</a:t>
+              <a:t>create_issue / add_comment → draft only</a:t>
             </a:r>
           </a:p>
           <a:p>
             <a:pPr>
-              <a:defRPr sz="1800"/>
+              <a:spcAft>
+                <a:spcPts val="1400"/>
+              </a:spcAft>
+              <a:defRPr sz="2000">
+                <a:solidFill>
+                  <a:srgbClr val="FAFAFA"/>
+                </a:solidFill>
+              </a:defRPr>
             </a:pPr>
             <a:r>
-              <a:t>Sync API for /api/run</a:t>
+              <a:t>Separate turn: yes → confirm_write posts</a:t>
             </a:r>
           </a:p>
           <a:p>
             <a:pPr>
-              <a:defRPr sz="1800"/>
+              <a:spcAft>
+                <a:spcPts val="1400"/>
+              </a:spcAft>
+              <a:defRPr sz="2000">
+                <a:solidFill>
+                  <a:srgbClr val="FAFAFA"/>
+                </a:solidFill>
+              </a:defRPr>
             </a:pPr>
             <a:r>
-              <a:t>LLM Gateway tool calling</a:t>
+              <a:t>No silent auto-merge, no drive-by comments</a:t>
             </a:r>
           </a:p>
           <a:p>
             <a:pPr>
-              <a:defRPr sz="1800"/>
+              <a:spcAft>
+                <a:spcPts val="1400"/>
+              </a:spcAft>
+              <a:defRPr sz="2000">
+                <a:solidFill>
+                  <a:srgbClr val="FAFAFA"/>
+                </a:solidFill>
+              </a:defRPr>
             </a:pPr>
             <a:r>
-              <a:t>Different auth per surface</a:t>
+              <a:t>OAuth + tokens stay server-side</a:t>
             </a:r>
           </a:p>
         </p:txBody>
@@ -4313,6 +4858,14 @@
 <file path=ppt/slides/slide9.xml><?xml version="1.0" encoding="utf-8"?>
 <p:sld xmlns:a="http://schemas.openxmlformats.org/drawingml/2006/main" xmlns:p="http://schemas.openxmlformats.org/presentationml/2006/main" xmlns:r="http://schemas.openxmlformats.org/officeDocument/2006/relationships">
   <p:cSld>
+    <p:bg>
+      <p:bgPr>
+        <a:solidFill>
+          <a:srgbClr val="0A0A0A"/>
+        </a:solidFill>
+        <a:effectLst/>
+      </p:bgPr>
+    </p:bg>
     <p:spTree>
       <p:nvGrpSpPr>
         <p:cNvPr id="1" name=""/>
@@ -4328,8 +4881,8 @@
         </p:nvSpPr>
         <p:spPr>
           <a:xfrm>
-            <a:off x="548640" y="365760"/>
-            <a:ext cx="10972800" cy="731520"/>
+            <a:off x="685800" y="502920"/>
+            <a:ext cx="10515600" cy="1280160"/>
           </a:xfrm>
           <a:prstGeom prst="rect">
             <a:avLst/>
@@ -4337,20 +4890,20 @@
           <a:noFill/>
         </p:spPr>
         <p:txBody>
-          <a:bodyPr wrap="none">
+          <a:bodyPr wrap="square">
             <a:spAutoFit/>
           </a:bodyPr>
           <a:lstStyle/>
           <a:p>
-            <a:pPr>
-              <a:defRPr sz="2800" b="1">
-                <a:solidFill>
-                  <a:srgbClr val="38BDF8"/>
+            <a:pPr algn="l">
+              <a:defRPr sz="3200" b="1">
+                <a:solidFill>
+                  <a:srgbClr val="F97316"/>
                 </a:solidFill>
               </a:defRPr>
             </a:pPr>
             <a:r>
-              <a:t>GitHub safety</a:t>
+              <a:t>Judgment, not vibes</a:t>
             </a:r>
           </a:p>
         </p:txBody>
@@ -4363,8 +4916,8 @@
         </p:nvSpPr>
         <p:spPr>
           <a:xfrm>
-            <a:off x="731520" y="1188720"/>
-            <a:ext cx="10515600" cy="5029200"/>
+            <a:off x="777240" y="1325880"/>
+            <a:ext cx="10241280" cy="4754880"/>
           </a:xfrm>
           <a:prstGeom prst="rect">
             <a:avLst/>
@@ -4372,40 +4925,68 @@
           <a:noFill/>
         </p:spPr>
         <p:txBody>
-          <a:bodyPr wrap="none">
+          <a:bodyPr wrap="square">
             <a:spAutoFit/>
           </a:bodyPr>
           <a:lstStyle/>
           <a:p>
             <a:pPr>
-              <a:defRPr sz="1800"/>
+              <a:spcAft>
+                <a:spcPts val="1400"/>
+              </a:spcAft>
+              <a:defRPr sz="2000">
+                <a:solidFill>
+                  <a:srgbClr val="FAFAFA"/>
+                </a:solidFill>
+              </a:defRPr>
             </a:pPr>
             <a:r>
-              <a:t>Issues and comments staged only</a:t>
+              <a:t>Jev: confident tool routing for map questions</a:t>
             </a:r>
           </a:p>
           <a:p>
             <a:pPr>
-              <a:defRPr sz="1800"/>
+              <a:spcAft>
+                <a:spcPts val="1400"/>
+              </a:spcAft>
+              <a:defRPr sz="2000">
+                <a:solidFill>
+                  <a:srgbClr val="FAFAFA"/>
+                </a:solidFill>
+              </a:defRPr>
             </a:pPr>
             <a:r>
-              <a:t>confirm_write on later yes</a:t>
+              <a:t>Review gate: structured safe-to-merge narrative</a:t>
             </a:r>
           </a:p>
           <a:p>
             <a:pPr>
-              <a:defRPr sz="1800"/>
+              <a:spcAft>
+                <a:spcPts val="1400"/>
+              </a:spcAft>
+              <a:defRPr sz="2000">
+                <a:solidFill>
+                  <a:srgbClr val="FAFAFA"/>
+                </a:solidFill>
+              </a:defRPr>
             </a:pPr>
             <a:r>
-              <a:t>OAuth optional; secrets server-side</a:t>
+              <a:t>Escalate when confidence is low (Vertex / K2)</a:t>
             </a:r>
           </a:p>
           <a:p>
             <a:pPr>
-              <a:defRPr sz="1800"/>
+              <a:spcAft>
+                <a:spcPts val="1400"/>
+              </a:spcAft>
+              <a:defRPr sz="2000">
+                <a:solidFill>
+                  <a:srgbClr val="FAFAFA"/>
+                </a:solidFill>
+              </a:defRPr>
             </a:pPr>
             <a:r>
-              <a:t>No close/delete on issues or PRs</a:t>
+              <a:t>Honest give-up when the repo cannot answer</a:t>
             </a:r>
           </a:p>
         </p:txBody>

</xml_diff>

<commit_message>
docs: add demo script for Friday voice agent and enhance pitch deck generation
Introduce a comprehensive demo script for showcasing the Friday voice agent's capabilities, emphasizing its interaction with GitHub. Additionally, improve the pitch deck generation script with updated styling and layout adjustments for better presentation quality.
</commit_message>
<xml_diff>
--- a/docs/presentation/Friday-Voice-Agent.pptx
+++ b/docs/presentation/Friday-Voice-Agent.pptx
@@ -16,8 +16,6 @@
     <p:sldId id="264" r:id="rId15"/>
     <p:sldId id="265" r:id="rId16"/>
     <p:sldId id="266" r:id="rId17"/>
-    <p:sldId id="267" r:id="rId18"/>
-    <p:sldId id="268" r:id="rId19"/>
   </p:sldIdLst>
   <p:sldSz cx="12191695" cy="6858000" type="screen4x3"/>
   <p:notesSz cx="6858000" cy="9144000"/>
@@ -3093,14 +3091,6 @@
 <file path=ppt/slides/slide1.xml><?xml version="1.0" encoding="utf-8"?>
 <p:sld xmlns:a="http://schemas.openxmlformats.org/drawingml/2006/main" xmlns:p="http://schemas.openxmlformats.org/presentationml/2006/main" xmlns:r="http://schemas.openxmlformats.org/officeDocument/2006/relationships">
   <p:cSld>
-    <p:bg>
-      <p:bgPr>
-        <a:solidFill>
-          <a:srgbClr val="0A0A0A"/>
-        </a:solidFill>
-        <a:effectLst/>
-      </p:bgPr>
-    </p:bg>
     <p:spTree>
       <p:nvGrpSpPr>
         <p:cNvPr id="1" name=""/>
@@ -3110,36 +3100,44 @@
       <p:grpSpPr/>
       <p:sp>
         <p:nvSpPr>
-          <p:cNvPr id="2" name="TextBox 1"/>
-          <p:cNvSpPr txBox="1"/>
-          <p:nvPr/>
-        </p:nvSpPr>
-        <p:spPr>
-          <a:xfrm>
-            <a:off x="685800" y="2103120"/>
-            <a:ext cx="10515600" cy="1280160"/>
+          <p:cNvPr id="2" name="Rectangle 1"/>
+          <p:cNvSpPr/>
+          <p:nvPr/>
+        </p:nvSpPr>
+        <p:spPr>
+          <a:xfrm>
+            <a:off x="0" y="0"/>
+            <a:ext cx="12191695" cy="6858000"/>
           </a:xfrm>
           <a:prstGeom prst="rect">
             <a:avLst/>
           </a:prstGeom>
-          <a:noFill/>
-        </p:spPr>
-        <p:txBody>
-          <a:bodyPr wrap="square">
-            <a:spAutoFit/>
-          </a:bodyPr>
-          <a:lstStyle/>
-          <a:p>
-            <a:pPr algn="l">
-              <a:defRPr sz="5200" b="1">
-                <a:solidFill>
-                  <a:srgbClr val="FAFAFA"/>
-                </a:solidFill>
-              </a:defRPr>
-            </a:pPr>
-            <a:r>
-              <a:t>Friday</a:t>
-            </a:r>
+          <a:solidFill>
+            <a:srgbClr val="0B0B0C"/>
+          </a:solidFill>
+          <a:ln>
+            <a:noFill/>
+          </a:ln>
+        </p:spPr>
+        <p:style>
+          <a:lnRef idx="1">
+            <a:schemeClr val="accent1"/>
+          </a:lnRef>
+          <a:fillRef idx="3">
+            <a:schemeClr val="accent1"/>
+          </a:fillRef>
+          <a:effectRef idx="2">
+            <a:schemeClr val="accent1"/>
+          </a:effectRef>
+          <a:fontRef idx="minor">
+            <a:schemeClr val="lt1"/>
+          </a:fontRef>
+        </p:style>
+        <p:txBody>
+          <a:bodyPr rtlCol="0" anchor="ctr"/>
+          <a:lstStyle/>
+          <a:p>
+            <a:pPr algn="ctr"/>
           </a:p>
         </p:txBody>
       </p:sp>
@@ -3151,8 +3149,8 @@
         </p:nvSpPr>
         <p:spPr>
           <a:xfrm>
-            <a:off x="685800" y="3063240"/>
-            <a:ext cx="10515600" cy="1097280"/>
+            <a:off x="548640" y="1965960"/>
+            <a:ext cx="10972800" cy="822960"/>
           </a:xfrm>
           <a:prstGeom prst="rect">
             <a:avLst/>
@@ -3160,20 +3158,87 @@
           <a:noFill/>
         </p:spPr>
         <p:txBody>
-          <a:bodyPr wrap="none">
-            <a:spAutoFit/>
-          </a:bodyPr>
-          <a:lstStyle/>
-          <a:p>
-            <a:pPr>
-              <a:defRPr sz="2400">
+          <a:bodyPr wrap="square"/>
+          <a:lstStyle/>
+          <a:p>
+            <a:pPr algn="l">
+              <a:defRPr sz="6000" b="1">
+                <a:solidFill>
+                  <a:srgbClr val="FAFAFA"/>
+                </a:solidFill>
+                <a:latin typeface="Calibri"/>
+              </a:defRPr>
+            </a:pPr>
+            <a:r>
+              <a:t>FRIDAY</a:t>
+            </a:r>
+          </a:p>
+        </p:txBody>
+      </p:sp>
+      <p:sp>
+        <p:nvSpPr>
+          <p:cNvPr id="4" name="TextBox 3"/>
+          <p:cNvSpPr txBox="1"/>
+          <p:nvPr/>
+        </p:nvSpPr>
+        <p:spPr>
+          <a:xfrm>
+            <a:off x="548640" y="2926080"/>
+            <a:ext cx="10058400" cy="822960"/>
+          </a:xfrm>
+          <a:prstGeom prst="rect">
+            <a:avLst/>
+          </a:prstGeom>
+          <a:noFill/>
+        </p:spPr>
+        <p:txBody>
+          <a:bodyPr wrap="square"/>
+          <a:lstStyle/>
+          <a:p>
+            <a:pPr algn="l">
+              <a:defRPr sz="2400" b="0">
                 <a:solidFill>
                   <a:srgbClr val="A1A1AA"/>
                 </a:solidFill>
-              </a:defRPr>
-            </a:pPr>
-            <a:r>
-              <a:t>Stay in control when code—and threats—move faster than review.</a:t>
+                <a:latin typeface="Calibri"/>
+              </a:defRPr>
+            </a:pPr>
+            <a:r>
+              <a:t>Stay in control when code — and threats — move faster than review.</a:t>
+            </a:r>
+          </a:p>
+        </p:txBody>
+      </p:sp>
+      <p:sp>
+        <p:nvSpPr>
+          <p:cNvPr id="5" name="TextBox 4"/>
+          <p:cNvSpPr txBox="1"/>
+          <p:nvPr/>
+        </p:nvSpPr>
+        <p:spPr>
+          <a:xfrm>
+            <a:off x="548640" y="3931920"/>
+            <a:ext cx="9144000" cy="365760"/>
+          </a:xfrm>
+          <a:prstGeom prst="rect">
+            <a:avLst/>
+          </a:prstGeom>
+          <a:noFill/>
+        </p:spPr>
+        <p:txBody>
+          <a:bodyPr wrap="square"/>
+          <a:lstStyle/>
+          <a:p>
+            <a:pPr algn="l">
+              <a:defRPr sz="1800" b="0">
+                <a:solidFill>
+                  <a:srgbClr val="F97316"/>
+                </a:solidFill>
+                <a:latin typeface="Calibri"/>
+              </a:defRPr>
+            </a:pPr>
+            <a:r>
+              <a:t>Voice-first control surface for the repo you already have open.</a:t>
             </a:r>
           </a:p>
         </p:txBody>
@@ -3189,14 +3254,6 @@
 <file path=ppt/slides/slide10.xml><?xml version="1.0" encoding="utf-8"?>
 <p:sld xmlns:a="http://schemas.openxmlformats.org/drawingml/2006/main" xmlns:p="http://schemas.openxmlformats.org/presentationml/2006/main" xmlns:r="http://schemas.openxmlformats.org/officeDocument/2006/relationships">
   <p:cSld>
-    <p:bg>
-      <p:bgPr>
-        <a:solidFill>
-          <a:srgbClr val="0A0A0A"/>
-        </a:solidFill>
-        <a:effectLst/>
-      </p:bgPr>
-    </p:bg>
     <p:spTree>
       <p:nvGrpSpPr>
         <p:cNvPr id="1" name=""/>
@@ -3206,14 +3263,57 @@
       <p:grpSpPr/>
       <p:sp>
         <p:nvSpPr>
-          <p:cNvPr id="2" name="TextBox 1"/>
+          <p:cNvPr id="2" name="Rectangle 1"/>
+          <p:cNvSpPr/>
+          <p:nvPr/>
+        </p:nvSpPr>
+        <p:spPr>
+          <a:xfrm>
+            <a:off x="0" y="0"/>
+            <a:ext cx="12191695" cy="6858000"/>
+          </a:xfrm>
+          <a:prstGeom prst="rect">
+            <a:avLst/>
+          </a:prstGeom>
+          <a:solidFill>
+            <a:srgbClr val="0B0B0C"/>
+          </a:solidFill>
+          <a:ln>
+            <a:noFill/>
+          </a:ln>
+        </p:spPr>
+        <p:style>
+          <a:lnRef idx="1">
+            <a:schemeClr val="accent1"/>
+          </a:lnRef>
+          <a:fillRef idx="3">
+            <a:schemeClr val="accent1"/>
+          </a:fillRef>
+          <a:effectRef idx="2">
+            <a:schemeClr val="accent1"/>
+          </a:effectRef>
+          <a:fontRef idx="minor">
+            <a:schemeClr val="lt1"/>
+          </a:fontRef>
+        </p:style>
+        <p:txBody>
+          <a:bodyPr rtlCol="0" anchor="ctr"/>
+          <a:lstStyle/>
+          <a:p>
+            <a:pPr algn="ctr"/>
+          </a:p>
+        </p:txBody>
+      </p:sp>
+      <p:sp>
+        <p:nvSpPr>
+          <p:cNvPr id="3" name="TextBox 2"/>
           <p:cNvSpPr txBox="1"/>
           <p:nvPr/>
         </p:nvSpPr>
         <p:spPr>
           <a:xfrm>
-            <a:off x="685800" y="502920"/>
-            <a:ext cx="10515600" cy="1280160"/>
+            <a:off x="502920" y="292608"/>
+            <a:ext cx="7315200" cy="292608"/>
           </a:xfrm>
           <a:prstGeom prst="rect">
             <a:avLst/>
@@ -3221,34 +3321,67 @@
           <a:noFill/>
         </p:spPr>
         <p:txBody>
-          <a:bodyPr wrap="square">
-            <a:spAutoFit/>
-          </a:bodyPr>
+          <a:bodyPr wrap="square"/>
+          <a:lstStyle/>
+          <a:p>
+            <a:pPr algn="l">
+              <a:defRPr sz="1200" b="1">
+                <a:solidFill>
+                  <a:srgbClr val="F97316"/>
+                </a:solidFill>
+                <a:latin typeface="Calibri"/>
+              </a:defRPr>
+            </a:pPr>
+            <a:r>
+              <a:t>DEMO SCRIPT · 90 SECONDS</a:t>
+            </a:r>
+          </a:p>
+        </p:txBody>
+      </p:sp>
+      <p:sp>
+        <p:nvSpPr>
+          <p:cNvPr id="4" name="TextBox 3"/>
+          <p:cNvSpPr txBox="1"/>
+          <p:nvPr/>
+        </p:nvSpPr>
+        <p:spPr>
+          <a:xfrm>
+            <a:off x="502920" y="566928"/>
+            <a:ext cx="11155680" cy="640080"/>
+          </a:xfrm>
+          <a:prstGeom prst="rect">
+            <a:avLst/>
+          </a:prstGeom>
+          <a:noFill/>
+        </p:spPr>
+        <p:txBody>
+          <a:bodyPr wrap="square"/>
           <a:lstStyle/>
           <a:p>
             <a:pPr algn="l">
               <a:defRPr sz="3200" b="1">
                 <a:solidFill>
-                  <a:srgbClr val="F97316"/>
-                </a:solidFill>
-              </a:defRPr>
-            </a:pPr>
-            <a:r>
-              <a:t>Stack</a:t>
-            </a:r>
-          </a:p>
-        </p:txBody>
-      </p:sp>
-      <p:sp>
-        <p:nvSpPr>
-          <p:cNvPr id="3" name="TextBox 2"/>
+                  <a:srgbClr val="FAFAFA"/>
+                </a:solidFill>
+                <a:latin typeface="Calibri"/>
+              </a:defRPr>
+            </a:pPr>
+            <a:r>
+              <a:t>Show the map. Then the consent.</a:t>
+            </a:r>
+          </a:p>
+        </p:txBody>
+      </p:sp>
+      <p:sp>
+        <p:nvSpPr>
+          <p:cNvPr id="5" name="TextBox 4"/>
           <p:cNvSpPr txBox="1"/>
           <p:nvPr/>
         </p:nvSpPr>
         <p:spPr>
           <a:xfrm>
-            <a:off x="777240" y="1325880"/>
-            <a:ext cx="10241280" cy="4754880"/>
+            <a:off x="640080" y="1554480"/>
+            <a:ext cx="10972800" cy="640080"/>
           </a:xfrm>
           <a:prstGeom prst="rect">
             <a:avLst/>
@@ -3256,53 +3389,155 @@
           <a:noFill/>
         </p:spPr>
         <p:txBody>
-          <a:bodyPr wrap="square">
-            <a:spAutoFit/>
-          </a:bodyPr>
-          <a:lstStyle/>
-          <a:p>
-            <a:pPr>
-              <a:spcAft>
-                <a:spcPts val="1400"/>
-              </a:spcAft>
-              <a:defRPr sz="2000">
+          <a:bodyPr wrap="square"/>
+          <a:lstStyle/>
+          <a:p>
+            <a:pPr algn="l">
+              <a:defRPr sz="2200" b="0">
                 <a:solidFill>
                   <a:srgbClr val="FAFAFA"/>
                 </a:solidFill>
-              </a:defRPr>
-            </a:pPr>
-            <a:r>
-              <a:t>FastAPI · AssemblyAI Voice + STT + LLM Gateway</a:t>
-            </a:r>
-          </a:p>
-          <a:p>
-            <a:pPr>
-              <a:spcAft>
-                <a:spcPts val="1400"/>
-              </a:spcAft>
-              <a:defRPr sz="2000">
+                <a:latin typeface="Calibri"/>
+              </a:defRPr>
+            </a:pPr>
+            <a:r>
+              <a:t>1   Open the live URL with ?repo=owner/name. Point at hotspots.</a:t>
+            </a:r>
+          </a:p>
+        </p:txBody>
+      </p:sp>
+      <p:sp>
+        <p:nvSpPr>
+          <p:cNvPr id="6" name="TextBox 5"/>
+          <p:cNvSpPr txBox="1"/>
+          <p:nvPr/>
+        </p:nvSpPr>
+        <p:spPr>
+          <a:xfrm>
+            <a:off x="640080" y="2331720"/>
+            <a:ext cx="10972800" cy="640080"/>
+          </a:xfrm>
+          <a:prstGeom prst="rect">
+            <a:avLst/>
+          </a:prstGeom>
+          <a:noFill/>
+        </p:spPr>
+        <p:txBody>
+          <a:bodyPr wrap="square"/>
+          <a:lstStyle/>
+          <a:p>
+            <a:pPr algn="l">
+              <a:defRPr sz="2200" b="0">
                 <a:solidFill>
                   <a:srgbClr val="FAFAFA"/>
                 </a:solidFill>
-              </a:defRPr>
-            </a:pPr>
-            <a:r>
-              <a:t>GitHub REST / OAuth · D3 map ingest</a:t>
-            </a:r>
-          </a:p>
-          <a:p>
-            <a:pPr>
-              <a:spcAft>
-                <a:spcPts val="1400"/>
-              </a:spcAft>
-              <a:defRPr sz="2000">
+                <a:latin typeface="Calibri"/>
+              </a:defRPr>
+            </a:pPr>
+            <a:r>
+              <a:t>2   “Explain the landmarks.” Then “What changed in the latest commit?”</a:t>
+            </a:r>
+          </a:p>
+        </p:txBody>
+      </p:sp>
+      <p:sp>
+        <p:nvSpPr>
+          <p:cNvPr id="7" name="TextBox 6"/>
+          <p:cNvSpPr txBox="1"/>
+          <p:nvPr/>
+        </p:nvSpPr>
+        <p:spPr>
+          <a:xfrm>
+            <a:off x="640080" y="3108960"/>
+            <a:ext cx="10972800" cy="640080"/>
+          </a:xfrm>
+          <a:prstGeom prst="rect">
+            <a:avLst/>
+          </a:prstGeom>
+          <a:noFill/>
+        </p:spPr>
+        <p:txBody>
+          <a:bodyPr wrap="square"/>
+          <a:lstStyle/>
+          <a:p>
+            <a:pPr algn="l">
+              <a:defRPr sz="2200" b="0">
                 <a:solidFill>
                   <a:srgbClr val="FAFAFA"/>
                 </a:solidFill>
-              </a:defRPr>
-            </a:pPr>
-            <a:r>
-              <a:t>Deployed on Google Cloud Run</a:t>
+                <a:latin typeface="Calibri"/>
+              </a:defRPr>
+            </a:pPr>
+            <a:r>
+              <a:t>3   “Scan this repository for security issues.”</a:t>
+            </a:r>
+          </a:p>
+        </p:txBody>
+      </p:sp>
+      <p:sp>
+        <p:nvSpPr>
+          <p:cNvPr id="8" name="TextBox 7"/>
+          <p:cNvSpPr txBox="1"/>
+          <p:nvPr/>
+        </p:nvSpPr>
+        <p:spPr>
+          <a:xfrm>
+            <a:off x="640080" y="3886200"/>
+            <a:ext cx="10972800" cy="640080"/>
+          </a:xfrm>
+          <a:prstGeom prst="rect">
+            <a:avLst/>
+          </a:prstGeom>
+          <a:noFill/>
+        </p:spPr>
+        <p:txBody>
+          <a:bodyPr wrap="square"/>
+          <a:lstStyle/>
+          <a:p>
+            <a:pPr algn="l">
+              <a:defRPr sz="2200" b="0">
+                <a:solidFill>
+                  <a:srgbClr val="FAFAFA"/>
+                </a:solidFill>
+                <a:latin typeface="Calibri"/>
+              </a:defRPr>
+            </a:pPr>
+            <a:r>
+              <a:t>4   “Open an issue titled Friday demo.” Show the draft. Do not post yet.</a:t>
+            </a:r>
+          </a:p>
+        </p:txBody>
+      </p:sp>
+      <p:sp>
+        <p:nvSpPr>
+          <p:cNvPr id="9" name="TextBox 8"/>
+          <p:cNvSpPr txBox="1"/>
+          <p:nvPr/>
+        </p:nvSpPr>
+        <p:spPr>
+          <a:xfrm>
+            <a:off x="640080" y="4663440"/>
+            <a:ext cx="10972800" cy="640080"/>
+          </a:xfrm>
+          <a:prstGeom prst="rect">
+            <a:avLst/>
+          </a:prstGeom>
+          <a:noFill/>
+        </p:spPr>
+        <p:txBody>
+          <a:bodyPr wrap="square"/>
+          <a:lstStyle/>
+          <a:p>
+            <a:pPr algn="l">
+              <a:defRPr sz="2200" b="0">
+                <a:solidFill>
+                  <a:srgbClr val="FAFAFA"/>
+                </a:solidFill>
+                <a:latin typeface="Calibri"/>
+              </a:defRPr>
+            </a:pPr>
+            <a:r>
+              <a:t>5   Next turn: “yes.” Show the GitHub link.</a:t>
             </a:r>
           </a:p>
         </p:txBody>
@@ -3318,14 +3553,6 @@
 <file path=ppt/slides/slide11.xml><?xml version="1.0" encoding="utf-8"?>
 <p:sld xmlns:a="http://schemas.openxmlformats.org/drawingml/2006/main" xmlns:p="http://schemas.openxmlformats.org/presentationml/2006/main" xmlns:r="http://schemas.openxmlformats.org/officeDocument/2006/relationships">
   <p:cSld>
-    <p:bg>
-      <p:bgPr>
-        <a:solidFill>
-          <a:srgbClr val="0A0A0A"/>
-        </a:solidFill>
-        <a:effectLst/>
-      </p:bgPr>
-    </p:bg>
     <p:spTree>
       <p:nvGrpSpPr>
         <p:cNvPr id="1" name=""/>
@@ -3335,14 +3562,57 @@
       <p:grpSpPr/>
       <p:sp>
         <p:nvSpPr>
-          <p:cNvPr id="2" name="TextBox 1"/>
+          <p:cNvPr id="2" name="Rectangle 1"/>
+          <p:cNvSpPr/>
+          <p:nvPr/>
+        </p:nvSpPr>
+        <p:spPr>
+          <a:xfrm>
+            <a:off x="0" y="0"/>
+            <a:ext cx="12191695" cy="6858000"/>
+          </a:xfrm>
+          <a:prstGeom prst="rect">
+            <a:avLst/>
+          </a:prstGeom>
+          <a:solidFill>
+            <a:srgbClr val="0B0B0C"/>
+          </a:solidFill>
+          <a:ln>
+            <a:noFill/>
+          </a:ln>
+        </p:spPr>
+        <p:style>
+          <a:lnRef idx="1">
+            <a:schemeClr val="accent1"/>
+          </a:lnRef>
+          <a:fillRef idx="3">
+            <a:schemeClr val="accent1"/>
+          </a:fillRef>
+          <a:effectRef idx="2">
+            <a:schemeClr val="accent1"/>
+          </a:effectRef>
+          <a:fontRef idx="minor">
+            <a:schemeClr val="lt1"/>
+          </a:fontRef>
+        </p:style>
+        <p:txBody>
+          <a:bodyPr rtlCol="0" anchor="ctr"/>
+          <a:lstStyle/>
+          <a:p>
+            <a:pPr algn="ctr"/>
+          </a:p>
+        </p:txBody>
+      </p:sp>
+      <p:sp>
+        <p:nvSpPr>
+          <p:cNvPr id="3" name="TextBox 2"/>
           <p:cNvSpPr txBox="1"/>
           <p:nvPr/>
         </p:nvSpPr>
         <p:spPr>
           <a:xfrm>
-            <a:off x="685800" y="1828800"/>
-            <a:ext cx="10515600" cy="1280160"/>
+            <a:off x="502920" y="292608"/>
+            <a:ext cx="7315200" cy="292608"/>
           </a:xfrm>
           <a:prstGeom prst="rect">
             <a:avLst/>
@@ -3350,9 +3620,109 @@
           <a:noFill/>
         </p:spPr>
         <p:txBody>
-          <a:bodyPr wrap="square">
-            <a:spAutoFit/>
-          </a:bodyPr>
+          <a:bodyPr wrap="square"/>
+          <a:lstStyle/>
+          <a:p>
+            <a:pPr algn="l">
+              <a:defRPr sz="1200" b="1">
+                <a:solidFill>
+                  <a:srgbClr val="F97316"/>
+                </a:solidFill>
+                <a:latin typeface="Calibri"/>
+              </a:defRPr>
+            </a:pPr>
+            <a:r>
+              <a:t>WHY NOW</a:t>
+            </a:r>
+          </a:p>
+        </p:txBody>
+      </p:sp>
+      <p:sp>
+        <p:nvSpPr>
+          <p:cNvPr id="4" name="TextBox 3"/>
+          <p:cNvSpPr txBox="1"/>
+          <p:nvPr/>
+        </p:nvSpPr>
+        <p:spPr>
+          <a:xfrm>
+            <a:off x="502920" y="566928"/>
+            <a:ext cx="11155680" cy="640080"/>
+          </a:xfrm>
+          <a:prstGeom prst="rect">
+            <a:avLst/>
+          </a:prstGeom>
+          <a:noFill/>
+        </p:spPr>
+        <p:txBody>
+          <a:bodyPr wrap="square"/>
+          <a:lstStyle/>
+          <a:p>
+            <a:pPr algn="l">
+              <a:defRPr sz="3200" b="1">
+                <a:solidFill>
+                  <a:srgbClr val="FAFAFA"/>
+                </a:solidFill>
+                <a:latin typeface="Calibri"/>
+              </a:defRPr>
+            </a:pPr>
+            <a:r>
+              <a:t>The approval window is narrowing.</a:t>
+            </a:r>
+          </a:p>
+        </p:txBody>
+      </p:sp>
+      <p:sp>
+        <p:nvSpPr>
+          <p:cNvPr id="5" name="TextBox 4"/>
+          <p:cNvSpPr txBox="1"/>
+          <p:nvPr/>
+        </p:nvSpPr>
+        <p:spPr>
+          <a:xfrm>
+            <a:off x="502920" y="1554480"/>
+            <a:ext cx="10972800" cy="1280160"/>
+          </a:xfrm>
+          <a:prstGeom prst="rect">
+            <a:avLst/>
+          </a:prstGeom>
+          <a:noFill/>
+        </p:spPr>
+        <p:txBody>
+          <a:bodyPr wrap="square"/>
+          <a:lstStyle/>
+          <a:p>
+            <a:pPr algn="l">
+              <a:defRPr sz="2200" b="0">
+                <a:solidFill>
+                  <a:srgbClr val="FAFAFA"/>
+                </a:solidFill>
+                <a:latin typeface="Calibri"/>
+              </a:defRPr>
+            </a:pPr>
+            <a:r>
+              <a:t>We can keep generating faster than we understand. Or we can put a map, a voice, and a hard yes in front of every action that leaves the building.</a:t>
+            </a:r>
+          </a:p>
+        </p:txBody>
+      </p:sp>
+      <p:sp>
+        <p:nvSpPr>
+          <p:cNvPr id="6" name="TextBox 5"/>
+          <p:cNvSpPr txBox="1"/>
+          <p:nvPr/>
+        </p:nvSpPr>
+        <p:spPr>
+          <a:xfrm>
+            <a:off x="502920" y="3291840"/>
+            <a:ext cx="10972800" cy="640080"/>
+          </a:xfrm>
+          <a:prstGeom prst="rect">
+            <a:avLst/>
+          </a:prstGeom>
+          <a:noFill/>
+        </p:spPr>
+        <p:txBody>
+          <a:bodyPr wrap="square"/>
           <a:lstStyle/>
           <a:p>
             <a:pPr algn="l">
@@ -3360,24 +3730,25 @@
                 <a:solidFill>
                   <a:srgbClr val="F97316"/>
                 </a:solidFill>
-              </a:defRPr>
-            </a:pPr>
-            <a:r>
-              <a:t>Try it</a:t>
-            </a:r>
-          </a:p>
-        </p:txBody>
-      </p:sp>
-      <p:sp>
-        <p:nvSpPr>
-          <p:cNvPr id="3" name="TextBox 2"/>
+                <a:latin typeface="Calibri"/>
+              </a:defRPr>
+            </a:pPr>
+            <a:r>
+              <a:t>Friday</a:t>
+            </a:r>
+          </a:p>
+        </p:txBody>
+      </p:sp>
+      <p:sp>
+        <p:nvSpPr>
+          <p:cNvPr id="7" name="TextBox 6"/>
           <p:cNvSpPr txBox="1"/>
           <p:nvPr/>
         </p:nvSpPr>
         <p:spPr>
           <a:xfrm>
-            <a:off x="685800" y="2743200"/>
-            <a:ext cx="10515600" cy="1097280"/>
+            <a:off x="502920" y="4114800"/>
+            <a:ext cx="10972800" cy="365760"/>
           </a:xfrm>
           <a:prstGeom prst="rect">
             <a:avLst/>
@@ -3385,225 +3756,53 @@
           <a:noFill/>
         </p:spPr>
         <p:txBody>
-          <a:bodyPr wrap="none">
-            <a:spAutoFit/>
-          </a:bodyPr>
-          <a:lstStyle/>
-          <a:p>
-            <a:pPr>
-              <a:defRPr sz="2000">
+          <a:bodyPr wrap="square"/>
+          <a:lstStyle/>
+          <a:p>
+            <a:pPr algn="l">
+              <a:defRPr sz="2000" b="0">
+                <a:solidFill>
+                  <a:srgbClr val="FAFAFA"/>
+                </a:solidFill>
+                <a:latin typeface="Calibri"/>
+              </a:defRPr>
+            </a:pPr>
+            <a:r>
+              <a:t>github.com/hatif03/friday-voice-agent</a:t>
+            </a:r>
+          </a:p>
+        </p:txBody>
+      </p:sp>
+      <p:sp>
+        <p:nvSpPr>
+          <p:cNvPr id="8" name="TextBox 7"/>
+          <p:cNvSpPr txBox="1"/>
+          <p:nvPr/>
+        </p:nvSpPr>
+        <p:spPr>
+          <a:xfrm>
+            <a:off x="502920" y="4663440"/>
+            <a:ext cx="10972800" cy="365760"/>
+          </a:xfrm>
+          <a:prstGeom prst="rect">
+            <a:avLst/>
+          </a:prstGeom>
+          <a:noFill/>
+        </p:spPr>
+        <p:txBody>
+          <a:bodyPr wrap="square"/>
+          <a:lstStyle/>
+          <a:p>
+            <a:pPr algn="l">
+              <a:defRPr sz="1800" b="0">
                 <a:solidFill>
                   <a:srgbClr val="A1A1AA"/>
                 </a:solidFill>
-              </a:defRPr>
-            </a:pPr>
-            <a:r>
-              <a:t>https://friday-voice-agent-147606977567.us-central1.run.app</a:t>
-            </a:r>
-            <a:br/>
-            <a:r>
-              <a:t>?repo=owner/name</a:t>
-            </a:r>
-            <a:br/>
-            <a:br/>
-            <a:r>
-              <a:t>Hold the mic · Explain the map · Check the latest commit</a:t>
-            </a:r>
-          </a:p>
-        </p:txBody>
-      </p:sp>
-    </p:spTree>
-  </p:cSld>
-  <p:clrMapOvr>
-    <a:masterClrMapping/>
-  </p:clrMapOvr>
-</p:sld>
-</file>
-
-<file path=ppt/slides/slide12.xml><?xml version="1.0" encoding="utf-8"?>
-<p:sld xmlns:a="http://schemas.openxmlformats.org/drawingml/2006/main" xmlns:p="http://schemas.openxmlformats.org/presentationml/2006/main" xmlns:r="http://schemas.openxmlformats.org/officeDocument/2006/relationships">
-  <p:cSld>
-    <p:bg>
-      <p:bgPr>
-        <a:solidFill>
-          <a:srgbClr val="0A0A0A"/>
-        </a:solidFill>
-        <a:effectLst/>
-      </p:bgPr>
-    </p:bg>
-    <p:spTree>
-      <p:nvGrpSpPr>
-        <p:cNvPr id="1" name=""/>
-        <p:cNvGrpSpPr/>
-        <p:nvPr/>
-      </p:nvGrpSpPr>
-      <p:grpSpPr/>
-      <p:sp>
-        <p:nvSpPr>
-          <p:cNvPr id="2" name="TextBox 1"/>
-          <p:cNvSpPr txBox="1"/>
-          <p:nvPr/>
-        </p:nvSpPr>
-        <p:spPr>
-          <a:xfrm>
-            <a:off x="685800" y="1737360"/>
-            <a:ext cx="10515600" cy="1280160"/>
-          </a:xfrm>
-          <a:prstGeom prst="rect">
-            <a:avLst/>
-          </a:prstGeom>
-          <a:noFill/>
-        </p:spPr>
-        <p:txBody>
-          <a:bodyPr wrap="square">
-            <a:spAutoFit/>
-          </a:bodyPr>
-          <a:lstStyle/>
-          <a:p>
-            <a:pPr algn="l">
-              <a:defRPr sz="3600" b="1">
-                <a:solidFill>
-                  <a:srgbClr val="FAFAFA"/>
-                </a:solidFill>
-              </a:defRPr>
-            </a:pPr>
-            <a:r>
-              <a:t>Why now</a:t>
-            </a:r>
-          </a:p>
-        </p:txBody>
-      </p:sp>
-      <p:sp>
-        <p:nvSpPr>
-          <p:cNvPr id="3" name="TextBox 2"/>
-          <p:cNvSpPr txBox="1"/>
-          <p:nvPr/>
-        </p:nvSpPr>
-        <p:spPr>
-          <a:xfrm>
-            <a:off x="685800" y="2743200"/>
-            <a:ext cx="10515600" cy="1097280"/>
-          </a:xfrm>
-          <a:prstGeom prst="rect">
-            <a:avLst/>
-          </a:prstGeom>
-          <a:noFill/>
-        </p:spPr>
-        <p:txBody>
-          <a:bodyPr wrap="none">
-            <a:spAutoFit/>
-          </a:bodyPr>
-          <a:lstStyle/>
-          <a:p>
-            <a:pPr>
-              <a:defRPr sz="2200">
-                <a:solidFill>
-                  <a:srgbClr val="A1A1AA"/>
-                </a:solidFill>
-              </a:defRPr>
-            </a:pPr>
-            <a:r>
-              <a:t>The window where humans still approve what ships is narrowing.</a:t>
-            </a:r>
-            <a:br/>
-            <a:r>
-              <a:t>Friday is how you keep orientation and consent in that window.</a:t>
-            </a:r>
-          </a:p>
-        </p:txBody>
-      </p:sp>
-    </p:spTree>
-  </p:cSld>
-  <p:clrMapOvr>
-    <a:masterClrMapping/>
-  </p:clrMapOvr>
-</p:sld>
-</file>
-
-<file path=ppt/slides/slide13.xml><?xml version="1.0" encoding="utf-8"?>
-<p:sld xmlns:a="http://schemas.openxmlformats.org/drawingml/2006/main" xmlns:p="http://schemas.openxmlformats.org/presentationml/2006/main" xmlns:r="http://schemas.openxmlformats.org/officeDocument/2006/relationships">
-  <p:cSld>
-    <p:bg>
-      <p:bgPr>
-        <a:solidFill>
-          <a:srgbClr val="0A0A0A"/>
-        </a:solidFill>
-        <a:effectLst/>
-      </p:bgPr>
-    </p:bg>
-    <p:spTree>
-      <p:nvGrpSpPr>
-        <p:cNvPr id="1" name=""/>
-        <p:cNvGrpSpPr/>
-        <p:nvPr/>
-      </p:nvGrpSpPr>
-      <p:grpSpPr/>
-      <p:sp>
-        <p:nvSpPr>
-          <p:cNvPr id="2" name="TextBox 1"/>
-          <p:cNvSpPr txBox="1"/>
-          <p:nvPr/>
-        </p:nvSpPr>
-        <p:spPr>
-          <a:xfrm>
-            <a:off x="685800" y="2286000"/>
-            <a:ext cx="10515600" cy="1280160"/>
-          </a:xfrm>
-          <a:prstGeom prst="rect">
-            <a:avLst/>
-          </a:prstGeom>
-          <a:noFill/>
-        </p:spPr>
-        <p:txBody>
-          <a:bodyPr wrap="square">
-            <a:spAutoFit/>
-          </a:bodyPr>
-          <a:lstStyle/>
-          <a:p>
-            <a:pPr algn="l">
-              <a:defRPr sz="4800" b="1">
-                <a:solidFill>
-                  <a:srgbClr val="FAFAFA"/>
-                </a:solidFill>
-              </a:defRPr>
-            </a:pPr>
-            <a:r>
-              <a:t>Friday</a:t>
-            </a:r>
-          </a:p>
-        </p:txBody>
-      </p:sp>
-      <p:sp>
-        <p:nvSpPr>
-          <p:cNvPr id="3" name="TextBox 2"/>
-          <p:cNvSpPr txBox="1"/>
-          <p:nvPr/>
-        </p:nvSpPr>
-        <p:spPr>
-          <a:xfrm>
-            <a:off x="685800" y="3108960"/>
-            <a:ext cx="10515600" cy="1097280"/>
-          </a:xfrm>
-          <a:prstGeom prst="rect">
-            <a:avLst/>
-          </a:prstGeom>
-          <a:noFill/>
-        </p:spPr>
-        <p:txBody>
-          <a:bodyPr wrap="none">
-            <a:spAutoFit/>
-          </a:bodyPr>
-          <a:lstStyle/>
-          <a:p>
-            <a:pPr>
-              <a:defRPr sz="2200">
-                <a:solidFill>
-                  <a:srgbClr val="A1A1AA"/>
-                </a:solidFill>
-              </a:defRPr>
-            </a:pPr>
-            <a:r>
-              <a:t>github.com/hatif03/friday-voice-agent</a:t>
+                <a:latin typeface="Calibri"/>
+              </a:defRPr>
+            </a:pPr>
+            <a:r>
+              <a:t>friday-voice-agent-147606977567.us-central1.run.app</a:t>
             </a:r>
           </a:p>
         </p:txBody>
@@ -3619,14 +3818,6 @@
 <file path=ppt/slides/slide2.xml><?xml version="1.0" encoding="utf-8"?>
 <p:sld xmlns:a="http://schemas.openxmlformats.org/drawingml/2006/main" xmlns:p="http://schemas.openxmlformats.org/presentationml/2006/main" xmlns:r="http://schemas.openxmlformats.org/officeDocument/2006/relationships">
   <p:cSld>
-    <p:bg>
-      <p:bgPr>
-        <a:solidFill>
-          <a:srgbClr val="0A0A0A"/>
-        </a:solidFill>
-        <a:effectLst/>
-      </p:bgPr>
-    </p:bg>
     <p:spTree>
       <p:nvGrpSpPr>
         <p:cNvPr id="1" name=""/>
@@ -3636,36 +3827,44 @@
       <p:grpSpPr/>
       <p:sp>
         <p:nvSpPr>
-          <p:cNvPr id="2" name="TextBox 1"/>
-          <p:cNvSpPr txBox="1"/>
-          <p:nvPr/>
-        </p:nvSpPr>
-        <p:spPr>
-          <a:xfrm>
-            <a:off x="685800" y="1828800"/>
-            <a:ext cx="10515600" cy="1280160"/>
+          <p:cNvPr id="2" name="Rectangle 1"/>
+          <p:cNvSpPr/>
+          <p:nvPr/>
+        </p:nvSpPr>
+        <p:spPr>
+          <a:xfrm>
+            <a:off x="0" y="0"/>
+            <a:ext cx="12191695" cy="6858000"/>
           </a:xfrm>
           <a:prstGeom prst="rect">
             <a:avLst/>
           </a:prstGeom>
-          <a:noFill/>
-        </p:spPr>
-        <p:txBody>
-          <a:bodyPr wrap="square">
-            <a:spAutoFit/>
-          </a:bodyPr>
-          <a:lstStyle/>
-          <a:p>
-            <a:pPr algn="l">
-              <a:defRPr sz="3800" b="1">
-                <a:solidFill>
-                  <a:srgbClr val="FAFAFA"/>
-                </a:solidFill>
-              </a:defRPr>
-            </a:pPr>
-            <a:r>
-              <a:t>We are in an existential squeeze.</a:t>
-            </a:r>
+          <a:solidFill>
+            <a:srgbClr val="0B0B0C"/>
+          </a:solidFill>
+          <a:ln>
+            <a:noFill/>
+          </a:ln>
+        </p:spPr>
+        <p:style>
+          <a:lnRef idx="1">
+            <a:schemeClr val="accent1"/>
+          </a:lnRef>
+          <a:fillRef idx="3">
+            <a:schemeClr val="accent1"/>
+          </a:fillRef>
+          <a:effectRef idx="2">
+            <a:schemeClr val="accent1"/>
+          </a:effectRef>
+          <a:fontRef idx="minor">
+            <a:schemeClr val="lt1"/>
+          </a:fontRef>
+        </p:style>
+        <p:txBody>
+          <a:bodyPr rtlCol="0" anchor="ctr"/>
+          <a:lstStyle/>
+          <a:p>
+            <a:pPr algn="ctr"/>
           </a:p>
         </p:txBody>
       </p:sp>
@@ -3677,8 +3876,8 @@
         </p:nvSpPr>
         <p:spPr>
           <a:xfrm>
-            <a:off x="685800" y="2926080"/>
-            <a:ext cx="10515600" cy="1097280"/>
+            <a:off x="502920" y="292608"/>
+            <a:ext cx="7315200" cy="292608"/>
           </a:xfrm>
           <a:prstGeom prst="rect">
             <a:avLst/>
@@ -3686,28 +3885,364 @@
           <a:noFill/>
         </p:spPr>
         <p:txBody>
-          <a:bodyPr wrap="none">
-            <a:spAutoFit/>
-          </a:bodyPr>
-          <a:lstStyle/>
+          <a:bodyPr wrap="square"/>
+          <a:lstStyle/>
+          <a:p>
+            <a:pPr algn="l">
+              <a:defRPr sz="1200" b="1">
+                <a:solidFill>
+                  <a:srgbClr val="F97316"/>
+                </a:solidFill>
+                <a:latin typeface="Calibri"/>
+              </a:defRPr>
+            </a:pPr>
+            <a:r>
+              <a:t>THE MOMENT</a:t>
+            </a:r>
+          </a:p>
+        </p:txBody>
+      </p:sp>
+      <p:sp>
+        <p:nvSpPr>
+          <p:cNvPr id="4" name="TextBox 3"/>
+          <p:cNvSpPr txBox="1"/>
+          <p:nvPr/>
+        </p:nvSpPr>
+        <p:spPr>
+          <a:xfrm>
+            <a:off x="502920" y="566928"/>
+            <a:ext cx="11155680" cy="640080"/>
+          </a:xfrm>
+          <a:prstGeom prst="rect">
+            <a:avLst/>
+          </a:prstGeom>
+          <a:noFill/>
+        </p:spPr>
+        <p:txBody>
+          <a:bodyPr wrap="square"/>
+          <a:lstStyle/>
+          <a:p>
+            <a:pPr algn="l">
+              <a:defRPr sz="3200" b="1">
+                <a:solidFill>
+                  <a:srgbClr val="FAFAFA"/>
+                </a:solidFill>
+                <a:latin typeface="Calibri"/>
+              </a:defRPr>
+            </a:pPr>
+            <a:r>
+              <a:t>Generation outran review.</a:t>
+            </a:r>
+          </a:p>
+        </p:txBody>
+      </p:sp>
+      <p:sp>
+        <p:nvSpPr>
+          <p:cNvPr id="5" name="TextBox 4"/>
+          <p:cNvSpPr txBox="1"/>
+          <p:nvPr/>
+        </p:nvSpPr>
+        <p:spPr>
+          <a:xfrm>
+            <a:off x="502920" y="1371600"/>
+            <a:ext cx="10972800" cy="1005840"/>
+          </a:xfrm>
+          <a:prstGeom prst="rect">
+            <a:avLst/>
+          </a:prstGeom>
+          <a:noFill/>
+        </p:spPr>
+        <p:txBody>
+          <a:bodyPr wrap="square"/>
+          <a:lstStyle/>
+          <a:p>
+            <a:pPr algn="l">
+              <a:defRPr sz="2000" b="0">
+                <a:solidFill>
+                  <a:srgbClr val="FAFAFA"/>
+                </a:solidFill>
+                <a:latin typeface="Calibri"/>
+              </a:defRPr>
+            </a:pPr>
+            <a:r>
+              <a:t>Models write code at machine speed. Humans are still the approval layer — expected to read every diff, catch logic bugs, and sign off on security. That does not scale.</a:t>
+            </a:r>
+          </a:p>
+        </p:txBody>
+      </p:sp>
+      <p:sp>
+        <p:nvSpPr>
+          <p:cNvPr id="6" name="Rounded Rectangle 5"/>
+          <p:cNvSpPr/>
+          <p:nvPr/>
+        </p:nvSpPr>
+        <p:spPr>
+          <a:xfrm>
+            <a:off x="502920" y="2743200"/>
+            <a:ext cx="3566160" cy="2194560"/>
+          </a:xfrm>
+          <a:prstGeom prst="roundRect">
+            <a:avLst/>
+          </a:prstGeom>
+          <a:solidFill>
+            <a:srgbClr val="18181B"/>
+          </a:solidFill>
+          <a:ln>
+            <a:solidFill>
+              <a:srgbClr val="3F3F46"/>
+            </a:solidFill>
+          </a:ln>
+        </p:spPr>
+        <p:style>
+          <a:lnRef idx="1">
+            <a:schemeClr val="accent1"/>
+          </a:lnRef>
+          <a:fillRef idx="3">
+            <a:schemeClr val="accent1"/>
+          </a:fillRef>
+          <a:effectRef idx="2">
+            <a:schemeClr val="accent1"/>
+          </a:effectRef>
+          <a:fontRef idx="minor">
+            <a:schemeClr val="lt1"/>
+          </a:fontRef>
+        </p:style>
+        <p:txBody>
+          <a:bodyPr rtlCol="0" anchor="ctr" wrap="square" lIns="164592" rIns="146304" tIns="128016"/>
+          <a:lstStyle/>
+          <a:p>
+            <a:pPr algn="ctr">
+              <a:defRPr sz="3200" b="1">
+                <a:solidFill>
+                  <a:srgbClr val="F97316"/>
+                </a:solidFill>
+                <a:latin typeface="Calibri"/>
+              </a:defRPr>
+            </a:pPr>
+            <a:r>
+              <a:t>↑ volume</a:t>
+            </a:r>
+          </a:p>
           <a:p>
             <a:pPr>
-              <a:defRPr sz="2200">
+              <a:defRPr sz="1600" b="1">
+                <a:solidFill>
+                  <a:srgbClr val="FAFAFA"/>
+                </a:solidFill>
+                <a:latin typeface="Calibri"/>
+              </a:defRPr>
+            </a:pPr>
+            <a:r>
+              <a:t>Output</a:t>
+            </a:r>
+          </a:p>
+          <a:p>
+            <a:pPr>
+              <a:defRPr sz="1300">
                 <a:solidFill>
                   <a:srgbClr val="A1A1AA"/>
                 </a:solidFill>
-              </a:defRPr>
-            </a:pPr>
-            <a:r>
-              <a:t>AI generates code at machine speed.</a:t>
-            </a:r>
-            <a:br/>
-            <a:r>
-              <a:t>Humans are still asked to review all of it.</a:t>
-            </a:r>
-            <a:br/>
-            <a:r>
-              <a:t>That math does not work.</a:t>
+                <a:latin typeface="Calibri"/>
+              </a:defRPr>
+            </a:pPr>
+            <a:r>
+              <a:t>AI coding tools are now default in daily work.</a:t>
+            </a:r>
+          </a:p>
+        </p:txBody>
+      </p:sp>
+      <p:sp>
+        <p:nvSpPr>
+          <p:cNvPr id="7" name="Rounded Rectangle 6"/>
+          <p:cNvSpPr/>
+          <p:nvPr/>
+        </p:nvSpPr>
+        <p:spPr>
+          <a:xfrm>
+            <a:off x="4297680" y="2743200"/>
+            <a:ext cx="3566160" cy="2194560"/>
+          </a:xfrm>
+          <a:prstGeom prst="roundRect">
+            <a:avLst/>
+          </a:prstGeom>
+          <a:solidFill>
+            <a:srgbClr val="18181B"/>
+          </a:solidFill>
+          <a:ln>
+            <a:solidFill>
+              <a:srgbClr val="3F3F46"/>
+            </a:solidFill>
+          </a:ln>
+        </p:spPr>
+        <p:style>
+          <a:lnRef idx="1">
+            <a:schemeClr val="accent1"/>
+          </a:lnRef>
+          <a:fillRef idx="3">
+            <a:schemeClr val="accent1"/>
+          </a:fillRef>
+          <a:effectRef idx="2">
+            <a:schemeClr val="accent1"/>
+          </a:effectRef>
+          <a:fontRef idx="minor">
+            <a:schemeClr val="lt1"/>
+          </a:fontRef>
+        </p:style>
+        <p:txBody>
+          <a:bodyPr rtlCol="0" anchor="ctr" wrap="square" lIns="164592" rIns="146304" tIns="128016"/>
+          <a:lstStyle/>
+          <a:p>
+            <a:pPr algn="ctr">
+              <a:defRPr sz="3200" b="1">
+                <a:solidFill>
+                  <a:srgbClr val="F97316"/>
+                </a:solidFill>
+                <a:latin typeface="Calibri"/>
+              </a:defRPr>
+            </a:pPr>
+            <a:r>
+              <a:t>flat</a:t>
+            </a:r>
+          </a:p>
+          <a:p>
+            <a:pPr>
+              <a:defRPr sz="1600" b="1">
+                <a:solidFill>
+                  <a:srgbClr val="FAFAFA"/>
+                </a:solidFill>
+                <a:latin typeface="Calibri"/>
+              </a:defRPr>
+            </a:pPr>
+            <a:r>
+              <a:t>Review</a:t>
+            </a:r>
+          </a:p>
+          <a:p>
+            <a:pPr>
+              <a:defRPr sz="1300">
+                <a:solidFill>
+                  <a:srgbClr val="A1A1AA"/>
+                </a:solidFill>
+                <a:latin typeface="Calibri"/>
+              </a:defRPr>
+            </a:pPr>
+            <a:r>
+              <a:t>Same humans, more diffs, same calendar.</a:t>
+            </a:r>
+          </a:p>
+        </p:txBody>
+      </p:sp>
+      <p:sp>
+        <p:nvSpPr>
+          <p:cNvPr id="8" name="Rounded Rectangle 7"/>
+          <p:cNvSpPr/>
+          <p:nvPr/>
+        </p:nvSpPr>
+        <p:spPr>
+          <a:xfrm>
+            <a:off x="8092440" y="2743200"/>
+            <a:ext cx="3566160" cy="2194560"/>
+          </a:xfrm>
+          <a:prstGeom prst="roundRect">
+            <a:avLst/>
+          </a:prstGeom>
+          <a:solidFill>
+            <a:srgbClr val="18181B"/>
+          </a:solidFill>
+          <a:ln>
+            <a:solidFill>
+              <a:srgbClr val="3F3F46"/>
+            </a:solidFill>
+          </a:ln>
+        </p:spPr>
+        <p:style>
+          <a:lnRef idx="1">
+            <a:schemeClr val="accent1"/>
+          </a:lnRef>
+          <a:fillRef idx="3">
+            <a:schemeClr val="accent1"/>
+          </a:fillRef>
+          <a:effectRef idx="2">
+            <a:schemeClr val="accent1"/>
+          </a:effectRef>
+          <a:fontRef idx="minor">
+            <a:schemeClr val="lt1"/>
+          </a:fontRef>
+        </p:style>
+        <p:txBody>
+          <a:bodyPr rtlCol="0" anchor="ctr" wrap="square" lIns="164592" rIns="146304" tIns="128016"/>
+          <a:lstStyle/>
+          <a:p>
+            <a:pPr algn="ctr">
+              <a:defRPr sz="3200" b="1">
+                <a:solidFill>
+                  <a:srgbClr val="F97316"/>
+                </a:solidFill>
+                <a:latin typeface="Calibri"/>
+              </a:defRPr>
+            </a:pPr>
+            <a:r>
+              <a:t>gap</a:t>
+            </a:r>
+          </a:p>
+          <a:p>
+            <a:pPr>
+              <a:defRPr sz="1600" b="1">
+                <a:solidFill>
+                  <a:srgbClr val="FAFAFA"/>
+                </a:solidFill>
+                <a:latin typeface="Calibri"/>
+              </a:defRPr>
+            </a:pPr>
+            <a:r>
+              <a:t>Risk</a:t>
+            </a:r>
+          </a:p>
+          <a:p>
+            <a:pPr>
+              <a:defRPr sz="1300">
+                <a:solidFill>
+                  <a:srgbClr val="A1A1AA"/>
+                </a:solidFill>
+                <a:latin typeface="Calibri"/>
+              </a:defRPr>
+            </a:pPr>
+            <a:r>
+              <a:t>Weak code ships before anyone holds the shape.</a:t>
+            </a:r>
+          </a:p>
+        </p:txBody>
+      </p:sp>
+      <p:sp>
+        <p:nvSpPr>
+          <p:cNvPr id="9" name="TextBox 8"/>
+          <p:cNvSpPr txBox="1"/>
+          <p:nvPr/>
+        </p:nvSpPr>
+        <p:spPr>
+          <a:xfrm>
+            <a:off x="502920" y="6446520"/>
+            <a:ext cx="11155680" cy="292608"/>
+          </a:xfrm>
+          <a:prstGeom prst="rect">
+            <a:avLst/>
+          </a:prstGeom>
+          <a:noFill/>
+        </p:spPr>
+        <p:txBody>
+          <a:bodyPr wrap="square"/>
+          <a:lstStyle/>
+          <a:p>
+            <a:pPr algn="l">
+              <a:defRPr sz="1100" b="0">
+                <a:solidFill>
+                  <a:srgbClr val="A1A1AA"/>
+                </a:solidFill>
+                <a:latin typeface="Calibri"/>
+              </a:defRPr>
+            </a:pPr>
+            <a:r>
+              <a:t>Thesis: orientation and consent have to move as fast as generation.</a:t>
             </a:r>
           </a:p>
         </p:txBody>
@@ -3723,14 +4258,6 @@
 <file path=ppt/slides/slide3.xml><?xml version="1.0" encoding="utf-8"?>
 <p:sld xmlns:a="http://schemas.openxmlformats.org/drawingml/2006/main" xmlns:p="http://schemas.openxmlformats.org/presentationml/2006/main" xmlns:r="http://schemas.openxmlformats.org/officeDocument/2006/relationships">
   <p:cSld>
-    <p:bg>
-      <p:bgPr>
-        <a:solidFill>
-          <a:srgbClr val="0A0A0A"/>
-        </a:solidFill>
-        <a:effectLst/>
-      </p:bgPr>
-    </p:bg>
     <p:spTree>
       <p:nvGrpSpPr>
         <p:cNvPr id="1" name=""/>
@@ -3740,14 +4267,57 @@
       <p:grpSpPr/>
       <p:sp>
         <p:nvSpPr>
-          <p:cNvPr id="2" name="TextBox 1"/>
+          <p:cNvPr id="2" name="Rectangle 1"/>
+          <p:cNvSpPr/>
+          <p:nvPr/>
+        </p:nvSpPr>
+        <p:spPr>
+          <a:xfrm>
+            <a:off x="0" y="0"/>
+            <a:ext cx="12191695" cy="6858000"/>
+          </a:xfrm>
+          <a:prstGeom prst="rect">
+            <a:avLst/>
+          </a:prstGeom>
+          <a:solidFill>
+            <a:srgbClr val="0B0B0C"/>
+          </a:solidFill>
+          <a:ln>
+            <a:noFill/>
+          </a:ln>
+        </p:spPr>
+        <p:style>
+          <a:lnRef idx="1">
+            <a:schemeClr val="accent1"/>
+          </a:lnRef>
+          <a:fillRef idx="3">
+            <a:schemeClr val="accent1"/>
+          </a:fillRef>
+          <a:effectRef idx="2">
+            <a:schemeClr val="accent1"/>
+          </a:effectRef>
+          <a:fontRef idx="minor">
+            <a:schemeClr val="lt1"/>
+          </a:fontRef>
+        </p:style>
+        <p:txBody>
+          <a:bodyPr rtlCol="0" anchor="ctr"/>
+          <a:lstStyle/>
+          <a:p>
+            <a:pPr algn="ctr"/>
+          </a:p>
+        </p:txBody>
+      </p:sp>
+      <p:sp>
+        <p:nvSpPr>
+          <p:cNvPr id="3" name="TextBox 2"/>
           <p:cNvSpPr txBox="1"/>
           <p:nvPr/>
         </p:nvSpPr>
         <p:spPr>
           <a:xfrm>
-            <a:off x="685800" y="502920"/>
-            <a:ext cx="10515600" cy="1280160"/>
+            <a:off x="502920" y="292608"/>
+            <a:ext cx="7315200" cy="292608"/>
           </a:xfrm>
           <a:prstGeom prst="rect">
             <a:avLst/>
@@ -3755,34 +4325,310 @@
           <a:noFill/>
         </p:spPr>
         <p:txBody>
-          <a:bodyPr wrap="square">
-            <a:spAutoFit/>
-          </a:bodyPr>
+          <a:bodyPr wrap="square"/>
+          <a:lstStyle/>
+          <a:p>
+            <a:pPr algn="l">
+              <a:defRPr sz="1200" b="1">
+                <a:solidFill>
+                  <a:srgbClr val="F97316"/>
+                </a:solidFill>
+                <a:latin typeface="Calibri"/>
+              </a:defRPr>
+            </a:pPr>
+            <a:r>
+              <a:t>WHAT THE RESEARCH SAYS</a:t>
+            </a:r>
+          </a:p>
+        </p:txBody>
+      </p:sp>
+      <p:sp>
+        <p:nvSpPr>
+          <p:cNvPr id="4" name="TextBox 3"/>
+          <p:cNvSpPr txBox="1"/>
+          <p:nvPr/>
+        </p:nvSpPr>
+        <p:spPr>
+          <a:xfrm>
+            <a:off x="502920" y="566928"/>
+            <a:ext cx="11155680" cy="640080"/>
+          </a:xfrm>
+          <a:prstGeom prst="rect">
+            <a:avLst/>
+          </a:prstGeom>
+          <a:noFill/>
+        </p:spPr>
+        <p:txBody>
+          <a:bodyPr wrap="square"/>
           <a:lstStyle/>
           <a:p>
             <a:pPr algn="l">
               <a:defRPr sz="3200" b="1">
                 <a:solidFill>
+                  <a:srgbClr val="FAFAFA"/>
+                </a:solidFill>
+                <a:latin typeface="Calibri"/>
+              </a:defRPr>
+            </a:pPr>
+            <a:r>
+              <a:t>Adoption is done. Control is not.</a:t>
+            </a:r>
+          </a:p>
+        </p:txBody>
+      </p:sp>
+      <p:sp>
+        <p:nvSpPr>
+          <p:cNvPr id="5" name="Rounded Rectangle 4"/>
+          <p:cNvSpPr/>
+          <p:nvPr/>
+        </p:nvSpPr>
+        <p:spPr>
+          <a:xfrm>
+            <a:off x="457200" y="1554480"/>
+            <a:ext cx="3657600" cy="4206240"/>
+          </a:xfrm>
+          <a:prstGeom prst="roundRect">
+            <a:avLst/>
+          </a:prstGeom>
+          <a:solidFill>
+            <a:srgbClr val="18181B"/>
+          </a:solidFill>
+          <a:ln>
+            <a:solidFill>
+              <a:srgbClr val="3F3F46"/>
+            </a:solidFill>
+          </a:ln>
+        </p:spPr>
+        <p:style>
+          <a:lnRef idx="1">
+            <a:schemeClr val="accent1"/>
+          </a:lnRef>
+          <a:fillRef idx="3">
+            <a:schemeClr val="accent1"/>
+          </a:fillRef>
+          <a:effectRef idx="2">
+            <a:schemeClr val="accent1"/>
+          </a:effectRef>
+          <a:fontRef idx="minor">
+            <a:schemeClr val="lt1"/>
+          </a:fontRef>
+        </p:style>
+        <p:txBody>
+          <a:bodyPr rtlCol="0" anchor="ctr" wrap="square" lIns="164592" rIns="146304" tIns="128016"/>
+          <a:lstStyle/>
+          <a:p>
+            <a:pPr algn="ctr">
+              <a:defRPr sz="3200" b="1">
+                <a:solidFill>
                   <a:srgbClr val="F97316"/>
                 </a:solidFill>
-              </a:defRPr>
-            </a:pPr>
-            <a:r>
-              <a:t>The review bottleneck</a:t>
-            </a:r>
-          </a:p>
-        </p:txBody>
-      </p:sp>
-      <p:sp>
-        <p:nvSpPr>
-          <p:cNvPr id="3" name="TextBox 2"/>
+                <a:latin typeface="Calibri"/>
+              </a:defRPr>
+            </a:pPr>
+            <a:r>
+              <a:t>97%+</a:t>
+            </a:r>
+          </a:p>
+          <a:p>
+            <a:pPr>
+              <a:defRPr sz="1600" b="1">
+                <a:solidFill>
+                  <a:srgbClr val="FAFAFA"/>
+                </a:solidFill>
+                <a:latin typeface="Calibri"/>
+              </a:defRPr>
+            </a:pPr>
+            <a:r>
+              <a:t>Used AI coding tools at work</a:t>
+            </a:r>
+          </a:p>
+          <a:p>
+            <a:pPr>
+              <a:defRPr sz="1300">
+                <a:solidFill>
+                  <a:srgbClr val="A1A1AA"/>
+                </a:solidFill>
+                <a:latin typeface="Calibri"/>
+              </a:defRPr>
+            </a:pPr>
+            <a:r>
+              <a:t>GitHub survey of 2,000 developers across four countries, 2024. Nearly everyone has tried the tools. Policy and review practice lag the habit.</a:t>
+            </a:r>
+          </a:p>
+        </p:txBody>
+      </p:sp>
+      <p:sp>
+        <p:nvSpPr>
+          <p:cNvPr id="6" name="Rounded Rectangle 5"/>
+          <p:cNvSpPr/>
+          <p:nvPr/>
+        </p:nvSpPr>
+        <p:spPr>
+          <a:xfrm>
+            <a:off x="4297680" y="1554480"/>
+            <a:ext cx="3657600" cy="4206240"/>
+          </a:xfrm>
+          <a:prstGeom prst="roundRect">
+            <a:avLst/>
+          </a:prstGeom>
+          <a:solidFill>
+            <a:srgbClr val="18181B"/>
+          </a:solidFill>
+          <a:ln>
+            <a:solidFill>
+              <a:srgbClr val="3F3F46"/>
+            </a:solidFill>
+          </a:ln>
+        </p:spPr>
+        <p:style>
+          <a:lnRef idx="1">
+            <a:schemeClr val="accent1"/>
+          </a:lnRef>
+          <a:fillRef idx="3">
+            <a:schemeClr val="accent1"/>
+          </a:fillRef>
+          <a:effectRef idx="2">
+            <a:schemeClr val="accent1"/>
+          </a:effectRef>
+          <a:fontRef idx="minor">
+            <a:schemeClr val="lt1"/>
+          </a:fontRef>
+        </p:style>
+        <p:txBody>
+          <a:bodyPr rtlCol="0" anchor="ctr" wrap="square" lIns="164592" rIns="146304" tIns="128016"/>
+          <a:lstStyle/>
+          <a:p>
+            <a:pPr algn="ctr">
+              <a:defRPr sz="3200" b="1">
+                <a:solidFill>
+                  <a:srgbClr val="F97316"/>
+                </a:solidFill>
+                <a:latin typeface="Calibri"/>
+              </a:defRPr>
+            </a:pPr>
+            <a:r>
+              <a:t>−7.2%</a:t>
+            </a:r>
+          </a:p>
+          <a:p>
+            <a:pPr>
+              <a:defRPr sz="1600" b="1">
+                <a:solidFill>
+                  <a:srgbClr val="FAFAFA"/>
+                </a:solidFill>
+                <a:latin typeface="Calibri"/>
+              </a:defRPr>
+            </a:pPr>
+            <a:r>
+              <a:t>Stability drop per +25% AI adoption</a:t>
+            </a:r>
+          </a:p>
+          <a:p>
+            <a:pPr>
+              <a:defRPr sz="1300">
+                <a:solidFill>
+                  <a:srgbClr val="A1A1AA"/>
+                </a:solidFill>
+                <a:latin typeface="Calibri"/>
+              </a:defRPr>
+            </a:pPr>
+            <a:r>
+              <a:t>Google DORA 2024: individual flow goes up. Delivery stability is estimated down 7.2%. Throughput slightly down too. Faster typing is not a healthier pipeline.</a:t>
+            </a:r>
+          </a:p>
+        </p:txBody>
+      </p:sp>
+      <p:sp>
+        <p:nvSpPr>
+          <p:cNvPr id="7" name="Rounded Rectangle 6"/>
+          <p:cNvSpPr/>
+          <p:nvPr/>
+        </p:nvSpPr>
+        <p:spPr>
+          <a:xfrm>
+            <a:off x="8138160" y="1554480"/>
+            <a:ext cx="3566160" cy="4206240"/>
+          </a:xfrm>
+          <a:prstGeom prst="roundRect">
+            <a:avLst/>
+          </a:prstGeom>
+          <a:solidFill>
+            <a:srgbClr val="18181B"/>
+          </a:solidFill>
+          <a:ln>
+            <a:solidFill>
+              <a:srgbClr val="3F3F46"/>
+            </a:solidFill>
+          </a:ln>
+        </p:spPr>
+        <p:style>
+          <a:lnRef idx="1">
+            <a:schemeClr val="accent1"/>
+          </a:lnRef>
+          <a:fillRef idx="3">
+            <a:schemeClr val="accent1"/>
+          </a:fillRef>
+          <a:effectRef idx="2">
+            <a:schemeClr val="accent1"/>
+          </a:effectRef>
+          <a:fontRef idx="minor">
+            <a:schemeClr val="lt1"/>
+          </a:fontRef>
+        </p:style>
+        <p:txBody>
+          <a:bodyPr rtlCol="0" anchor="ctr" wrap="square" lIns="164592" rIns="146304" tIns="128016"/>
+          <a:lstStyle/>
+          <a:p>
+            <a:pPr algn="ctr">
+              <a:defRPr sz="3200" b="1">
+                <a:solidFill>
+                  <a:srgbClr val="F97316"/>
+                </a:solidFill>
+                <a:latin typeface="Calibri"/>
+              </a:defRPr>
+            </a:pPr>
+            <a:r>
+              <a:t>45%</a:t>
+            </a:r>
+          </a:p>
+          <a:p>
+            <a:pPr>
+              <a:defRPr sz="1600" b="1">
+                <a:solidFill>
+                  <a:srgbClr val="FAFAFA"/>
+                </a:solidFill>
+                <a:latin typeface="Calibri"/>
+              </a:defRPr>
+            </a:pPr>
+            <a:r>
+              <a:t>AI code tasks with an OWASP flaw</a:t>
+            </a:r>
+          </a:p>
+          <a:p>
+            <a:pPr>
+              <a:defRPr sz="1300">
+                <a:solidFill>
+                  <a:srgbClr val="A1A1AA"/>
+                </a:solidFill>
+                <a:latin typeface="Calibri"/>
+              </a:defRPr>
+            </a:pPr>
+            <a:r>
+              <a:t>Veracode 2025: 100+ models, 80 tasks. Syntax improved. Security pass rate stayed ~55%. Newer models did not get meaningfully safer.</a:t>
+            </a:r>
+          </a:p>
+        </p:txBody>
+      </p:sp>
+      <p:sp>
+        <p:nvSpPr>
+          <p:cNvPr id="8" name="TextBox 7"/>
           <p:cNvSpPr txBox="1"/>
           <p:nvPr/>
         </p:nvSpPr>
         <p:spPr>
           <a:xfrm>
-            <a:off x="777240" y="1325880"/>
-            <a:ext cx="10241280" cy="4754880"/>
+            <a:off x="502920" y="6446520"/>
+            <a:ext cx="11155680" cy="292608"/>
           </a:xfrm>
           <a:prstGeom prst="rect">
             <a:avLst/>
@@ -3790,53 +4636,19 @@
           <a:noFill/>
         </p:spPr>
         <p:txBody>
-          <a:bodyPr wrap="square">
-            <a:spAutoFit/>
-          </a:bodyPr>
-          <a:lstStyle/>
-          <a:p>
-            <a:pPr>
-              <a:spcAft>
-                <a:spcPts val="1400"/>
-              </a:spcAft>
-              <a:defRPr sz="2000">
-                <a:solidFill>
-                  <a:srgbClr val="FAFAFA"/>
-                </a:solidFill>
-              </a:defRPr>
-            </a:pPr>
-            <a:r>
-              <a:t>PR queues and diff mountains grow with every agent-assisted sprint</a:t>
-            </a:r>
-          </a:p>
-          <a:p>
-            <a:pPr>
-              <a:spcAft>
-                <a:spcPts val="1400"/>
-              </a:spcAft>
-              <a:defRPr sz="2000">
-                <a:solidFill>
-                  <a:srgbClr val="FAFAFA"/>
-                </a:solidFill>
-              </a:defRPr>
-            </a:pPr>
-            <a:r>
-              <a:t>LGTM becomes survival, not assurance</a:t>
-            </a:r>
-          </a:p>
-          <a:p>
-            <a:pPr>
-              <a:spcAft>
-                <a:spcPts val="1400"/>
-              </a:spcAft>
-              <a:defRPr sz="2000">
-                <a:solidFill>
-                  <a:srgbClr val="FAFAFA"/>
-                </a:solidFill>
-              </a:defRPr>
-            </a:pPr>
-            <a:r>
-              <a:t>Nobody holds architecture + history + issues in one head</a:t>
+          <a:bodyPr wrap="square"/>
+          <a:lstStyle/>
+          <a:p>
+            <a:pPr algn="l">
+              <a:defRPr sz="1100" b="0">
+                <a:solidFill>
+                  <a:srgbClr val="A1A1AA"/>
+                </a:solidFill>
+                <a:latin typeface="Calibri"/>
+              </a:defRPr>
+            </a:pPr>
+            <a:r>
+              <a:t>Sources: GitHub AI in software development survey (2024) · DORA Accelerate State of DevOps 2024 · Veracode GenAI Code Security Report 2025</a:t>
             </a:r>
           </a:p>
         </p:txBody>
@@ -3852,14 +4664,6 @@
 <file path=ppt/slides/slide4.xml><?xml version="1.0" encoding="utf-8"?>
 <p:sld xmlns:a="http://schemas.openxmlformats.org/drawingml/2006/main" xmlns:p="http://schemas.openxmlformats.org/presentationml/2006/main" xmlns:r="http://schemas.openxmlformats.org/officeDocument/2006/relationships">
   <p:cSld>
-    <p:bg>
-      <p:bgPr>
-        <a:solidFill>
-          <a:srgbClr val="0A0A0A"/>
-        </a:solidFill>
-        <a:effectLst/>
-      </p:bgPr>
-    </p:bg>
     <p:spTree>
       <p:nvGrpSpPr>
         <p:cNvPr id="1" name=""/>
@@ -3869,14 +4673,57 @@
       <p:grpSpPr/>
       <p:sp>
         <p:nvSpPr>
-          <p:cNvPr id="2" name="TextBox 1"/>
+          <p:cNvPr id="2" name="Rectangle 1"/>
+          <p:cNvSpPr/>
+          <p:nvPr/>
+        </p:nvSpPr>
+        <p:spPr>
+          <a:xfrm>
+            <a:off x="0" y="0"/>
+            <a:ext cx="12191695" cy="6858000"/>
+          </a:xfrm>
+          <a:prstGeom prst="rect">
+            <a:avLst/>
+          </a:prstGeom>
+          <a:solidFill>
+            <a:srgbClr val="0B0B0C"/>
+          </a:solidFill>
+          <a:ln>
+            <a:noFill/>
+          </a:ln>
+        </p:spPr>
+        <p:style>
+          <a:lnRef idx="1">
+            <a:schemeClr val="accent1"/>
+          </a:lnRef>
+          <a:fillRef idx="3">
+            <a:schemeClr val="accent1"/>
+          </a:fillRef>
+          <a:effectRef idx="2">
+            <a:schemeClr val="accent1"/>
+          </a:effectRef>
+          <a:fontRef idx="minor">
+            <a:schemeClr val="lt1"/>
+          </a:fontRef>
+        </p:style>
+        <p:txBody>
+          <a:bodyPr rtlCol="0" anchor="ctr"/>
+          <a:lstStyle/>
+          <a:p>
+            <a:pPr algn="ctr"/>
+          </a:p>
+        </p:txBody>
+      </p:sp>
+      <p:sp>
+        <p:nvSpPr>
+          <p:cNvPr id="3" name="TextBox 2"/>
           <p:cNvSpPr txBox="1"/>
           <p:nvPr/>
         </p:nvSpPr>
         <p:spPr>
           <a:xfrm>
-            <a:off x="685800" y="502920"/>
-            <a:ext cx="10515600" cy="1280160"/>
+            <a:off x="502920" y="292608"/>
+            <a:ext cx="7315200" cy="292608"/>
           </a:xfrm>
           <a:prstGeom prst="rect">
             <a:avLst/>
@@ -3884,34 +4731,203 @@
           <a:noFill/>
         </p:spPr>
         <p:txBody>
-          <a:bodyPr wrap="square">
-            <a:spAutoFit/>
-          </a:bodyPr>
+          <a:bodyPr wrap="square"/>
+          <a:lstStyle/>
+          <a:p>
+            <a:pPr algn="l">
+              <a:defRPr sz="1200" b="1">
+                <a:solidFill>
+                  <a:srgbClr val="F97316"/>
+                </a:solidFill>
+                <a:latin typeface="Calibri"/>
+              </a:defRPr>
+            </a:pPr>
+            <a:r>
+              <a:t>THE ASYMMETRY</a:t>
+            </a:r>
+          </a:p>
+        </p:txBody>
+      </p:sp>
+      <p:sp>
+        <p:nvSpPr>
+          <p:cNvPr id="4" name="TextBox 3"/>
+          <p:cNvSpPr txBox="1"/>
+          <p:nvPr/>
+        </p:nvSpPr>
+        <p:spPr>
+          <a:xfrm>
+            <a:off x="502920" y="566928"/>
+            <a:ext cx="11155680" cy="640080"/>
+          </a:xfrm>
+          <a:prstGeom prst="rect">
+            <a:avLst/>
+          </a:prstGeom>
+          <a:noFill/>
+        </p:spPr>
+        <p:txBody>
+          <a:bodyPr wrap="square"/>
           <a:lstStyle/>
           <a:p>
             <a:pPr algn="l">
               <a:defRPr sz="3200" b="1">
                 <a:solidFill>
-                  <a:srgbClr val="F97316"/>
-                </a:solidFill>
-              </a:defRPr>
-            </a:pPr>
-            <a:r>
-              <a:t>The security asymmetry</a:t>
-            </a:r>
-          </a:p>
-        </p:txBody>
-      </p:sp>
-      <p:sp>
-        <p:nvSpPr>
-          <p:cNvPr id="3" name="TextBox 2"/>
+                  <a:srgbClr val="FAFAFA"/>
+                </a:solidFill>
+                <a:latin typeface="Calibri"/>
+              </a:defRPr>
+            </a:pPr>
+            <a:r>
+              <a:t>Offense automated. Understanding did not.</a:t>
+            </a:r>
+          </a:p>
+        </p:txBody>
+      </p:sp>
+      <p:sp>
+        <p:nvSpPr>
+          <p:cNvPr id="5" name="Rounded Rectangle 4"/>
+          <p:cNvSpPr/>
+          <p:nvPr/>
+        </p:nvSpPr>
+        <p:spPr>
+          <a:xfrm>
+            <a:off x="502920" y="1554480"/>
+            <a:ext cx="5486400" cy="4297680"/>
+          </a:xfrm>
+          <a:prstGeom prst="roundRect">
+            <a:avLst/>
+          </a:prstGeom>
+          <a:solidFill>
+            <a:srgbClr val="18181B"/>
+          </a:solidFill>
+          <a:ln>
+            <a:solidFill>
+              <a:srgbClr val="3F3F46"/>
+            </a:solidFill>
+          </a:ln>
+        </p:spPr>
+        <p:style>
+          <a:lnRef idx="1">
+            <a:schemeClr val="accent1"/>
+          </a:lnRef>
+          <a:fillRef idx="3">
+            <a:schemeClr val="accent1"/>
+          </a:fillRef>
+          <a:effectRef idx="2">
+            <a:schemeClr val="accent1"/>
+          </a:effectRef>
+          <a:fontRef idx="minor">
+            <a:schemeClr val="lt1"/>
+          </a:fontRef>
+        </p:style>
+        <p:txBody>
+          <a:bodyPr rtlCol="0" anchor="ctr" wrap="square" lIns="164592" rIns="146304" tIns="128016"/>
+          <a:lstStyle/>
+          <a:p>
+            <a:pPr algn="ctr">
+              <a:defRPr sz="1600" b="1">
+                <a:solidFill>
+                  <a:srgbClr val="FAFAFA"/>
+                </a:solidFill>
+                <a:latin typeface="Calibri"/>
+              </a:defRPr>
+            </a:pPr>
+            <a:r>
+              <a:t>What got faster</a:t>
+            </a:r>
+          </a:p>
+          <a:p>
+            <a:pPr>
+              <a:defRPr sz="1300">
+                <a:solidFill>
+                  <a:srgbClr val="A1A1AA"/>
+                </a:solidFill>
+                <a:latin typeface="Calibri"/>
+              </a:defRPr>
+            </a:pPr>
+            <a:r>
+              <a:t>Writing functions. Finding secrets, XSS, injection, and unsafe patterns. Opening issues and comments from an agent with no second look.</a:t>
+            </a:r>
+          </a:p>
+        </p:txBody>
+      </p:sp>
+      <p:sp>
+        <p:nvSpPr>
+          <p:cNvPr id="6" name="Rounded Rectangle 5"/>
+          <p:cNvSpPr/>
+          <p:nvPr/>
+        </p:nvSpPr>
+        <p:spPr>
+          <a:xfrm>
+            <a:off x="6217920" y="1554480"/>
+            <a:ext cx="5486400" cy="4297680"/>
+          </a:xfrm>
+          <a:prstGeom prst="roundRect">
+            <a:avLst/>
+          </a:prstGeom>
+          <a:solidFill>
+            <a:srgbClr val="18181B"/>
+          </a:solidFill>
+          <a:ln>
+            <a:solidFill>
+              <a:srgbClr val="3F3F46"/>
+            </a:solidFill>
+          </a:ln>
+        </p:spPr>
+        <p:style>
+          <a:lnRef idx="1">
+            <a:schemeClr val="accent1"/>
+          </a:lnRef>
+          <a:fillRef idx="3">
+            <a:schemeClr val="accent1"/>
+          </a:fillRef>
+          <a:effectRef idx="2">
+            <a:schemeClr val="accent1"/>
+          </a:effectRef>
+          <a:fontRef idx="minor">
+            <a:schemeClr val="lt1"/>
+          </a:fontRef>
+        </p:style>
+        <p:txBody>
+          <a:bodyPr rtlCol="0" anchor="ctr" wrap="square" lIns="164592" rIns="146304" tIns="128016"/>
+          <a:lstStyle/>
+          <a:p>
+            <a:pPr algn="ctr">
+              <a:defRPr sz="1600" b="1">
+                <a:solidFill>
+                  <a:srgbClr val="FAFAFA"/>
+                </a:solidFill>
+                <a:latin typeface="Calibri"/>
+              </a:defRPr>
+            </a:pPr>
+            <a:r>
+              <a:t>What stayed human-speed</a:t>
+            </a:r>
+          </a:p>
+          <a:p>
+            <a:pPr>
+              <a:defRPr sz="1300">
+                <a:solidFill>
+                  <a:srgbClr val="A1A1AA"/>
+                </a:solidFill>
+                <a:latin typeface="Calibri"/>
+              </a:defRPr>
+            </a:pPr>
+            <a:r>
+              <a:t>Holding architecture in your head. Reading the last commit against the map. Deciding what is safe to merge. Saying yes only when you mean it.</a:t>
+            </a:r>
+          </a:p>
+        </p:txBody>
+      </p:sp>
+      <p:sp>
+        <p:nvSpPr>
+          <p:cNvPr id="7" name="TextBox 6"/>
           <p:cNvSpPr txBox="1"/>
           <p:nvPr/>
         </p:nvSpPr>
         <p:spPr>
           <a:xfrm>
-            <a:off x="777240" y="1325880"/>
-            <a:ext cx="10241280" cy="4754880"/>
+            <a:off x="502920" y="6446520"/>
+            <a:ext cx="11155680" cy="292608"/>
           </a:xfrm>
           <a:prstGeom prst="rect">
             <a:avLst/>
@@ -3919,53 +4935,19 @@
           <a:noFill/>
         </p:spPr>
         <p:txBody>
-          <a:bodyPr wrap="square">
-            <a:spAutoFit/>
-          </a:bodyPr>
-          <a:lstStyle/>
-          <a:p>
-            <a:pPr>
-              <a:spcAft>
-                <a:spcPts val="1400"/>
-              </a:spcAft>
-              <a:defRPr sz="2000">
-                <a:solidFill>
-                  <a:srgbClr val="FAFAFA"/>
-                </a:solidFill>
-              </a:defRPr>
-            </a:pPr>
-            <a:r>
-              <a:t>AI finds vulnerabilities and unsafe patterns quickly</a:t>
-            </a:r>
-          </a:p>
-          <a:p>
-            <a:pPr>
-              <a:spcAft>
-                <a:spcPts val="1400"/>
-              </a:spcAft>
-              <a:defRPr sz="2000">
-                <a:solidFill>
-                  <a:srgbClr val="FAFAFA"/>
-                </a:solidFill>
-              </a:defRPr>
-            </a:pPr>
-            <a:r>
-              <a:t>Exploitation automates; understanding does not</a:t>
-            </a:r>
-          </a:p>
-          <a:p>
-            <a:pPr>
-              <a:spcAft>
-                <a:spcPts val="1400"/>
-              </a:spcAft>
-              <a:defRPr sz="2000">
-                <a:solidFill>
-                  <a:srgbClr val="FAFAFA"/>
-                </a:solidFill>
-              </a:defRPr>
-            </a:pPr>
-            <a:r>
-              <a:t>Ship fast without orientation → lose grip on what actually runs</a:t>
+          <a:bodyPr wrap="square"/>
+          <a:lstStyle/>
+          <a:p>
+            <a:pPr algn="l">
+              <a:defRPr sz="1100" b="0">
+                <a:solidFill>
+                  <a:srgbClr val="A1A1AA"/>
+                </a:solidFill>
+                <a:latin typeface="Calibri"/>
+              </a:defRPr>
+            </a:pPr>
+            <a:r>
+              <a:t>If we ship opaque volume, we lose grip on what actually runs.</a:t>
             </a:r>
           </a:p>
         </p:txBody>
@@ -3981,14 +4963,6 @@
 <file path=ppt/slides/slide5.xml><?xml version="1.0" encoding="utf-8"?>
 <p:sld xmlns:a="http://schemas.openxmlformats.org/drawingml/2006/main" xmlns:p="http://schemas.openxmlformats.org/presentationml/2006/main" xmlns:r="http://schemas.openxmlformats.org/officeDocument/2006/relationships">
   <p:cSld>
-    <p:bg>
-      <p:bgPr>
-        <a:solidFill>
-          <a:srgbClr val="0A0A0A"/>
-        </a:solidFill>
-        <a:effectLst/>
-      </p:bgPr>
-    </p:bg>
     <p:spTree>
       <p:nvGrpSpPr>
         <p:cNvPr id="1" name=""/>
@@ -3998,36 +4972,44 @@
       <p:grpSpPr/>
       <p:sp>
         <p:nvSpPr>
-          <p:cNvPr id="2" name="TextBox 1"/>
-          <p:cNvSpPr txBox="1"/>
-          <p:nvPr/>
-        </p:nvSpPr>
-        <p:spPr>
-          <a:xfrm>
-            <a:off x="685800" y="1645920"/>
-            <a:ext cx="10515600" cy="1280160"/>
+          <p:cNvPr id="2" name="Rectangle 1"/>
+          <p:cNvSpPr/>
+          <p:nvPr/>
+        </p:nvSpPr>
+        <p:spPr>
+          <a:xfrm>
+            <a:off x="0" y="0"/>
+            <a:ext cx="12191695" cy="6858000"/>
           </a:xfrm>
           <a:prstGeom prst="rect">
             <a:avLst/>
           </a:prstGeom>
-          <a:noFill/>
-        </p:spPr>
-        <p:txBody>
-          <a:bodyPr wrap="square">
-            <a:spAutoFit/>
-          </a:bodyPr>
-          <a:lstStyle/>
-          <a:p>
-            <a:pPr algn="l">
-              <a:defRPr sz="4400" b="1">
-                <a:solidFill>
-                  <a:srgbClr val="F97316"/>
-                </a:solidFill>
-              </a:defRPr>
-            </a:pPr>
-            <a:r>
-              <a:t>Friday</a:t>
-            </a:r>
+          <a:solidFill>
+            <a:srgbClr val="0B0B0C"/>
+          </a:solidFill>
+          <a:ln>
+            <a:noFill/>
+          </a:ln>
+        </p:spPr>
+        <p:style>
+          <a:lnRef idx="1">
+            <a:schemeClr val="accent1"/>
+          </a:lnRef>
+          <a:fillRef idx="3">
+            <a:schemeClr val="accent1"/>
+          </a:fillRef>
+          <a:effectRef idx="2">
+            <a:schemeClr val="accent1"/>
+          </a:effectRef>
+          <a:fontRef idx="minor">
+            <a:schemeClr val="lt1"/>
+          </a:fontRef>
+        </p:style>
+        <p:txBody>
+          <a:bodyPr rtlCol="0" anchor="ctr"/>
+          <a:lstStyle/>
+          <a:p>
+            <a:pPr algn="ctr"/>
           </a:p>
         </p:txBody>
       </p:sp>
@@ -4039,8 +5021,8 @@
         </p:nvSpPr>
         <p:spPr>
           <a:xfrm>
-            <a:off x="685800" y="2651760"/>
-            <a:ext cx="10515600" cy="1097280"/>
+            <a:off x="502920" y="292608"/>
+            <a:ext cx="7315200" cy="292608"/>
           </a:xfrm>
           <a:prstGeom prst="rect">
             <a:avLst/>
@@ -4048,24 +5030,291 @@
           <a:noFill/>
         </p:spPr>
         <p:txBody>
-          <a:bodyPr wrap="none">
-            <a:spAutoFit/>
-          </a:bodyPr>
-          <a:lstStyle/>
+          <a:bodyPr wrap="square"/>
+          <a:lstStyle/>
+          <a:p>
+            <a:pPr algn="l">
+              <a:defRPr sz="1200" b="1">
+                <a:solidFill>
+                  <a:srgbClr val="F97316"/>
+                </a:solidFill>
+                <a:latin typeface="Calibri"/>
+              </a:defRPr>
+            </a:pPr>
+            <a:r>
+              <a:t>THE PRODUCT</a:t>
+            </a:r>
+          </a:p>
+        </p:txBody>
+      </p:sp>
+      <p:sp>
+        <p:nvSpPr>
+          <p:cNvPr id="4" name="TextBox 3"/>
+          <p:cNvSpPr txBox="1"/>
+          <p:nvPr/>
+        </p:nvSpPr>
+        <p:spPr>
+          <a:xfrm>
+            <a:off x="502920" y="566928"/>
+            <a:ext cx="11155680" cy="640080"/>
+          </a:xfrm>
+          <a:prstGeom prst="rect">
+            <a:avLst/>
+          </a:prstGeom>
+          <a:noFill/>
+        </p:spPr>
+        <p:txBody>
+          <a:bodyPr wrap="square"/>
+          <a:lstStyle/>
+          <a:p>
+            <a:pPr algn="l">
+              <a:defRPr sz="3200" b="1">
+                <a:solidFill>
+                  <a:srgbClr val="FAFAFA"/>
+                </a:solidFill>
+                <a:latin typeface="Calibri"/>
+              </a:defRPr>
+            </a:pPr>
+            <a:r>
+              <a:t>Friday is a control surface, not another chat box.</a:t>
+            </a:r>
+          </a:p>
+        </p:txBody>
+      </p:sp>
+      <p:sp>
+        <p:nvSpPr>
+          <p:cNvPr id="5" name="TextBox 4"/>
+          <p:cNvSpPr txBox="1"/>
+          <p:nvPr/>
+        </p:nvSpPr>
+        <p:spPr>
+          <a:xfrm>
+            <a:off x="502920" y="1371600"/>
+            <a:ext cx="10972800" cy="822960"/>
+          </a:xfrm>
+          <a:prstGeom prst="rect">
+            <a:avLst/>
+          </a:prstGeom>
+          <a:noFill/>
+        </p:spPr>
+        <p:txBody>
+          <a:bodyPr wrap="square"/>
+          <a:lstStyle/>
+          <a:p>
+            <a:pPr algn="l">
+              <a:defRPr sz="1800" b="0">
+                <a:solidFill>
+                  <a:srgbClr val="A1A1AA"/>
+                </a:solidFill>
+                <a:latin typeface="Calibri"/>
+              </a:defRPr>
+            </a:pPr>
+            <a:r>
+              <a:t>A live map of the repo you already opened. Voice or type. Answers from ingested structure and real GitHub data. Writes wait for a later yes.</a:t>
+            </a:r>
+          </a:p>
+        </p:txBody>
+      </p:sp>
+      <p:sp>
+        <p:nvSpPr>
+          <p:cNvPr id="6" name="Rounded Rectangle 5"/>
+          <p:cNvSpPr/>
+          <p:nvPr/>
+        </p:nvSpPr>
+        <p:spPr>
+          <a:xfrm>
+            <a:off x="502920" y="2468880"/>
+            <a:ext cx="3611880" cy="3108960"/>
+          </a:xfrm>
+          <a:prstGeom prst="roundRect">
+            <a:avLst/>
+          </a:prstGeom>
+          <a:solidFill>
+            <a:srgbClr val="18181B"/>
+          </a:solidFill>
+          <a:ln>
+            <a:solidFill>
+              <a:srgbClr val="3F3F46"/>
+            </a:solidFill>
+          </a:ln>
+        </p:spPr>
+        <p:style>
+          <a:lnRef idx="1">
+            <a:schemeClr val="accent1"/>
+          </a:lnRef>
+          <a:fillRef idx="3">
+            <a:schemeClr val="accent1"/>
+          </a:fillRef>
+          <a:effectRef idx="2">
+            <a:schemeClr val="accent1"/>
+          </a:effectRef>
+          <a:fontRef idx="minor">
+            <a:schemeClr val="lt1"/>
+          </a:fontRef>
+        </p:style>
+        <p:txBody>
+          <a:bodyPr rtlCol="0" anchor="ctr" wrap="square" lIns="164592" rIns="146304" tIns="128016"/>
+          <a:lstStyle/>
+          <a:p>
+            <a:pPr algn="ctr">
+              <a:defRPr sz="1600" b="1">
+                <a:solidFill>
+                  <a:srgbClr val="FAFAFA"/>
+                </a:solidFill>
+                <a:latin typeface="Calibri"/>
+              </a:defRPr>
+            </a:pPr>
+            <a:r>
+              <a:t>See</a:t>
+            </a:r>
+          </a:p>
           <a:p>
             <a:pPr>
-              <a:defRPr sz="2200">
+              <a:defRPr sz="1300">
                 <a:solidFill>
                   <a:srgbClr val="A1A1AA"/>
                 </a:solidFill>
-              </a:defRPr>
-            </a:pPr>
-            <a:r>
-              <a:t>A voice-first control surface for the repo you have open.</a:t>
-            </a:r>
-            <a:br/>
-            <a:r>
-              <a:t>See the shape. Ask out loud. Stage GitHub actions. Confirm before you post.</a:t>
+                <a:latin typeface="Calibri"/>
+              </a:defRPr>
+            </a:pPr>
+            <a:r>
+              <a:t>Circle pack: entry, core, hotspots, heat, imports.</a:t>
+            </a:r>
+          </a:p>
+        </p:txBody>
+      </p:sp>
+      <p:sp>
+        <p:nvSpPr>
+          <p:cNvPr id="7" name="Rounded Rectangle 6"/>
+          <p:cNvSpPr/>
+          <p:nvPr/>
+        </p:nvSpPr>
+        <p:spPr>
+          <a:xfrm>
+            <a:off x="4343400" y="2468880"/>
+            <a:ext cx="3611880" cy="3108960"/>
+          </a:xfrm>
+          <a:prstGeom prst="roundRect">
+            <a:avLst/>
+          </a:prstGeom>
+          <a:solidFill>
+            <a:srgbClr val="18181B"/>
+          </a:solidFill>
+          <a:ln>
+            <a:solidFill>
+              <a:srgbClr val="3F3F46"/>
+            </a:solidFill>
+          </a:ln>
+        </p:spPr>
+        <p:style>
+          <a:lnRef idx="1">
+            <a:schemeClr val="accent1"/>
+          </a:lnRef>
+          <a:fillRef idx="3">
+            <a:schemeClr val="accent1"/>
+          </a:fillRef>
+          <a:effectRef idx="2">
+            <a:schemeClr val="accent1"/>
+          </a:effectRef>
+          <a:fontRef idx="minor">
+            <a:schemeClr val="lt1"/>
+          </a:fontRef>
+        </p:style>
+        <p:txBody>
+          <a:bodyPr rtlCol="0" anchor="ctr" wrap="square" lIns="164592" rIns="146304" tIns="128016"/>
+          <a:lstStyle/>
+          <a:p>
+            <a:pPr algn="ctr">
+              <a:defRPr sz="1600" b="1">
+                <a:solidFill>
+                  <a:srgbClr val="FAFAFA"/>
+                </a:solidFill>
+                <a:latin typeface="Calibri"/>
+              </a:defRPr>
+            </a:pPr>
+            <a:r>
+              <a:t>Ask</a:t>
+            </a:r>
+          </a:p>
+          <a:p>
+            <a:pPr>
+              <a:defRPr sz="1300">
+                <a:solidFill>
+                  <a:srgbClr val="A1A1AA"/>
+                </a:solidFill>
+                <a:latin typeface="Calibri"/>
+              </a:defRPr>
+            </a:pPr>
+            <a:r>
+              <a:t>Landmarks, diffs, issues, PRs, security, merge risk.</a:t>
+            </a:r>
+          </a:p>
+        </p:txBody>
+      </p:sp>
+      <p:sp>
+        <p:nvSpPr>
+          <p:cNvPr id="8" name="Rounded Rectangle 7"/>
+          <p:cNvSpPr/>
+          <p:nvPr/>
+        </p:nvSpPr>
+        <p:spPr>
+          <a:xfrm>
+            <a:off x="8183880" y="2468880"/>
+            <a:ext cx="3611880" cy="3108960"/>
+          </a:xfrm>
+          <a:prstGeom prst="roundRect">
+            <a:avLst/>
+          </a:prstGeom>
+          <a:solidFill>
+            <a:srgbClr val="18181B"/>
+          </a:solidFill>
+          <a:ln>
+            <a:solidFill>
+              <a:srgbClr val="3F3F46"/>
+            </a:solidFill>
+          </a:ln>
+        </p:spPr>
+        <p:style>
+          <a:lnRef idx="1">
+            <a:schemeClr val="accent1"/>
+          </a:lnRef>
+          <a:fillRef idx="3">
+            <a:schemeClr val="accent1"/>
+          </a:fillRef>
+          <a:effectRef idx="2">
+            <a:schemeClr val="accent1"/>
+          </a:effectRef>
+          <a:fontRef idx="minor">
+            <a:schemeClr val="lt1"/>
+          </a:fontRef>
+        </p:style>
+        <p:txBody>
+          <a:bodyPr rtlCol="0" anchor="ctr" wrap="square" lIns="164592" rIns="146304" tIns="128016"/>
+          <a:lstStyle/>
+          <a:p>
+            <a:pPr algn="ctr">
+              <a:defRPr sz="1600" b="1">
+                <a:solidFill>
+                  <a:srgbClr val="FAFAFA"/>
+                </a:solidFill>
+                <a:latin typeface="Calibri"/>
+              </a:defRPr>
+            </a:pPr>
+            <a:r>
+              <a:t>Act</a:t>
+            </a:r>
+          </a:p>
+          <a:p>
+            <a:pPr>
+              <a:defRPr sz="1300">
+                <a:solidFill>
+                  <a:srgbClr val="A1A1AA"/>
+                </a:solidFill>
+                <a:latin typeface="Calibri"/>
+              </a:defRPr>
+            </a:pPr>
+            <a:r>
+              <a:t>Stage an issue or comment. Post only after yes.</a:t>
             </a:r>
           </a:p>
         </p:txBody>
@@ -4081,14 +5330,6 @@
 <file path=ppt/slides/slide6.xml><?xml version="1.0" encoding="utf-8"?>
 <p:sld xmlns:a="http://schemas.openxmlformats.org/drawingml/2006/main" xmlns:p="http://schemas.openxmlformats.org/presentationml/2006/main" xmlns:r="http://schemas.openxmlformats.org/officeDocument/2006/relationships">
   <p:cSld>
-    <p:bg>
-      <p:bgPr>
-        <a:solidFill>
-          <a:srgbClr val="0A0A0A"/>
-        </a:solidFill>
-        <a:effectLst/>
-      </p:bgPr>
-    </p:bg>
     <p:spTree>
       <p:nvGrpSpPr>
         <p:cNvPr id="1" name=""/>
@@ -4098,14 +5339,57 @@
       <p:grpSpPr/>
       <p:sp>
         <p:nvSpPr>
-          <p:cNvPr id="2" name="TextBox 1"/>
+          <p:cNvPr id="2" name="Rectangle 1"/>
+          <p:cNvSpPr/>
+          <p:nvPr/>
+        </p:nvSpPr>
+        <p:spPr>
+          <a:xfrm>
+            <a:off x="0" y="0"/>
+            <a:ext cx="12191695" cy="6858000"/>
+          </a:xfrm>
+          <a:prstGeom prst="rect">
+            <a:avLst/>
+          </a:prstGeom>
+          <a:solidFill>
+            <a:srgbClr val="0B0B0C"/>
+          </a:solidFill>
+          <a:ln>
+            <a:noFill/>
+          </a:ln>
+        </p:spPr>
+        <p:style>
+          <a:lnRef idx="1">
+            <a:schemeClr val="accent1"/>
+          </a:lnRef>
+          <a:fillRef idx="3">
+            <a:schemeClr val="accent1"/>
+          </a:fillRef>
+          <a:effectRef idx="2">
+            <a:schemeClr val="accent1"/>
+          </a:effectRef>
+          <a:fontRef idx="minor">
+            <a:schemeClr val="lt1"/>
+          </a:fontRef>
+        </p:style>
+        <p:txBody>
+          <a:bodyPr rtlCol="0" anchor="ctr"/>
+          <a:lstStyle/>
+          <a:p>
+            <a:pPr algn="ctr"/>
+          </a:p>
+        </p:txBody>
+      </p:sp>
+      <p:sp>
+        <p:nvSpPr>
+          <p:cNvPr id="3" name="TextBox 2"/>
           <p:cNvSpPr txBox="1"/>
           <p:nvPr/>
         </p:nvSpPr>
         <p:spPr>
           <a:xfrm>
-            <a:off x="685800" y="502920"/>
-            <a:ext cx="10515600" cy="1280160"/>
+            <a:off x="502920" y="292608"/>
+            <a:ext cx="7315200" cy="292608"/>
           </a:xfrm>
           <a:prstGeom prst="rect">
             <a:avLst/>
@@ -4113,103 +5397,189 @@
           <a:noFill/>
         </p:spPr>
         <p:txBody>
-          <a:bodyPr wrap="square">
-            <a:spAutoFit/>
-          </a:bodyPr>
+          <a:bodyPr wrap="square"/>
+          <a:lstStyle/>
+          <a:p>
+            <a:pPr algn="l">
+              <a:defRPr sz="1200" b="1">
+                <a:solidFill>
+                  <a:srgbClr val="F97316"/>
+                </a:solidFill>
+                <a:latin typeface="Calibri"/>
+              </a:defRPr>
+            </a:pPr>
+            <a:r>
+              <a:t>THE JOB TO BE DONE</a:t>
+            </a:r>
+          </a:p>
+        </p:txBody>
+      </p:sp>
+      <p:sp>
+        <p:nvSpPr>
+          <p:cNvPr id="4" name="TextBox 3"/>
+          <p:cNvSpPr txBox="1"/>
+          <p:nvPr/>
+        </p:nvSpPr>
+        <p:spPr>
+          <a:xfrm>
+            <a:off x="502920" y="566928"/>
+            <a:ext cx="11155680" cy="640080"/>
+          </a:xfrm>
+          <a:prstGeom prst="rect">
+            <a:avLst/>
+          </a:prstGeom>
+          <a:noFill/>
+        </p:spPr>
+        <p:txBody>
+          <a:bodyPr wrap="square"/>
           <a:lstStyle/>
           <a:p>
             <a:pPr algn="l">
               <a:defRPr sz="3200" b="1">
                 <a:solidFill>
-                  <a:srgbClr val="F97316"/>
-                </a:solidFill>
-              </a:defRPr>
-            </a:pPr>
-            <a:r>
-              <a:t>Product</a:t>
-            </a:r>
-          </a:p>
-        </p:txBody>
-      </p:sp>
-      <p:sp>
-        <p:nvSpPr>
-          <p:cNvPr id="3" name="TextBox 2"/>
-          <p:cNvSpPr txBox="1"/>
-          <p:nvPr/>
-        </p:nvSpPr>
-        <p:spPr>
-          <a:xfrm>
-            <a:off x="777240" y="1325880"/>
-            <a:ext cx="10241280" cy="4754880"/>
-          </a:xfrm>
-          <a:prstGeom prst="rect">
-            <a:avLst/>
-          </a:prstGeom>
-          <a:noFill/>
-        </p:spPr>
-        <p:txBody>
-          <a:bodyPr wrap="square">
-            <a:spAutoFit/>
-          </a:bodyPr>
-          <a:lstStyle/>
+                  <a:srgbClr val="FAFAFA"/>
+                </a:solidFill>
+                <a:latin typeface="Calibri"/>
+              </a:defRPr>
+            </a:pPr>
+            <a:r>
+              <a:t>From tab sprawl to one spoken loop.</a:t>
+            </a:r>
+          </a:p>
+        </p:txBody>
+      </p:sp>
+      <p:sp>
+        <p:nvSpPr>
+          <p:cNvPr id="5" name="Rounded Rectangle 4"/>
+          <p:cNvSpPr/>
+          <p:nvPr/>
+        </p:nvSpPr>
+        <p:spPr>
+          <a:xfrm>
+            <a:off x="457200" y="1554480"/>
+            <a:ext cx="5486400" cy="4389120"/>
+          </a:xfrm>
+          <a:prstGeom prst="roundRect">
+            <a:avLst/>
+          </a:prstGeom>
+          <a:solidFill>
+            <a:srgbClr val="18181B"/>
+          </a:solidFill>
+          <a:ln>
+            <a:solidFill>
+              <a:srgbClr val="3F3F46"/>
+            </a:solidFill>
+          </a:ln>
+        </p:spPr>
+        <p:style>
+          <a:lnRef idx="1">
+            <a:schemeClr val="accent1"/>
+          </a:lnRef>
+          <a:fillRef idx="3">
+            <a:schemeClr val="accent1"/>
+          </a:fillRef>
+          <a:effectRef idx="2">
+            <a:schemeClr val="accent1"/>
+          </a:effectRef>
+          <a:fontRef idx="minor">
+            <a:schemeClr val="lt1"/>
+          </a:fontRef>
+        </p:style>
+        <p:txBody>
+          <a:bodyPr rtlCol="0" anchor="ctr" wrap="square" lIns="164592" rIns="146304" tIns="128016"/>
+          <a:lstStyle/>
+          <a:p>
+            <a:pPr algn="ctr">
+              <a:defRPr sz="1600" b="1">
+                <a:solidFill>
+                  <a:srgbClr val="FAFAFA"/>
+                </a:solidFill>
+                <a:latin typeface="Calibri"/>
+              </a:defRPr>
+            </a:pPr>
+            <a:r>
+              <a:t>Today</a:t>
+            </a:r>
+          </a:p>
           <a:p>
             <a:pPr>
-              <a:spcAft>
-                <a:spcPts val="1400"/>
-              </a:spcAft>
-              <a:defRPr sz="2000">
+              <a:defRPr sz="1300">
+                <a:solidFill>
+                  <a:srgbClr val="A1A1AA"/>
+                </a:solidFill>
+                <a:latin typeface="Calibri"/>
+              </a:defRPr>
+            </a:pPr>
+            <a:r>
+              <a:t>Files in the editor. History in another tab. Issues somewhere else. A chatbot that invents paths. An agent that posts before you look.</a:t>
+            </a:r>
+          </a:p>
+        </p:txBody>
+      </p:sp>
+      <p:sp>
+        <p:nvSpPr>
+          <p:cNvPr id="6" name="Rounded Rectangle 5"/>
+          <p:cNvSpPr/>
+          <p:nvPr/>
+        </p:nvSpPr>
+        <p:spPr>
+          <a:xfrm>
+            <a:off x="6217920" y="1554480"/>
+            <a:ext cx="5486400" cy="4389120"/>
+          </a:xfrm>
+          <a:prstGeom prst="roundRect">
+            <a:avLst/>
+          </a:prstGeom>
+          <a:solidFill>
+            <a:srgbClr val="18181B"/>
+          </a:solidFill>
+          <a:ln>
+            <a:solidFill>
+              <a:srgbClr val="3F3F46"/>
+            </a:solidFill>
+          </a:ln>
+        </p:spPr>
+        <p:style>
+          <a:lnRef idx="1">
+            <a:schemeClr val="accent1"/>
+          </a:lnRef>
+          <a:fillRef idx="3">
+            <a:schemeClr val="accent1"/>
+          </a:fillRef>
+          <a:effectRef idx="2">
+            <a:schemeClr val="accent1"/>
+          </a:effectRef>
+          <a:fontRef idx="minor">
+            <a:schemeClr val="lt1"/>
+          </a:fontRef>
+        </p:style>
+        <p:txBody>
+          <a:bodyPr rtlCol="0" anchor="ctr" wrap="square" lIns="164592" rIns="146304" tIns="128016"/>
+          <a:lstStyle/>
+          <a:p>
+            <a:pPr algn="ctr">
+              <a:defRPr sz="1600" b="1">
                 <a:solidFill>
                   <a:srgbClr val="FAFAFA"/>
                 </a:solidFill>
-              </a:defRPr>
-            </a:pPr>
-            <a:r>
-              <a:t>Circle-pack map — entry points, core, hotspots</a:t>
+                <a:latin typeface="Calibri"/>
+              </a:defRPr>
+            </a:pPr>
+            <a:r>
+              <a:t>With Friday</a:t>
             </a:r>
           </a:p>
           <a:p>
             <a:pPr>
-              <a:spcAft>
-                <a:spcPts val="1400"/>
-              </a:spcAft>
-              <a:defRPr sz="2000">
-                <a:solidFill>
-                  <a:srgbClr val="FAFAFA"/>
-                </a:solidFill>
-              </a:defRPr>
-            </a:pPr>
-            <a:r>
-              <a:t>Landmarks + layers — heat, imports, focus</a:t>
-            </a:r>
-          </a:p>
-          <a:p>
-            <a:pPr>
-              <a:spcAft>
-                <a:spcPts val="1400"/>
-              </a:spcAft>
-              <a:defRPr sz="2000">
-                <a:solidFill>
-                  <a:srgbClr val="FAFAFA"/>
-                </a:solidFill>
-              </a:defRPr>
-            </a:pPr>
-            <a:r>
-              <a:t>Voice (AssemblyAI) + typed Ask — same brain</a:t>
-            </a:r>
-          </a:p>
-          <a:p>
-            <a:pPr>
-              <a:spcAft>
-                <a:spcPts val="1400"/>
-              </a:spcAft>
-              <a:defRPr sz="2000">
-                <a:solidFill>
-                  <a:srgbClr val="FAFAFA"/>
-                </a:solidFill>
-              </a:defRPr>
-            </a:pPr>
-            <a:r>
-              <a:t>Commits, issues, PRs, security scan, merge review</a:t>
+              <a:defRPr sz="1300">
+                <a:solidFill>
+                  <a:srgbClr val="A1A1AA"/>
+                </a:solidFill>
+                <a:latin typeface="Calibri"/>
+              </a:defRPr>
+            </a:pPr>
+            <a:r>
+              <a:t>Map on screen. “What changed?” “Is this safe?” “Open an issue titled …” Draft appears. You say yes on the next turn. Link comes back.</a:t>
             </a:r>
           </a:p>
         </p:txBody>
@@ -4225,14 +5595,6 @@
 <file path=ppt/slides/slide7.xml><?xml version="1.0" encoding="utf-8"?>
 <p:sld xmlns:a="http://schemas.openxmlformats.org/drawingml/2006/main" xmlns:p="http://schemas.openxmlformats.org/presentationml/2006/main" xmlns:r="http://schemas.openxmlformats.org/officeDocument/2006/relationships">
   <p:cSld>
-    <p:bg>
-      <p:bgPr>
-        <a:solidFill>
-          <a:srgbClr val="0A0A0A"/>
-        </a:solidFill>
-        <a:effectLst/>
-      </p:bgPr>
-    </p:bg>
     <p:spTree>
       <p:nvGrpSpPr>
         <p:cNvPr id="1" name=""/>
@@ -4242,60 +5604,23 @@
       <p:grpSpPr/>
       <p:sp>
         <p:nvSpPr>
-          <p:cNvPr id="2" name="TextBox 1"/>
-          <p:cNvSpPr txBox="1"/>
-          <p:nvPr/>
-        </p:nvSpPr>
-        <p:spPr>
-          <a:xfrm>
-            <a:off x="685800" y="411480"/>
-            <a:ext cx="10515600" cy="1280160"/>
+          <p:cNvPr id="2" name="Rectangle 1"/>
+          <p:cNvSpPr/>
+          <p:nvPr/>
+        </p:nvSpPr>
+        <p:spPr>
+          <a:xfrm>
+            <a:off x="0" y="0"/>
+            <a:ext cx="12191695" cy="6858000"/>
           </a:xfrm>
           <a:prstGeom prst="rect">
             <a:avLst/>
           </a:prstGeom>
-          <a:noFill/>
-        </p:spPr>
-        <p:txBody>
-          <a:bodyPr wrap="square">
-            <a:spAutoFit/>
-          </a:bodyPr>
-          <a:lstStyle/>
-          <a:p>
-            <a:pPr algn="l">
-              <a:defRPr sz="3000" b="1">
-                <a:solidFill>
-                  <a:srgbClr val="F97316"/>
-                </a:solidFill>
-              </a:defRPr>
-            </a:pPr>
-            <a:r>
-              <a:t>How Friday works</a:t>
-            </a:r>
-          </a:p>
-        </p:txBody>
-      </p:sp>
-      <p:sp>
-        <p:nvSpPr>
-          <p:cNvPr id="3" name="Rounded Rectangle 2"/>
-          <p:cNvSpPr/>
-          <p:nvPr/>
-        </p:nvSpPr>
-        <p:spPr>
-          <a:xfrm>
-            <a:off x="548640" y="2148840"/>
-            <a:ext cx="2377440" cy="1234440"/>
-          </a:xfrm>
-          <a:prstGeom prst="roundRect">
-            <a:avLst/>
-          </a:prstGeom>
           <a:solidFill>
-            <a:srgbClr val="1C1C1E"/>
+            <a:srgbClr val="0B0B0C"/>
           </a:solidFill>
           <a:ln>
-            <a:solidFill>
-              <a:srgbClr val="F97316"/>
-            </a:solidFill>
+            <a:noFill/>
           </a:ln>
         </p:spPr>
         <p:style>
@@ -4316,50 +5641,99 @@
           <a:bodyPr rtlCol="0" anchor="ctr"/>
           <a:lstStyle/>
           <a:p>
-            <a:pPr algn="ctr">
-              <a:defRPr sz="1800" b="1">
+            <a:pPr algn="ctr"/>
+          </a:p>
+        </p:txBody>
+      </p:sp>
+      <p:sp>
+        <p:nvSpPr>
+          <p:cNvPr id="3" name="TextBox 2"/>
+          <p:cNvSpPr txBox="1"/>
+          <p:nvPr/>
+        </p:nvSpPr>
+        <p:spPr>
+          <a:xfrm>
+            <a:off x="502920" y="292608"/>
+            <a:ext cx="7315200" cy="292608"/>
+          </a:xfrm>
+          <a:prstGeom prst="rect">
+            <a:avLst/>
+          </a:prstGeom>
+          <a:noFill/>
+        </p:spPr>
+        <p:txBody>
+          <a:bodyPr wrap="square"/>
+          <a:lstStyle/>
+          <a:p>
+            <a:pPr algn="l">
+              <a:defRPr sz="1200" b="1">
+                <a:solidFill>
+                  <a:srgbClr val="F97316"/>
+                </a:solidFill>
+                <a:latin typeface="Calibri"/>
+              </a:defRPr>
+            </a:pPr>
+            <a:r>
+              <a:t>SYSTEM</a:t>
+            </a:r>
+          </a:p>
+        </p:txBody>
+      </p:sp>
+      <p:sp>
+        <p:nvSpPr>
+          <p:cNvPr id="4" name="TextBox 3"/>
+          <p:cNvSpPr txBox="1"/>
+          <p:nvPr/>
+        </p:nvSpPr>
+        <p:spPr>
+          <a:xfrm>
+            <a:off x="502920" y="566928"/>
+            <a:ext cx="11155680" cy="640080"/>
+          </a:xfrm>
+          <a:prstGeom prst="rect">
+            <a:avLst/>
+          </a:prstGeom>
+          <a:noFill/>
+        </p:spPr>
+        <p:txBody>
+          <a:bodyPr wrap="square"/>
+          <a:lstStyle/>
+          <a:p>
+            <a:pPr algn="l">
+              <a:defRPr sz="3200" b="1">
                 <a:solidFill>
                   <a:srgbClr val="FAFAFA"/>
                 </a:solidFill>
-              </a:defRPr>
-            </a:pPr>
-            <a:r>
-              <a:t>You</a:t>
-            </a:r>
-          </a:p>
-          <a:p>
-            <a:pPr>
-              <a:defRPr sz="1300">
-                <a:solidFill>
-                  <a:srgbClr val="A1A1AA"/>
-                </a:solidFill>
-              </a:defRPr>
-            </a:pPr>
-            <a:r>
-              <a:t>Voice or text</a:t>
-            </a:r>
-          </a:p>
-        </p:txBody>
-      </p:sp>
-      <p:sp>
-        <p:nvSpPr>
-          <p:cNvPr id="4" name="Right Arrow 3"/>
+                <a:latin typeface="Calibri"/>
+              </a:defRPr>
+            </a:pPr>
+            <a:r>
+              <a:t>One turn. Ground truth. Then consent.</a:t>
+            </a:r>
+          </a:p>
+        </p:txBody>
+      </p:sp>
+      <p:sp>
+        <p:nvSpPr>
+          <p:cNvPr id="5" name="Rounded Rectangle 4"/>
           <p:cNvSpPr/>
           <p:nvPr/>
         </p:nvSpPr>
         <p:spPr>
           <a:xfrm>
-            <a:off x="2971800" y="2560320"/>
-            <a:ext cx="228599" cy="320040"/>
-          </a:xfrm>
-          <a:prstGeom prst="rightArrow">
+            <a:off x="365760" y="1965960"/>
+            <a:ext cx="2148840" cy="2103120"/>
+          </a:xfrm>
+          <a:prstGeom prst="roundRect">
             <a:avLst/>
           </a:prstGeom>
           <a:solidFill>
-            <a:srgbClr val="A1A1AA"/>
+            <a:srgbClr val="18181B"/>
           </a:solidFill>
           <a:ln>
-            <a:noFill/>
+            <a:solidFill>
+              <a:srgbClr val="3F3F46"/>
+            </a:solidFill>
           </a:ln>
         </p:spPr>
         <p:style>
@@ -4377,34 +5751,55 @@
           </a:fontRef>
         </p:style>
         <p:txBody>
-          <a:bodyPr rtlCol="0" anchor="ctr"/>
-          <a:lstStyle/>
-          <a:p>
-            <a:pPr algn="ctr"/>
-          </a:p>
-        </p:txBody>
-      </p:sp>
-      <p:sp>
-        <p:nvSpPr>
-          <p:cNvPr id="5" name="Rounded Rectangle 4"/>
+          <a:bodyPr rtlCol="0" anchor="ctr" wrap="square" lIns="164592" rIns="146304" tIns="128016"/>
+          <a:lstStyle/>
+          <a:p>
+            <a:pPr algn="ctr">
+              <a:defRPr sz="1600" b="1">
+                <a:solidFill>
+                  <a:srgbClr val="FAFAFA"/>
+                </a:solidFill>
+                <a:latin typeface="Calibri"/>
+              </a:defRPr>
+            </a:pPr>
+            <a:r>
+              <a:t>1  You</a:t>
+            </a:r>
+          </a:p>
+          <a:p>
+            <a:pPr>
+              <a:defRPr sz="1300">
+                <a:solidFill>
+                  <a:srgbClr val="A1A1AA"/>
+                </a:solidFill>
+                <a:latin typeface="Calibri"/>
+              </a:defRPr>
+            </a:pPr>
+            <a:r>
+              <a:t>Hold mic or Ask</a:t>
+            </a:r>
+          </a:p>
+        </p:txBody>
+      </p:sp>
+      <p:sp>
+        <p:nvSpPr>
+          <p:cNvPr id="6" name="Right Arrow 5"/>
           <p:cNvSpPr/>
           <p:nvPr/>
         </p:nvSpPr>
         <p:spPr>
           <a:xfrm>
-            <a:off x="3246120" y="2148840"/>
-            <a:ext cx="2377440" cy="1234440"/>
-          </a:xfrm>
-          <a:prstGeom prst="roundRect">
+            <a:off x="2450591" y="2834640"/>
+            <a:ext cx="201168" cy="256032"/>
+          </a:xfrm>
+          <a:prstGeom prst="rightArrow">
             <a:avLst/>
           </a:prstGeom>
           <a:solidFill>
-            <a:srgbClr val="1C1C1E"/>
+            <a:srgbClr val="F97316"/>
           </a:solidFill>
           <a:ln>
-            <a:solidFill>
-              <a:srgbClr val="F97316"/>
-            </a:solidFill>
+            <a:noFill/>
           </a:ln>
         </p:spPr>
         <p:style>
@@ -4425,50 +5820,31 @@
           <a:bodyPr rtlCol="0" anchor="ctr"/>
           <a:lstStyle/>
           <a:p>
-            <a:pPr algn="ctr">
-              <a:defRPr sz="1800" b="1">
-                <a:solidFill>
-                  <a:srgbClr val="FAFAFA"/>
-                </a:solidFill>
-              </a:defRPr>
-            </a:pPr>
-            <a:r>
-              <a:t>Friday</a:t>
-            </a:r>
-          </a:p>
-          <a:p>
-            <a:pPr>
-              <a:defRPr sz="1300">
-                <a:solidFill>
-                  <a:srgbClr val="A1A1AA"/>
-                </a:solidFill>
-              </a:defRPr>
-            </a:pPr>
-            <a:r>
-              <a:t>Route + tools</a:t>
-            </a:r>
-          </a:p>
-        </p:txBody>
-      </p:sp>
-      <p:sp>
-        <p:nvSpPr>
-          <p:cNvPr id="6" name="Right Arrow 5"/>
+            <a:pPr algn="ctr"/>
+          </a:p>
+        </p:txBody>
+      </p:sp>
+      <p:sp>
+        <p:nvSpPr>
+          <p:cNvPr id="7" name="Rounded Rectangle 6"/>
           <p:cNvSpPr/>
           <p:nvPr/>
         </p:nvSpPr>
         <p:spPr>
           <a:xfrm>
-            <a:off x="5669280" y="2560320"/>
-            <a:ext cx="228599" cy="320040"/>
-          </a:xfrm>
-          <a:prstGeom prst="rightArrow">
+            <a:off x="2697479" y="1965960"/>
+            <a:ext cx="2148840" cy="2103120"/>
+          </a:xfrm>
+          <a:prstGeom prst="roundRect">
             <a:avLst/>
           </a:prstGeom>
           <a:solidFill>
-            <a:srgbClr val="A1A1AA"/>
+            <a:srgbClr val="18181B"/>
           </a:solidFill>
           <a:ln>
-            <a:noFill/>
+            <a:solidFill>
+              <a:srgbClr val="3F3F46"/>
+            </a:solidFill>
           </a:ln>
         </p:spPr>
         <p:style>
@@ -4486,34 +5862,55 @@
           </a:fontRef>
         </p:style>
         <p:txBody>
-          <a:bodyPr rtlCol="0" anchor="ctr"/>
-          <a:lstStyle/>
-          <a:p>
-            <a:pPr algn="ctr"/>
-          </a:p>
-        </p:txBody>
-      </p:sp>
-      <p:sp>
-        <p:nvSpPr>
-          <p:cNvPr id="7" name="Rounded Rectangle 6"/>
+          <a:bodyPr rtlCol="0" anchor="ctr" wrap="square" lIns="164592" rIns="146304" tIns="128016"/>
+          <a:lstStyle/>
+          <a:p>
+            <a:pPr algn="ctr">
+              <a:defRPr sz="1600" b="1">
+                <a:solidFill>
+                  <a:srgbClr val="FAFAFA"/>
+                </a:solidFill>
+                <a:latin typeface="Calibri"/>
+              </a:defRPr>
+            </a:pPr>
+            <a:r>
+              <a:t>2  Route</a:t>
+            </a:r>
+          </a:p>
+          <a:p>
+            <a:pPr>
+              <a:defRPr sz="1300">
+                <a:solidFill>
+                  <a:srgbClr val="A1A1AA"/>
+                </a:solidFill>
+                <a:latin typeface="Calibri"/>
+              </a:defRPr>
+            </a:pPr>
+            <a:r>
+              <a:t>Parser, Jev, or Gateway</a:t>
+            </a:r>
+          </a:p>
+        </p:txBody>
+      </p:sp>
+      <p:sp>
+        <p:nvSpPr>
+          <p:cNvPr id="8" name="Right Arrow 7"/>
           <p:cNvSpPr/>
           <p:nvPr/>
         </p:nvSpPr>
         <p:spPr>
           <a:xfrm>
-            <a:off x="5943600" y="2148840"/>
-            <a:ext cx="2377440" cy="1234440"/>
-          </a:xfrm>
-          <a:prstGeom prst="roundRect">
+            <a:off x="4782312" y="2834640"/>
+            <a:ext cx="201168" cy="256032"/>
+          </a:xfrm>
+          <a:prstGeom prst="rightArrow">
             <a:avLst/>
           </a:prstGeom>
           <a:solidFill>
-            <a:srgbClr val="1C1C1E"/>
+            <a:srgbClr val="F97316"/>
           </a:solidFill>
           <a:ln>
-            <a:solidFill>
-              <a:srgbClr val="F97316"/>
-            </a:solidFill>
+            <a:noFill/>
           </a:ln>
         </p:spPr>
         <p:style>
@@ -4534,50 +5931,31 @@
           <a:bodyPr rtlCol="0" anchor="ctr"/>
           <a:lstStyle/>
           <a:p>
-            <a:pPr algn="ctr">
-              <a:defRPr sz="1800" b="1">
-                <a:solidFill>
-                  <a:srgbClr val="FAFAFA"/>
-                </a:solidFill>
-              </a:defRPr>
-            </a:pPr>
-            <a:r>
-              <a:t>Map + GitHub</a:t>
-            </a:r>
-          </a:p>
-          <a:p>
-            <a:pPr>
-              <a:defRPr sz="1300">
-                <a:solidFill>
-                  <a:srgbClr val="A1A1AA"/>
-                </a:solidFill>
-              </a:defRPr>
-            </a:pPr>
-            <a:r>
-              <a:t>Ground truth</a:t>
-            </a:r>
-          </a:p>
-        </p:txBody>
-      </p:sp>
-      <p:sp>
-        <p:nvSpPr>
-          <p:cNvPr id="8" name="Right Arrow 7"/>
+            <a:pPr algn="ctr"/>
+          </a:p>
+        </p:txBody>
+      </p:sp>
+      <p:sp>
+        <p:nvSpPr>
+          <p:cNvPr id="9" name="Rounded Rectangle 8"/>
           <p:cNvSpPr/>
           <p:nvPr/>
         </p:nvSpPr>
         <p:spPr>
           <a:xfrm>
-            <a:off x="8366760" y="2560320"/>
-            <a:ext cx="228599" cy="320040"/>
-          </a:xfrm>
-          <a:prstGeom prst="rightArrow">
+            <a:off x="5029200" y="1965960"/>
+            <a:ext cx="2148840" cy="2103120"/>
+          </a:xfrm>
+          <a:prstGeom prst="roundRect">
             <a:avLst/>
           </a:prstGeom>
           <a:solidFill>
-            <a:srgbClr val="A1A1AA"/>
+            <a:srgbClr val="18181B"/>
           </a:solidFill>
           <a:ln>
-            <a:noFill/>
+            <a:solidFill>
+              <a:srgbClr val="3F3F46"/>
+            </a:solidFill>
           </a:ln>
         </p:spPr>
         <p:style>
@@ -4595,34 +5973,55 @@
           </a:fontRef>
         </p:style>
         <p:txBody>
-          <a:bodyPr rtlCol="0" anchor="ctr"/>
-          <a:lstStyle/>
-          <a:p>
-            <a:pPr algn="ctr"/>
-          </a:p>
-        </p:txBody>
-      </p:sp>
-      <p:sp>
-        <p:nvSpPr>
-          <p:cNvPr id="9" name="Rounded Rectangle 8"/>
+          <a:bodyPr rtlCol="0" anchor="ctr" wrap="square" lIns="164592" rIns="146304" tIns="128016"/>
+          <a:lstStyle/>
+          <a:p>
+            <a:pPr algn="ctr">
+              <a:defRPr sz="1600" b="1">
+                <a:solidFill>
+                  <a:srgbClr val="FAFAFA"/>
+                </a:solidFill>
+                <a:latin typeface="Calibri"/>
+              </a:defRPr>
+            </a:pPr>
+            <a:r>
+              <a:t>3  Truth</a:t>
+            </a:r>
+          </a:p>
+          <a:p>
+            <a:pPr>
+              <a:defRPr sz="1300">
+                <a:solidFill>
+                  <a:srgbClr val="A1A1AA"/>
+                </a:solidFill>
+                <a:latin typeface="Calibri"/>
+              </a:defRPr>
+            </a:pPr>
+            <a:r>
+              <a:t>Map + GitHub APIs</a:t>
+            </a:r>
+          </a:p>
+        </p:txBody>
+      </p:sp>
+      <p:sp>
+        <p:nvSpPr>
+          <p:cNvPr id="10" name="Right Arrow 9"/>
           <p:cNvSpPr/>
           <p:nvPr/>
         </p:nvSpPr>
         <p:spPr>
           <a:xfrm>
-            <a:off x="8641080" y="2148840"/>
-            <a:ext cx="2377440" cy="1234440"/>
-          </a:xfrm>
-          <a:prstGeom prst="roundRect">
+            <a:off x="7114031" y="2834640"/>
+            <a:ext cx="201168" cy="256032"/>
+          </a:xfrm>
+          <a:prstGeom prst="rightArrow">
             <a:avLst/>
           </a:prstGeom>
           <a:solidFill>
-            <a:srgbClr val="1C1C1E"/>
+            <a:srgbClr val="F97316"/>
           </a:solidFill>
           <a:ln>
-            <a:solidFill>
-              <a:srgbClr val="F97316"/>
-            </a:solidFill>
+            <a:noFill/>
           </a:ln>
         </p:spPr>
         <p:style>
@@ -4643,15 +6042,61 @@
           <a:bodyPr rtlCol="0" anchor="ctr"/>
           <a:lstStyle/>
           <a:p>
+            <a:pPr algn="ctr"/>
+          </a:p>
+        </p:txBody>
+      </p:sp>
+      <p:sp>
+        <p:nvSpPr>
+          <p:cNvPr id="11" name="Rounded Rectangle 10"/>
+          <p:cNvSpPr/>
+          <p:nvPr/>
+        </p:nvSpPr>
+        <p:spPr>
+          <a:xfrm>
+            <a:off x="7360919" y="1965960"/>
+            <a:ext cx="2148840" cy="2103120"/>
+          </a:xfrm>
+          <a:prstGeom prst="roundRect">
+            <a:avLst/>
+          </a:prstGeom>
+          <a:solidFill>
+            <a:srgbClr val="18181B"/>
+          </a:solidFill>
+          <a:ln>
+            <a:solidFill>
+              <a:srgbClr val="3F3F46"/>
+            </a:solidFill>
+          </a:ln>
+        </p:spPr>
+        <p:style>
+          <a:lnRef idx="1">
+            <a:schemeClr val="accent1"/>
+          </a:lnRef>
+          <a:fillRef idx="3">
+            <a:schemeClr val="accent1"/>
+          </a:fillRef>
+          <a:effectRef idx="2">
+            <a:schemeClr val="accent1"/>
+          </a:effectRef>
+          <a:fontRef idx="minor">
+            <a:schemeClr val="lt1"/>
+          </a:fontRef>
+        </p:style>
+        <p:txBody>
+          <a:bodyPr rtlCol="0" anchor="ctr" wrap="square" lIns="164592" rIns="146304" tIns="128016"/>
+          <a:lstStyle/>
+          <a:p>
             <a:pPr algn="ctr">
-              <a:defRPr sz="1800" b="1">
+              <a:defRPr sz="1600" b="1">
                 <a:solidFill>
                   <a:srgbClr val="FAFAFA"/>
                 </a:solidFill>
-              </a:defRPr>
-            </a:pPr>
-            <a:r>
-              <a:t>You</a:t>
+                <a:latin typeface="Calibri"/>
+              </a:defRPr>
+            </a:pPr>
+            <a:r>
+              <a:t>4  Say</a:t>
             </a:r>
           </a:p>
           <a:p>
@@ -4660,24 +6105,136 @@
                 <a:solidFill>
                   <a:srgbClr val="A1A1AA"/>
                 </a:solidFill>
-              </a:defRPr>
-            </a:pPr>
-            <a:r>
-              <a:t>Yes to post</a:t>
-            </a:r>
-          </a:p>
-        </p:txBody>
-      </p:sp>
-      <p:sp>
-        <p:nvSpPr>
-          <p:cNvPr id="10" name="TextBox 9"/>
+                <a:latin typeface="Calibri"/>
+              </a:defRPr>
+            </a:pPr>
+            <a:r>
+              <a:t>Spoken + on-screen</a:t>
+            </a:r>
+          </a:p>
+        </p:txBody>
+      </p:sp>
+      <p:sp>
+        <p:nvSpPr>
+          <p:cNvPr id="12" name="Right Arrow 11"/>
+          <p:cNvSpPr/>
+          <p:nvPr/>
+        </p:nvSpPr>
+        <p:spPr>
+          <a:xfrm>
+            <a:off x="9445751" y="2834640"/>
+            <a:ext cx="201168" cy="256032"/>
+          </a:xfrm>
+          <a:prstGeom prst="rightArrow">
+            <a:avLst/>
+          </a:prstGeom>
+          <a:solidFill>
+            <a:srgbClr val="F97316"/>
+          </a:solidFill>
+          <a:ln>
+            <a:noFill/>
+          </a:ln>
+        </p:spPr>
+        <p:style>
+          <a:lnRef idx="1">
+            <a:schemeClr val="accent1"/>
+          </a:lnRef>
+          <a:fillRef idx="3">
+            <a:schemeClr val="accent1"/>
+          </a:fillRef>
+          <a:effectRef idx="2">
+            <a:schemeClr val="accent1"/>
+          </a:effectRef>
+          <a:fontRef idx="minor">
+            <a:schemeClr val="lt1"/>
+          </a:fontRef>
+        </p:style>
+        <p:txBody>
+          <a:bodyPr rtlCol="0" anchor="ctr"/>
+          <a:lstStyle/>
+          <a:p>
+            <a:pPr algn="ctr"/>
+          </a:p>
+        </p:txBody>
+      </p:sp>
+      <p:sp>
+        <p:nvSpPr>
+          <p:cNvPr id="13" name="Rounded Rectangle 12"/>
+          <p:cNvSpPr/>
+          <p:nvPr/>
+        </p:nvSpPr>
+        <p:spPr>
+          <a:xfrm>
+            <a:off x="9692640" y="1965960"/>
+            <a:ext cx="2148840" cy="2103120"/>
+          </a:xfrm>
+          <a:prstGeom prst="roundRect">
+            <a:avLst/>
+          </a:prstGeom>
+          <a:solidFill>
+            <a:srgbClr val="18181B"/>
+          </a:solidFill>
+          <a:ln>
+            <a:solidFill>
+              <a:srgbClr val="3F3F46"/>
+            </a:solidFill>
+          </a:ln>
+        </p:spPr>
+        <p:style>
+          <a:lnRef idx="1">
+            <a:schemeClr val="accent1"/>
+          </a:lnRef>
+          <a:fillRef idx="3">
+            <a:schemeClr val="accent1"/>
+          </a:fillRef>
+          <a:effectRef idx="2">
+            <a:schemeClr val="accent1"/>
+          </a:effectRef>
+          <a:fontRef idx="minor">
+            <a:schemeClr val="lt1"/>
+          </a:fontRef>
+        </p:style>
+        <p:txBody>
+          <a:bodyPr rtlCol="0" anchor="ctr" wrap="square" lIns="164592" rIns="146304" tIns="128016"/>
+          <a:lstStyle/>
+          <a:p>
+            <a:pPr algn="ctr">
+              <a:defRPr sz="1600" b="1">
+                <a:solidFill>
+                  <a:srgbClr val="FAFAFA"/>
+                </a:solidFill>
+                <a:latin typeface="Calibri"/>
+              </a:defRPr>
+            </a:pPr>
+            <a:r>
+              <a:t>5  Yes</a:t>
+            </a:r>
+          </a:p>
+          <a:p>
+            <a:pPr>
+              <a:defRPr sz="1300">
+                <a:solidFill>
+                  <a:srgbClr val="A1A1AA"/>
+                </a:solidFill>
+                <a:latin typeface="Calibri"/>
+              </a:defRPr>
+            </a:pPr>
+            <a:r>
+              <a:t>Only then we post</a:t>
+            </a:r>
+          </a:p>
+        </p:txBody>
+      </p:sp>
+      <p:sp>
+        <p:nvSpPr>
+          <p:cNvPr id="14" name="TextBox 13"/>
           <p:cNvSpPr txBox="1"/>
           <p:nvPr/>
         </p:nvSpPr>
         <p:spPr>
           <a:xfrm>
-            <a:off x="685800" y="3794760"/>
-            <a:ext cx="10515600" cy="1097280"/>
+            <a:off x="502920" y="4389120"/>
+            <a:ext cx="10972800" cy="1280160"/>
           </a:xfrm>
           <a:prstGeom prst="rect">
             <a:avLst/>
@@ -4685,20 +6242,19 @@
           <a:noFill/>
         </p:spPr>
         <p:txBody>
-          <a:bodyPr wrap="none">
-            <a:spAutoFit/>
-          </a:bodyPr>
-          <a:lstStyle/>
-          <a:p>
-            <a:pPr>
-              <a:defRPr sz="1600">
+          <a:bodyPr wrap="square"/>
+          <a:lstStyle/>
+          <a:p>
+            <a:pPr algn="l">
+              <a:defRPr sz="1600" b="0">
                 <a:solidFill>
                   <a:srgbClr val="A1A1AA"/>
                 </a:solidFill>
-              </a:defRPr>
-            </a:pPr>
-            <a:r>
-              <a:t>Jev picks map tools · Gateway loop for multi-step GitHub · Writes never auto-post</a:t>
+                <a:latin typeface="Calibri"/>
+              </a:defRPr>
+            </a:pPr>
+            <a:r>
+              <a:t>Direct phrases (yes / no / “comment on issue 2”) never wait on a model. Multi-step triage can use an 8-turn tool loop. Map questions stay on the orchestrator.</a:t>
             </a:r>
           </a:p>
         </p:txBody>
@@ -4714,14 +6270,6 @@
 <file path=ppt/slides/slide8.xml><?xml version="1.0" encoding="utf-8"?>
 <p:sld xmlns:a="http://schemas.openxmlformats.org/drawingml/2006/main" xmlns:p="http://schemas.openxmlformats.org/presentationml/2006/main" xmlns:r="http://schemas.openxmlformats.org/officeDocument/2006/relationships">
   <p:cSld>
-    <p:bg>
-      <p:bgPr>
-        <a:solidFill>
-          <a:srgbClr val="0A0A0A"/>
-        </a:solidFill>
-        <a:effectLst/>
-      </p:bgPr>
-    </p:bg>
     <p:spTree>
       <p:nvGrpSpPr>
         <p:cNvPr id="1" name=""/>
@@ -4731,14 +6279,57 @@
       <p:grpSpPr/>
       <p:sp>
         <p:nvSpPr>
-          <p:cNvPr id="2" name="TextBox 1"/>
+          <p:cNvPr id="2" name="Rectangle 1"/>
+          <p:cNvSpPr/>
+          <p:nvPr/>
+        </p:nvSpPr>
+        <p:spPr>
+          <a:xfrm>
+            <a:off x="0" y="0"/>
+            <a:ext cx="12191695" cy="6858000"/>
+          </a:xfrm>
+          <a:prstGeom prst="rect">
+            <a:avLst/>
+          </a:prstGeom>
+          <a:solidFill>
+            <a:srgbClr val="0B0B0C"/>
+          </a:solidFill>
+          <a:ln>
+            <a:noFill/>
+          </a:ln>
+        </p:spPr>
+        <p:style>
+          <a:lnRef idx="1">
+            <a:schemeClr val="accent1"/>
+          </a:lnRef>
+          <a:fillRef idx="3">
+            <a:schemeClr val="accent1"/>
+          </a:fillRef>
+          <a:effectRef idx="2">
+            <a:schemeClr val="accent1"/>
+          </a:effectRef>
+          <a:fontRef idx="minor">
+            <a:schemeClr val="lt1"/>
+          </a:fontRef>
+        </p:style>
+        <p:txBody>
+          <a:bodyPr rtlCol="0" anchor="ctr"/>
+          <a:lstStyle/>
+          <a:p>
+            <a:pPr algn="ctr"/>
+          </a:p>
+        </p:txBody>
+      </p:sp>
+      <p:sp>
+        <p:nvSpPr>
+          <p:cNvPr id="3" name="TextBox 2"/>
           <p:cNvSpPr txBox="1"/>
           <p:nvPr/>
         </p:nvSpPr>
         <p:spPr>
           <a:xfrm>
-            <a:off x="685800" y="502920"/>
-            <a:ext cx="10515600" cy="1280160"/>
+            <a:off x="502920" y="292608"/>
+            <a:ext cx="7315200" cy="292608"/>
           </a:xfrm>
           <a:prstGeom prst="rect">
             <a:avLst/>
@@ -4746,34 +6337,339 @@
           <a:noFill/>
         </p:spPr>
         <p:txBody>
-          <a:bodyPr wrap="square">
-            <a:spAutoFit/>
-          </a:bodyPr>
+          <a:bodyPr wrap="square"/>
+          <a:lstStyle/>
+          <a:p>
+            <a:pPr algn="l">
+              <a:defRPr sz="1200" b="1">
+                <a:solidFill>
+                  <a:srgbClr val="F97316"/>
+                </a:solidFill>
+                <a:latin typeface="Calibri"/>
+              </a:defRPr>
+            </a:pPr>
+            <a:r>
+              <a:t>ARCHITECTURE</a:t>
+            </a:r>
+          </a:p>
+        </p:txBody>
+      </p:sp>
+      <p:sp>
+        <p:nvSpPr>
+          <p:cNvPr id="4" name="TextBox 3"/>
+          <p:cNvSpPr txBox="1"/>
+          <p:nvPr/>
+        </p:nvSpPr>
+        <p:spPr>
+          <a:xfrm>
+            <a:off x="502920" y="566928"/>
+            <a:ext cx="11155680" cy="640080"/>
+          </a:xfrm>
+          <a:prstGeom prst="rect">
+            <a:avLst/>
+          </a:prstGeom>
+          <a:noFill/>
+        </p:spPr>
+        <p:txBody>
+          <a:bodyPr wrap="square"/>
           <a:lstStyle/>
           <a:p>
             <a:pPr algn="l">
               <a:defRPr sz="3200" b="1">
                 <a:solidFill>
-                  <a:srgbClr val="F97316"/>
-                </a:solidFill>
-              </a:defRPr>
-            </a:pPr>
-            <a:r>
-              <a:t>Human in the loop</a:t>
-            </a:r>
-          </a:p>
-        </p:txBody>
-      </p:sp>
-      <p:sp>
-        <p:nvSpPr>
-          <p:cNvPr id="3" name="TextBox 2"/>
+                  <a:srgbClr val="FAFAFA"/>
+                </a:solidFill>
+                <a:latin typeface="Calibri"/>
+              </a:defRPr>
+            </a:pPr>
+            <a:r>
+              <a:t>Browser talks. Server decides. GitHub waits.</a:t>
+            </a:r>
+          </a:p>
+        </p:txBody>
+      </p:sp>
+      <p:sp>
+        <p:nvSpPr>
+          <p:cNvPr id="5" name="Rounded Rectangle 4"/>
+          <p:cNvSpPr/>
+          <p:nvPr/>
+        </p:nvSpPr>
+        <p:spPr>
+          <a:xfrm>
+            <a:off x="457200" y="1645920"/>
+            <a:ext cx="2651760" cy="3291840"/>
+          </a:xfrm>
+          <a:prstGeom prst="roundRect">
+            <a:avLst/>
+          </a:prstGeom>
+          <a:solidFill>
+            <a:srgbClr val="18181B"/>
+          </a:solidFill>
+          <a:ln>
+            <a:solidFill>
+              <a:srgbClr val="3F3F46"/>
+            </a:solidFill>
+          </a:ln>
+        </p:spPr>
+        <p:style>
+          <a:lnRef idx="1">
+            <a:schemeClr val="accent1"/>
+          </a:lnRef>
+          <a:fillRef idx="3">
+            <a:schemeClr val="accent1"/>
+          </a:fillRef>
+          <a:effectRef idx="2">
+            <a:schemeClr val="accent1"/>
+          </a:effectRef>
+          <a:fontRef idx="minor">
+            <a:schemeClr val="lt1"/>
+          </a:fontRef>
+        </p:style>
+        <p:txBody>
+          <a:bodyPr rtlCol="0" anchor="ctr" wrap="square" lIns="164592" rIns="146304" tIns="128016"/>
+          <a:lstStyle/>
+          <a:p>
+            <a:pPr algn="ctr">
+              <a:defRPr sz="1600" b="1">
+                <a:solidFill>
+                  <a:srgbClr val="FAFAFA"/>
+                </a:solidFill>
+                <a:latin typeface="Calibri"/>
+              </a:defRPr>
+            </a:pPr>
+            <a:r>
+              <a:t>Browser</a:t>
+            </a:r>
+          </a:p>
+          <a:p>
+            <a:pPr>
+              <a:defRPr sz="1300">
+                <a:solidFill>
+                  <a:srgbClr val="A1A1AA"/>
+                </a:solidFill>
+                <a:latin typeface="Calibri"/>
+              </a:defRPr>
+            </a:pPr>
+            <a:r>
+              <a:t>D3 map · hold-to-talk · Ask · markdown links</a:t>
+            </a:r>
+          </a:p>
+        </p:txBody>
+      </p:sp>
+      <p:sp>
+        <p:nvSpPr>
+          <p:cNvPr id="6" name="Rounded Rectangle 5"/>
+          <p:cNvSpPr/>
+          <p:nvPr/>
+        </p:nvSpPr>
+        <p:spPr>
+          <a:xfrm>
+            <a:off x="3246120" y="1645920"/>
+            <a:ext cx="2651760" cy="3291840"/>
+          </a:xfrm>
+          <a:prstGeom prst="roundRect">
+            <a:avLst/>
+          </a:prstGeom>
+          <a:solidFill>
+            <a:srgbClr val="18181B"/>
+          </a:solidFill>
+          <a:ln>
+            <a:solidFill>
+              <a:srgbClr val="3F3F46"/>
+            </a:solidFill>
+          </a:ln>
+        </p:spPr>
+        <p:style>
+          <a:lnRef idx="1">
+            <a:schemeClr val="accent1"/>
+          </a:lnRef>
+          <a:fillRef idx="3">
+            <a:schemeClr val="accent1"/>
+          </a:fillRef>
+          <a:effectRef idx="2">
+            <a:schemeClr val="accent1"/>
+          </a:effectRef>
+          <a:fontRef idx="minor">
+            <a:schemeClr val="lt1"/>
+          </a:fontRef>
+        </p:style>
+        <p:txBody>
+          <a:bodyPr rtlCol="0" anchor="ctr" wrap="square" lIns="164592" rIns="146304" tIns="128016"/>
+          <a:lstStyle/>
+          <a:p>
+            <a:pPr algn="ctr">
+              <a:defRPr sz="1600" b="1">
+                <a:solidFill>
+                  <a:srgbClr val="FAFAFA"/>
+                </a:solidFill>
+                <a:latin typeface="Calibri"/>
+              </a:defRPr>
+            </a:pPr>
+            <a:r>
+              <a:t>Voice</a:t>
+            </a:r>
+          </a:p>
+          <a:p>
+            <a:pPr>
+              <a:defRPr sz="1300">
+                <a:solidFill>
+                  <a:srgbClr val="A1A1AA"/>
+                </a:solidFill>
+                <a:latin typeface="Calibri"/>
+              </a:defRPr>
+            </a:pPr>
+            <a:r>
+              <a:t>AssemblyAI Voice Agent · friday_turn</a:t>
+            </a:r>
+          </a:p>
+        </p:txBody>
+      </p:sp>
+      <p:sp>
+        <p:nvSpPr>
+          <p:cNvPr id="7" name="Rounded Rectangle 6"/>
+          <p:cNvSpPr/>
+          <p:nvPr/>
+        </p:nvSpPr>
+        <p:spPr>
+          <a:xfrm>
+            <a:off x="6035040" y="1645920"/>
+            <a:ext cx="2651760" cy="3291840"/>
+          </a:xfrm>
+          <a:prstGeom prst="roundRect">
+            <a:avLst/>
+          </a:prstGeom>
+          <a:solidFill>
+            <a:srgbClr val="18181B"/>
+          </a:solidFill>
+          <a:ln>
+            <a:solidFill>
+              <a:srgbClr val="3F3F46"/>
+            </a:solidFill>
+          </a:ln>
+        </p:spPr>
+        <p:style>
+          <a:lnRef idx="1">
+            <a:schemeClr val="accent1"/>
+          </a:lnRef>
+          <a:fillRef idx="3">
+            <a:schemeClr val="accent1"/>
+          </a:fillRef>
+          <a:effectRef idx="2">
+            <a:schemeClr val="accent1"/>
+          </a:effectRef>
+          <a:fontRef idx="minor">
+            <a:schemeClr val="lt1"/>
+          </a:fontRef>
+        </p:style>
+        <p:txBody>
+          <a:bodyPr rtlCol="0" anchor="ctr" wrap="square" lIns="164592" rIns="146304" tIns="128016"/>
+          <a:lstStyle/>
+          <a:p>
+            <a:pPr algn="ctr">
+              <a:defRPr sz="1600" b="1">
+                <a:solidFill>
+                  <a:srgbClr val="FAFAFA"/>
+                </a:solidFill>
+                <a:latin typeface="Calibri"/>
+              </a:defRPr>
+            </a:pPr>
+            <a:r>
+              <a:t>Friday</a:t>
+            </a:r>
+          </a:p>
+          <a:p>
+            <a:pPr>
+              <a:defRPr sz="1300">
+                <a:solidFill>
+                  <a:srgbClr val="A1A1AA"/>
+                </a:solidFill>
+                <a:latin typeface="Calibri"/>
+              </a:defRPr>
+            </a:pPr>
+            <a:r>
+              <a:t>chat.turn · orchestrator · review gate</a:t>
+            </a:r>
+          </a:p>
+        </p:txBody>
+      </p:sp>
+      <p:sp>
+        <p:nvSpPr>
+          <p:cNvPr id="8" name="Rounded Rectangle 7"/>
+          <p:cNvSpPr/>
+          <p:nvPr/>
+        </p:nvSpPr>
+        <p:spPr>
+          <a:xfrm>
+            <a:off x="8823960" y="1645920"/>
+            <a:ext cx="2651760" cy="3291840"/>
+          </a:xfrm>
+          <a:prstGeom prst="roundRect">
+            <a:avLst/>
+          </a:prstGeom>
+          <a:solidFill>
+            <a:srgbClr val="18181B"/>
+          </a:solidFill>
+          <a:ln>
+            <a:solidFill>
+              <a:srgbClr val="3F3F46"/>
+            </a:solidFill>
+          </a:ln>
+        </p:spPr>
+        <p:style>
+          <a:lnRef idx="1">
+            <a:schemeClr val="accent1"/>
+          </a:lnRef>
+          <a:fillRef idx="3">
+            <a:schemeClr val="accent1"/>
+          </a:fillRef>
+          <a:effectRef idx="2">
+            <a:schemeClr val="accent1"/>
+          </a:effectRef>
+          <a:fontRef idx="minor">
+            <a:schemeClr val="lt1"/>
+          </a:fontRef>
+        </p:style>
+        <p:txBody>
+          <a:bodyPr rtlCol="0" anchor="ctr" wrap="square" lIns="164592" rIns="146304" tIns="128016"/>
+          <a:lstStyle/>
+          <a:p>
+            <a:pPr algn="ctr">
+              <a:defRPr sz="1600" b="1">
+                <a:solidFill>
+                  <a:srgbClr val="FAFAFA"/>
+                </a:solidFill>
+                <a:latin typeface="Calibri"/>
+              </a:defRPr>
+            </a:pPr>
+            <a:r>
+              <a:t>Outside</a:t>
+            </a:r>
+          </a:p>
+          <a:p>
+            <a:pPr>
+              <a:defRPr sz="1300">
+                <a:solidFill>
+                  <a:srgbClr val="A1A1AA"/>
+                </a:solidFill>
+                <a:latin typeface="Calibri"/>
+              </a:defRPr>
+            </a:pPr>
+            <a:r>
+              <a:t>GitHub · LLM Gateway · optional Jev / K2</a:t>
+            </a:r>
+          </a:p>
+        </p:txBody>
+      </p:sp>
+      <p:sp>
+        <p:nvSpPr>
+          <p:cNvPr id="9" name="TextBox 8"/>
           <p:cNvSpPr txBox="1"/>
           <p:nvPr/>
         </p:nvSpPr>
         <p:spPr>
           <a:xfrm>
-            <a:off x="777240" y="1325880"/>
-            <a:ext cx="10241280" cy="4754880"/>
+            <a:off x="502920" y="5303520"/>
+            <a:ext cx="10972800" cy="731520"/>
           </a:xfrm>
           <a:prstGeom prst="rect">
             <a:avLst/>
@@ -4781,68 +6677,19 @@
           <a:noFill/>
         </p:spPr>
         <p:txBody>
-          <a:bodyPr wrap="square">
-            <a:spAutoFit/>
-          </a:bodyPr>
-          <a:lstStyle/>
-          <a:p>
-            <a:pPr>
-              <a:spcAft>
-                <a:spcPts val="1400"/>
-              </a:spcAft>
-              <a:defRPr sz="2000">
+          <a:bodyPr wrap="square"/>
+          <a:lstStyle/>
+          <a:p>
+            <a:pPr algn="l">
+              <a:defRPr sz="1600" b="0">
                 <a:solidFill>
                   <a:srgbClr val="FAFAFA"/>
                 </a:solidFill>
-              </a:defRPr>
-            </a:pPr>
-            <a:r>
-              <a:t>create_issue / add_comment → draft only</a:t>
-            </a:r>
-          </a:p>
-          <a:p>
-            <a:pPr>
-              <a:spcAft>
-                <a:spcPts val="1400"/>
-              </a:spcAft>
-              <a:defRPr sz="2000">
-                <a:solidFill>
-                  <a:srgbClr val="FAFAFA"/>
-                </a:solidFill>
-              </a:defRPr>
-            </a:pPr>
-            <a:r>
-              <a:t>Separate turn: yes → confirm_write posts</a:t>
-            </a:r>
-          </a:p>
-          <a:p>
-            <a:pPr>
-              <a:spcAft>
-                <a:spcPts val="1400"/>
-              </a:spcAft>
-              <a:defRPr sz="2000">
-                <a:solidFill>
-                  <a:srgbClr val="FAFAFA"/>
-                </a:solidFill>
-              </a:defRPr>
-            </a:pPr>
-            <a:r>
-              <a:t>No silent auto-merge, no drive-by comments</a:t>
-            </a:r>
-          </a:p>
-          <a:p>
-            <a:pPr>
-              <a:spcAft>
-                <a:spcPts val="1400"/>
-              </a:spcAft>
-              <a:defRPr sz="2000">
-                <a:solidFill>
-                  <a:srgbClr val="FAFAFA"/>
-                </a:solidFill>
-              </a:defRPr>
-            </a:pPr>
-            <a:r>
-              <a:t>OAuth + tokens stay server-side</a:t>
+                <a:latin typeface="Calibri"/>
+              </a:defRPr>
+            </a:pPr>
+            <a:r>
+              <a:t>Live: https://friday-voice-agent-147606977567.us-central1.run.app   ·   Cloud Run, HTTPS, OAuth callback on the service URL.</a:t>
             </a:r>
           </a:p>
         </p:txBody>
@@ -4858,14 +6705,6 @@
 <file path=ppt/slides/slide9.xml><?xml version="1.0" encoding="utf-8"?>
 <p:sld xmlns:a="http://schemas.openxmlformats.org/drawingml/2006/main" xmlns:p="http://schemas.openxmlformats.org/presentationml/2006/main" xmlns:r="http://schemas.openxmlformats.org/officeDocument/2006/relationships">
   <p:cSld>
-    <p:bg>
-      <p:bgPr>
-        <a:solidFill>
-          <a:srgbClr val="0A0A0A"/>
-        </a:solidFill>
-        <a:effectLst/>
-      </p:bgPr>
-    </p:bg>
     <p:spTree>
       <p:nvGrpSpPr>
         <p:cNvPr id="1" name=""/>
@@ -4875,14 +6714,57 @@
       <p:grpSpPr/>
       <p:sp>
         <p:nvSpPr>
-          <p:cNvPr id="2" name="TextBox 1"/>
+          <p:cNvPr id="2" name="Rectangle 1"/>
+          <p:cNvSpPr/>
+          <p:nvPr/>
+        </p:nvSpPr>
+        <p:spPr>
+          <a:xfrm>
+            <a:off x="0" y="0"/>
+            <a:ext cx="12191695" cy="6858000"/>
+          </a:xfrm>
+          <a:prstGeom prst="rect">
+            <a:avLst/>
+          </a:prstGeom>
+          <a:solidFill>
+            <a:srgbClr val="0B0B0C"/>
+          </a:solidFill>
+          <a:ln>
+            <a:noFill/>
+          </a:ln>
+        </p:spPr>
+        <p:style>
+          <a:lnRef idx="1">
+            <a:schemeClr val="accent1"/>
+          </a:lnRef>
+          <a:fillRef idx="3">
+            <a:schemeClr val="accent1"/>
+          </a:fillRef>
+          <a:effectRef idx="2">
+            <a:schemeClr val="accent1"/>
+          </a:effectRef>
+          <a:fontRef idx="minor">
+            <a:schemeClr val="lt1"/>
+          </a:fontRef>
+        </p:style>
+        <p:txBody>
+          <a:bodyPr rtlCol="0" anchor="ctr"/>
+          <a:lstStyle/>
+          <a:p>
+            <a:pPr algn="ctr"/>
+          </a:p>
+        </p:txBody>
+      </p:sp>
+      <p:sp>
+        <p:nvSpPr>
+          <p:cNvPr id="3" name="TextBox 2"/>
           <p:cNvSpPr txBox="1"/>
           <p:nvPr/>
         </p:nvSpPr>
         <p:spPr>
           <a:xfrm>
-            <a:off x="685800" y="502920"/>
-            <a:ext cx="10515600" cy="1280160"/>
+            <a:off x="502920" y="292608"/>
+            <a:ext cx="7315200" cy="292608"/>
           </a:xfrm>
           <a:prstGeom prst="rect">
             <a:avLst/>
@@ -4890,103 +6772,257 @@
           <a:noFill/>
         </p:spPr>
         <p:txBody>
-          <a:bodyPr wrap="square">
-            <a:spAutoFit/>
-          </a:bodyPr>
+          <a:bodyPr wrap="square"/>
+          <a:lstStyle/>
+          <a:p>
+            <a:pPr algn="l">
+              <a:defRPr sz="1200" b="1">
+                <a:solidFill>
+                  <a:srgbClr val="F97316"/>
+                </a:solidFill>
+                <a:latin typeface="Calibri"/>
+              </a:defRPr>
+            </a:pPr>
+            <a:r>
+              <a:t>SAFETY</a:t>
+            </a:r>
+          </a:p>
+        </p:txBody>
+      </p:sp>
+      <p:sp>
+        <p:nvSpPr>
+          <p:cNvPr id="4" name="TextBox 3"/>
+          <p:cNvSpPr txBox="1"/>
+          <p:nvPr/>
+        </p:nvSpPr>
+        <p:spPr>
+          <a:xfrm>
+            <a:off x="502920" y="566928"/>
+            <a:ext cx="11155680" cy="640080"/>
+          </a:xfrm>
+          <a:prstGeom prst="rect">
+            <a:avLst/>
+          </a:prstGeom>
+          <a:noFill/>
+        </p:spPr>
+        <p:txBody>
+          <a:bodyPr wrap="square"/>
           <a:lstStyle/>
           <a:p>
             <a:pPr algn="l">
               <a:defRPr sz="3200" b="1">
                 <a:solidFill>
-                  <a:srgbClr val="F97316"/>
-                </a:solidFill>
-              </a:defRPr>
-            </a:pPr>
-            <a:r>
-              <a:t>Judgment, not vibes</a:t>
-            </a:r>
-          </a:p>
-        </p:txBody>
-      </p:sp>
-      <p:sp>
-        <p:nvSpPr>
-          <p:cNvPr id="3" name="TextBox 2"/>
-          <p:cNvSpPr txBox="1"/>
-          <p:nvPr/>
-        </p:nvSpPr>
-        <p:spPr>
-          <a:xfrm>
-            <a:off x="777240" y="1325880"/>
-            <a:ext cx="10241280" cy="4754880"/>
-          </a:xfrm>
-          <a:prstGeom prst="rect">
-            <a:avLst/>
-          </a:prstGeom>
-          <a:noFill/>
-        </p:spPr>
-        <p:txBody>
-          <a:bodyPr wrap="square">
-            <a:spAutoFit/>
-          </a:bodyPr>
-          <a:lstStyle/>
+                  <a:srgbClr val="FAFAFA"/>
+                </a:solidFill>
+                <a:latin typeface="Calibri"/>
+              </a:defRPr>
+            </a:pPr>
+            <a:r>
+              <a:t>Draft is not a write.</a:t>
+            </a:r>
+          </a:p>
+        </p:txBody>
+      </p:sp>
+      <p:sp>
+        <p:nvSpPr>
+          <p:cNvPr id="5" name="Rounded Rectangle 4"/>
+          <p:cNvSpPr/>
+          <p:nvPr/>
+        </p:nvSpPr>
+        <p:spPr>
+          <a:xfrm>
+            <a:off x="502920" y="1645920"/>
+            <a:ext cx="3566160" cy="4023360"/>
+          </a:xfrm>
+          <a:prstGeom prst="roundRect">
+            <a:avLst/>
+          </a:prstGeom>
+          <a:solidFill>
+            <a:srgbClr val="18181B"/>
+          </a:solidFill>
+          <a:ln>
+            <a:solidFill>
+              <a:srgbClr val="3F3F46"/>
+            </a:solidFill>
+          </a:ln>
+        </p:spPr>
+        <p:style>
+          <a:lnRef idx="1">
+            <a:schemeClr val="accent1"/>
+          </a:lnRef>
+          <a:fillRef idx="3">
+            <a:schemeClr val="accent1"/>
+          </a:fillRef>
+          <a:effectRef idx="2">
+            <a:schemeClr val="accent1"/>
+          </a:effectRef>
+          <a:fontRef idx="minor">
+            <a:schemeClr val="lt1"/>
+          </a:fontRef>
+        </p:style>
+        <p:txBody>
+          <a:bodyPr rtlCol="0" anchor="ctr" wrap="square" lIns="164592" rIns="146304" tIns="128016"/>
+          <a:lstStyle/>
+          <a:p>
+            <a:pPr algn="ctr">
+              <a:defRPr sz="1600" b="1">
+                <a:solidFill>
+                  <a:srgbClr val="FAFAFA"/>
+                </a:solidFill>
+                <a:latin typeface="Calibri"/>
+              </a:defRPr>
+            </a:pPr>
+            <a:r>
+              <a:t>Stage</a:t>
+            </a:r>
+          </a:p>
           <a:p>
             <a:pPr>
-              <a:spcAft>
-                <a:spcPts val="1400"/>
-              </a:spcAft>
-              <a:defRPr sz="2000">
+              <a:defRPr sz="1300">
+                <a:solidFill>
+                  <a:srgbClr val="A1A1AA"/>
+                </a:solidFill>
+                <a:latin typeface="Calibri"/>
+              </a:defRPr>
+            </a:pPr>
+            <a:r>
+              <a:t>create_issue and add_comment only prepare a draft. Same sentence cannot also say yes.</a:t>
+            </a:r>
+          </a:p>
+        </p:txBody>
+      </p:sp>
+      <p:sp>
+        <p:nvSpPr>
+          <p:cNvPr id="6" name="Rounded Rectangle 5"/>
+          <p:cNvSpPr/>
+          <p:nvPr/>
+        </p:nvSpPr>
+        <p:spPr>
+          <a:xfrm>
+            <a:off x="4297680" y="1645920"/>
+            <a:ext cx="3566160" cy="4023360"/>
+          </a:xfrm>
+          <a:prstGeom prst="roundRect">
+            <a:avLst/>
+          </a:prstGeom>
+          <a:solidFill>
+            <a:srgbClr val="18181B"/>
+          </a:solidFill>
+          <a:ln>
+            <a:solidFill>
+              <a:srgbClr val="3F3F46"/>
+            </a:solidFill>
+          </a:ln>
+        </p:spPr>
+        <p:style>
+          <a:lnRef idx="1">
+            <a:schemeClr val="accent1"/>
+          </a:lnRef>
+          <a:fillRef idx="3">
+            <a:schemeClr val="accent1"/>
+          </a:fillRef>
+          <a:effectRef idx="2">
+            <a:schemeClr val="accent1"/>
+          </a:effectRef>
+          <a:fontRef idx="minor">
+            <a:schemeClr val="lt1"/>
+          </a:fontRef>
+        </p:style>
+        <p:txBody>
+          <a:bodyPr rtlCol="0" anchor="ctr" wrap="square" lIns="164592" rIns="146304" tIns="128016"/>
+          <a:lstStyle/>
+          <a:p>
+            <a:pPr algn="ctr">
+              <a:defRPr sz="1600" b="1">
                 <a:solidFill>
                   <a:srgbClr val="FAFAFA"/>
                 </a:solidFill>
-              </a:defRPr>
-            </a:pPr>
-            <a:r>
-              <a:t>Jev: confident tool routing for map questions</a:t>
+                <a:latin typeface="Calibri"/>
+              </a:defRPr>
+            </a:pPr>
+            <a:r>
+              <a:t>Confirm</a:t>
             </a:r>
           </a:p>
           <a:p>
             <a:pPr>
-              <a:spcAft>
-                <a:spcPts val="1400"/>
-              </a:spcAft>
-              <a:defRPr sz="2000">
+              <a:defRPr sz="1300">
+                <a:solidFill>
+                  <a:srgbClr val="A1A1AA"/>
+                </a:solidFill>
+                <a:latin typeface="Calibri"/>
+              </a:defRPr>
+            </a:pPr>
+            <a:r>
+              <a:t>A later turn of yes calls confirm_write. No cancels. Tokens never ship to the browser.</a:t>
+            </a:r>
+          </a:p>
+        </p:txBody>
+      </p:sp>
+      <p:sp>
+        <p:nvSpPr>
+          <p:cNvPr id="7" name="Rounded Rectangle 6"/>
+          <p:cNvSpPr/>
+          <p:nvPr/>
+        </p:nvSpPr>
+        <p:spPr>
+          <a:xfrm>
+            <a:off x="8092440" y="1645920"/>
+            <a:ext cx="3566160" cy="4023360"/>
+          </a:xfrm>
+          <a:prstGeom prst="roundRect">
+            <a:avLst/>
+          </a:prstGeom>
+          <a:solidFill>
+            <a:srgbClr val="18181B"/>
+          </a:solidFill>
+          <a:ln>
+            <a:solidFill>
+              <a:srgbClr val="3F3F46"/>
+            </a:solidFill>
+          </a:ln>
+        </p:spPr>
+        <p:style>
+          <a:lnRef idx="1">
+            <a:schemeClr val="accent1"/>
+          </a:lnRef>
+          <a:fillRef idx="3">
+            <a:schemeClr val="accent1"/>
+          </a:fillRef>
+          <a:effectRef idx="2">
+            <a:schemeClr val="accent1"/>
+          </a:effectRef>
+          <a:fontRef idx="minor">
+            <a:schemeClr val="lt1"/>
+          </a:fontRef>
+        </p:style>
+        <p:txBody>
+          <a:bodyPr rtlCol="0" anchor="ctr" wrap="square" lIns="164592" rIns="146304" tIns="128016"/>
+          <a:lstStyle/>
+          <a:p>
+            <a:pPr algn="ctr">
+              <a:defRPr sz="1600" b="1">
                 <a:solidFill>
                   <a:srgbClr val="FAFAFA"/>
                 </a:solidFill>
-              </a:defRPr>
-            </a:pPr>
-            <a:r>
-              <a:t>Review gate: structured safe-to-merge narrative</a:t>
+                <a:latin typeface="Calibri"/>
+              </a:defRPr>
+            </a:pPr>
+            <a:r>
+              <a:t>Refuse</a:t>
             </a:r>
           </a:p>
           <a:p>
             <a:pPr>
-              <a:spcAft>
-                <a:spcPts val="1400"/>
-              </a:spcAft>
-              <a:defRPr sz="2000">
-                <a:solidFill>
-                  <a:srgbClr val="FAFAFA"/>
-                </a:solidFill>
-              </a:defRPr>
-            </a:pPr>
-            <a:r>
-              <a:t>Escalate when confidence is low (Vertex / K2)</a:t>
-            </a:r>
-          </a:p>
-          <a:p>
-            <a:pPr>
-              <a:spcAft>
-                <a:spcPts val="1400"/>
-              </a:spcAft>
-              <a:defRPr sz="2000">
-                <a:solidFill>
-                  <a:srgbClr val="FAFAFA"/>
-                </a:solidFill>
-              </a:defRPr>
-            </a:pPr>
-            <a:r>
-              <a:t>Honest give-up when the repo cannot answer</a:t>
+              <a:defRPr sz="1300">
+                <a:solidFill>
+                  <a:srgbClr val="A1A1AA"/>
+                </a:solidFill>
+                <a:latin typeface="Calibri"/>
+              </a:defRPr>
+            </a:pPr>
+            <a:r>
+              <a:t>Friday will not close or delete issues or pull requests. Give up honestly when the repo has no answer.</a:t>
             </a:r>
           </a:p>
         </p:txBody>

</xml_diff>